<commit_message>
Amplia contexto y ejemplos de cada modulo en la presentacion
</commit_message>
<xml_diff>
--- a/instructor/clases/00-presentacion-alumnos.pptx
+++ b/instructor/clases/00-presentacion-alumnos.pptx
@@ -2,26 +2,26 @@
 <file path=ppt/presentation.xml><?xml version="1.0" encoding="utf-8"?>
 <p:presentation xmlns:p="http://schemas.openxmlformats.org/presentationml/2006/main">
   <p:sldMasterIdLst>
-    <p:sldMasterId xmlns:r="http://schemas.openxmlformats.org/officeDocument/2006/relationships" id="2147483648" r:id="R1adf94d6bfd9481c"/>
+    <p:sldMasterId xmlns:r="http://schemas.openxmlformats.org/officeDocument/2006/relationships" id="2147483648" r:id="R82631cc8b9334827"/>
   </p:sldMasterIdLst>
   <p:notesMasterIdLst>
-    <p:notesMasterId xmlns:r="http://schemas.openxmlformats.org/officeDocument/2006/relationships" r:id="R199269297e664454"/>
+    <p:notesMasterId xmlns:r="http://schemas.openxmlformats.org/officeDocument/2006/relationships" r:id="Rce19066b91874d47"/>
   </p:notesMasterIdLst>
   <p:sldIdLst>
-    <p:sldId xmlns:r="http://schemas.openxmlformats.org/officeDocument/2006/relationships" id="256" r:id="Rcf60bac52fde41b1"/>
-    <p:sldId xmlns:r="http://schemas.openxmlformats.org/officeDocument/2006/relationships" id="257" r:id="R8eea30bfd4e448fc"/>
-    <p:sldId xmlns:r="http://schemas.openxmlformats.org/officeDocument/2006/relationships" id="258" r:id="Rebf4d94c7de54c0c"/>
-    <p:sldId xmlns:r="http://schemas.openxmlformats.org/officeDocument/2006/relationships" id="259" r:id="Rc426a2ae2587444f"/>
-    <p:sldId xmlns:r="http://schemas.openxmlformats.org/officeDocument/2006/relationships" id="260" r:id="R8b9a9b1fb77b46ea"/>
-    <p:sldId xmlns:r="http://schemas.openxmlformats.org/officeDocument/2006/relationships" id="261" r:id="R86913d3a9810484d"/>
-    <p:sldId xmlns:r="http://schemas.openxmlformats.org/officeDocument/2006/relationships" id="262" r:id="R70884c72bdc641c9"/>
-    <p:sldId xmlns:r="http://schemas.openxmlformats.org/officeDocument/2006/relationships" id="263" r:id="Rc96ba0e274444977"/>
-    <p:sldId xmlns:r="http://schemas.openxmlformats.org/officeDocument/2006/relationships" id="264" r:id="R8725c3dd7bdf4efb"/>
-    <p:sldId xmlns:r="http://schemas.openxmlformats.org/officeDocument/2006/relationships" id="265" r:id="R388ce8bbf2a94fdd"/>
-    <p:sldId xmlns:r="http://schemas.openxmlformats.org/officeDocument/2006/relationships" id="266" r:id="R4dbebe64679d4bcb"/>
-    <p:sldId xmlns:r="http://schemas.openxmlformats.org/officeDocument/2006/relationships" id="267" r:id="R6f85f7ce97ac4d55"/>
-    <p:sldId xmlns:r="http://schemas.openxmlformats.org/officeDocument/2006/relationships" id="268" r:id="Ra73cac06f8ff4b84"/>
-    <p:sldId xmlns:r="http://schemas.openxmlformats.org/officeDocument/2006/relationships" id="269" r:id="Rd0004bf1ad734a53"/>
+    <p:sldId xmlns:r="http://schemas.openxmlformats.org/officeDocument/2006/relationships" id="256" r:id="R0a404aa8c5d748f8"/>
+    <p:sldId xmlns:r="http://schemas.openxmlformats.org/officeDocument/2006/relationships" id="257" r:id="Rd13976f65ac443f0"/>
+    <p:sldId xmlns:r="http://schemas.openxmlformats.org/officeDocument/2006/relationships" id="258" r:id="R465840514ca945c9"/>
+    <p:sldId xmlns:r="http://schemas.openxmlformats.org/officeDocument/2006/relationships" id="259" r:id="R0dd90b38dd0a4934"/>
+    <p:sldId xmlns:r="http://schemas.openxmlformats.org/officeDocument/2006/relationships" id="260" r:id="R222d8554ea0d467b"/>
+    <p:sldId xmlns:r="http://schemas.openxmlformats.org/officeDocument/2006/relationships" id="261" r:id="R26e405b247624f63"/>
+    <p:sldId xmlns:r="http://schemas.openxmlformats.org/officeDocument/2006/relationships" id="262" r:id="Rb8e083284b32456e"/>
+    <p:sldId xmlns:r="http://schemas.openxmlformats.org/officeDocument/2006/relationships" id="263" r:id="R77ed92c254ba4835"/>
+    <p:sldId xmlns:r="http://schemas.openxmlformats.org/officeDocument/2006/relationships" id="264" r:id="Rc2785ff173af4df7"/>
+    <p:sldId xmlns:r="http://schemas.openxmlformats.org/officeDocument/2006/relationships" id="265" r:id="R83df7a47ccca4bb9"/>
+    <p:sldId xmlns:r="http://schemas.openxmlformats.org/officeDocument/2006/relationships" id="266" r:id="Re8ac42630666419f"/>
+    <p:sldId xmlns:r="http://schemas.openxmlformats.org/officeDocument/2006/relationships" id="267" r:id="R40bc58730d8045f4"/>
+    <p:sldId xmlns:r="http://schemas.openxmlformats.org/officeDocument/2006/relationships" id="268" r:id="R35f26a1be6a54d9e"/>
+    <p:sldId xmlns:r="http://schemas.openxmlformats.org/officeDocument/2006/relationships" id="269" r:id="R9bc98dfefbcd483c"/>
   </p:sldIdLst>
   <p:sldSz cx="12192000" cy="6858000"/>
   <p:notesSz cx="6858000" cy="9144000"/>
@@ -558,6 +558,13 @@
               <a:t>Material del curso: https://github.com/ychavez/CursoNETIA/blob/main/instructor/clases/07-calidad.md</a:t>
             </a:r>
           </a:p>
+          <a:p xmlns:a="http://schemas.openxmlformats.org/drawingml/2006/main">
+            <a:br/>
+            <a:br/>
+            <a:r>
+              <a:t>Ejemplo para explicar: una prueba de dominio comprueba que un pedido vacío se rechaza. Otra prueba atraviesa la API y verifica la respuesta HTTP. Antes de aceptar una refactorización de Copilot, ejecutamos las pruebas y revisamos qué comportamientos cubren.</a:t>
+            </a:r>
+          </a:p>
         </p:txBody>
       </p:sp>
       <p:sp>
@@ -638,6 +645,13 @@
               <a:t>Material del curso: https://github.com/ychavez/CursoNETIA/blob/main/instructor/clases/08-resiliencia.md</a:t>
             </a:r>
           </a:p>
+          <a:p xmlns:a="http://schemas.openxmlformats.org/drawingml/2006/main">
+            <a:br/>
+            <a:br/>
+            <a:r>
+              <a:t>Ejemplo para explicar: el pedido y su aviso pendiente se guardan juntos. Si el receptor no responde, el worker puede volver a enviar el aviso. Como puede haber reenvíos, el receptor reconoce el identificador del evento para evitar procesarlo dos veces.</a:t>
+            </a:r>
+          </a:p>
         </p:txBody>
       </p:sp>
       <p:sp>
@@ -718,6 +732,13 @@
               <a:t>Material del curso: https://github.com/ychavez/CursoNETIA/blob/main/instructor/clases/09-operacion.md</a:t>
             </a:r>
           </a:p>
+          <a:p xmlns:a="http://schemas.openxmlformats.org/drawingml/2006/main">
+            <a:br/>
+            <a:br/>
+            <a:r>
+              <a:t>Ejemplo para explicar: levantamos la API, la base y el receptor con Docker Compose en la computadora del alumno. Seguimos una petición con trazas y registros para localizar una demora. El laboratorio es local y no necesita Azure ni AWS.</a:t>
+            </a:r>
+          </a:p>
         </p:txBody>
       </p:sp>
       <p:sp>
@@ -798,6 +819,13 @@
               <a:t>Material del curso: https://github.com/ychavez/CursoNETIA/blob/main/instructor/clases/10-entrega.md</a:t>
             </a:r>
           </a:p>
+          <a:p xmlns:a="http://schemas.openxmlformats.org/drawingml/2006/main">
+            <a:br/>
+            <a:br/>
+            <a:r>
+              <a:t>Ejemplo para explicar: el desafío final recorre el contrato de la API, el caso de uso, la persistencia y las pruebas. El participante demuestra el cambio, explica una decisión y distingue lo que ya verificó de lo que aún debe preparar para producción.</a:t>
+            </a:r>
+          </a:p>
         </p:txBody>
       </p:sp>
       <p:sp>
@@ -1128,6 +1156,13 @@
               <a:t>Material del curso: https://github.com/ychavez/CursoNETIA/blob/main/instructor/clases/01-ia-harness.md</a:t>
             </a:r>
           </a:p>
+          <a:p xmlns:a="http://schemas.openxmlformats.org/drawingml/2006/main">
+            <a:br/>
+            <a:br/>
+            <a:r>
+              <a:t>Ejemplo para explicar: si pedimos crear un endpoint sin indicar las capas, Copilot puede mezclar reglas del negocio con HTTP. Las instrucciones del repositorio orientan dónde colocar cada parte y las pruebas ayudan a comprobar el resultado.</a:t>
+            </a:r>
+          </a:p>
         </p:txBody>
       </p:sp>
       <p:sp>
@@ -1208,6 +1243,13 @@
               <a:t>Material del curso: https://github.com/ychavez/CursoNETIA/blob/main/instructor/clases/02-arquitectura.md</a:t>
             </a:r>
           </a:p>
+          <a:p xmlns:a="http://schemas.openxmlformats.org/drawingml/2006/main">
+            <a:br/>
+            <a:br/>
+            <a:r>
+              <a:t>Ejemplo para explicar: la regla que impide crear un pedido vacío pertenece al dominio. Conservamos esa regla al usar SQLite o SQL Server. La infraestructura implementa el acceso a cada motor.</a:t>
+            </a:r>
+          </a:p>
         </p:txBody>
       </p:sp>
       <p:sp>
@@ -1288,6 +1330,13 @@
               <a:t>Material del curso: https://github.com/ychavez/CursoNETIA/blob/main/instructor/clases/03-patrones.md</a:t>
             </a:r>
           </a:p>
+          <a:p xmlns:a="http://schemas.openxmlformats.org/drawingml/2006/main">
+            <a:br/>
+            <a:br/>
+            <a:r>
+              <a:t>Ejemplo para explicar: el caso de uso solicita un producto mediante un contrato. La implementación de EF Core lo busca en la base. IRepository&lt;T&gt; reúne operaciones comunes e IUnitOfWork confirma los cambios. Las consultas específicas permanecen en contratos especializados.</a:t>
+            </a:r>
+          </a:p>
         </p:txBody>
       </p:sp>
       <p:sp>
@@ -1368,6 +1417,13 @@
               <a:t>Material del curso: https://github.com/ychavez/CursoNETIA/blob/main/instructor/clases/04-api.md</a:t>
             </a:r>
           </a:p>
+          <a:p xmlns:a="http://schemas.openxmlformats.org/drawingml/2006/main">
+            <a:br/>
+            <a:br/>
+            <a:r>
+              <a:t>Ejemplo para explicar: al crear un pedido, el cliente envía productos y cantidades. El contrato define los datos requeridos y la respuesta esperada. Si una entrada es inválida, la API devuelve un error comprensible y consistente.</a:t>
+            </a:r>
+          </a:p>
         </p:txBody>
       </p:sp>
       <p:sp>
@@ -1448,6 +1504,13 @@
               <a:t>Material del curso: https://github.com/ychavez/CursoNETIA/blob/main/instructor/clases/05-datos.md</a:t>
             </a:r>
           </a:p>
+          <a:p xmlns:a="http://schemas.openxmlformats.org/drawingml/2006/main">
+            <a:br/>
+            <a:br/>
+            <a:r>
+              <a:t>Ejemplo para explicar: una relación asocia un pedido con sus líneas. Al cambiar el modelo, una migración registra cómo evoluciona la estructura. Revisamos las consultas y los cambios simultáneos para proteger la consistencia de los datos.</a:t>
+            </a:r>
+          </a:p>
         </p:txBody>
       </p:sp>
       <p:sp>
@@ -1528,6 +1591,13 @@
               <a:t>Material del curso: https://github.com/ychavez/CursoNETIA/blob/main/instructor/clases/06-seguridad.md</a:t>
             </a:r>
           </a:p>
+          <a:p xmlns:a="http://schemas.openxmlformats.org/drawingml/2006/main">
+            <a:br/>
+            <a:br/>
+            <a:r>
+              <a:t>Ejemplo para explicar: dos usuarios pueden tener un JWT válido, pero no deben poder consultar los pedidos del otro. Probaremos el acceso por propietario y los permisos exigidos por cada operación, incluidos los rechazos esperados.</a:t>
+            </a:r>
+          </a:p>
         </p:txBody>
       </p:sp>
       <p:sp>
@@ -1644,6 +1714,7 @@
                 <a:spcPts val="0"/>
               </a:spcAft>
               <a:buNone/>
+              <a:defRPr/>
             </a:lvl1pPr>
             <a:lvl2pPr marL="0" indent="0">
               <a:lnSpc>
@@ -1656,6 +1727,7 @@
                 <a:spcPts val="0"/>
               </a:spcAft>
               <a:buNone/>
+              <a:defRPr/>
             </a:lvl2pPr>
             <a:lvl3pPr marL="0" indent="0">
               <a:lnSpc>
@@ -1668,6 +1740,7 @@
                 <a:spcPts val="0"/>
               </a:spcAft>
               <a:buNone/>
+              <a:defRPr/>
             </a:lvl3pPr>
             <a:lvl4pPr marL="0" indent="0">
               <a:lnSpc>
@@ -1680,6 +1753,7 @@
                 <a:spcPts val="0"/>
               </a:spcAft>
               <a:buNone/>
+              <a:defRPr/>
             </a:lvl4pPr>
             <a:lvl5pPr marL="0" indent="0">
               <a:lnSpc>
@@ -1692,6 +1766,7 @@
                 <a:spcPts val="0"/>
               </a:spcAft>
               <a:buNone/>
+              <a:defRPr/>
             </a:lvl5pPr>
             <a:lvl6pPr marL="0" indent="0">
               <a:lnSpc>
@@ -1704,6 +1779,7 @@
                 <a:spcPts val="0"/>
               </a:spcAft>
               <a:buNone/>
+              <a:defRPr/>
             </a:lvl6pPr>
             <a:lvl7pPr marL="0" indent="0">
               <a:lnSpc>
@@ -1716,6 +1792,7 @@
                 <a:spcPts val="0"/>
               </a:spcAft>
               <a:buNone/>
+              <a:defRPr/>
             </a:lvl7pPr>
             <a:lvl8pPr marL="0" indent="0">
               <a:lnSpc>
@@ -1728,6 +1805,7 @@
                 <a:spcPts val="0"/>
               </a:spcAft>
               <a:buNone/>
+              <a:defRPr/>
             </a:lvl8pPr>
             <a:lvl9pPr marL="0" indent="0">
               <a:lnSpc>
@@ -1740,6 +1818,7 @@
                 <a:spcPts val="0"/>
               </a:spcAft>
               <a:buNone/>
+              <a:defRPr/>
             </a:lvl9pPr>
           </a:lstStyle>
           <a:p xmlns:a="http://schemas.openxmlformats.org/drawingml/2006/main"/>
@@ -1791,6 +1870,7 @@
                 <a:spcPts val="0"/>
               </a:spcAft>
               <a:buNone/>
+              <a:defRPr/>
             </a:lvl1pPr>
             <a:lvl2pPr marL="0" indent="0">
               <a:lnSpc>
@@ -1803,6 +1883,7 @@
                 <a:spcPts val="0"/>
               </a:spcAft>
               <a:buNone/>
+              <a:defRPr/>
             </a:lvl2pPr>
             <a:lvl3pPr marL="0" indent="0">
               <a:lnSpc>
@@ -1815,6 +1896,7 @@
                 <a:spcPts val="0"/>
               </a:spcAft>
               <a:buNone/>
+              <a:defRPr/>
             </a:lvl3pPr>
             <a:lvl4pPr marL="0" indent="0">
               <a:lnSpc>
@@ -1827,6 +1909,7 @@
                 <a:spcPts val="0"/>
               </a:spcAft>
               <a:buNone/>
+              <a:defRPr/>
             </a:lvl4pPr>
             <a:lvl5pPr marL="0" indent="0">
               <a:lnSpc>
@@ -1839,6 +1922,7 @@
                 <a:spcPts val="0"/>
               </a:spcAft>
               <a:buNone/>
+              <a:defRPr/>
             </a:lvl5pPr>
             <a:lvl6pPr marL="0" indent="0">
               <a:lnSpc>
@@ -1851,6 +1935,7 @@
                 <a:spcPts val="0"/>
               </a:spcAft>
               <a:buNone/>
+              <a:defRPr/>
             </a:lvl6pPr>
             <a:lvl7pPr marL="0" indent="0">
               <a:lnSpc>
@@ -1863,6 +1948,7 @@
                 <a:spcPts val="0"/>
               </a:spcAft>
               <a:buNone/>
+              <a:defRPr/>
             </a:lvl7pPr>
             <a:lvl8pPr marL="0" indent="0">
               <a:lnSpc>
@@ -1875,6 +1961,7 @@
                 <a:spcPts val="0"/>
               </a:spcAft>
               <a:buNone/>
+              <a:defRPr/>
             </a:lvl8pPr>
             <a:lvl9pPr marL="0" indent="0">
               <a:lnSpc>
@@ -1887,6 +1974,7 @@
                 <a:spcPts val="0"/>
               </a:spcAft>
               <a:buNone/>
+              <a:defRPr/>
             </a:lvl9pPr>
           </a:lstStyle>
           <a:p xmlns:a="http://schemas.openxmlformats.org/drawingml/2006/main"/>
@@ -1986,6 +2074,7 @@
                 <a:spcPts val="0"/>
               </a:spcAft>
               <a:buNone/>
+              <a:defRPr/>
             </a:lvl1pPr>
             <a:lvl2pPr marL="0" indent="0">
               <a:lnSpc>
@@ -1998,6 +2087,7 @@
                 <a:spcPts val="0"/>
               </a:spcAft>
               <a:buNone/>
+              <a:defRPr/>
             </a:lvl2pPr>
             <a:lvl3pPr marL="0" indent="0">
               <a:lnSpc>
@@ -2010,6 +2100,7 @@
                 <a:spcPts val="0"/>
               </a:spcAft>
               <a:buNone/>
+              <a:defRPr/>
             </a:lvl3pPr>
             <a:lvl4pPr marL="0" indent="0">
               <a:lnSpc>
@@ -2022,6 +2113,7 @@
                 <a:spcPts val="0"/>
               </a:spcAft>
               <a:buNone/>
+              <a:defRPr/>
             </a:lvl4pPr>
             <a:lvl5pPr marL="0" indent="0">
               <a:lnSpc>
@@ -2034,6 +2126,7 @@
                 <a:spcPts val="0"/>
               </a:spcAft>
               <a:buNone/>
+              <a:defRPr/>
             </a:lvl5pPr>
             <a:lvl6pPr marL="0" indent="0">
               <a:lnSpc>
@@ -2046,6 +2139,7 @@
                 <a:spcPts val="0"/>
               </a:spcAft>
               <a:buNone/>
+              <a:defRPr/>
             </a:lvl6pPr>
             <a:lvl7pPr marL="0" indent="0">
               <a:lnSpc>
@@ -2058,6 +2152,7 @@
                 <a:spcPts val="0"/>
               </a:spcAft>
               <a:buNone/>
+              <a:defRPr/>
             </a:lvl7pPr>
             <a:lvl8pPr marL="0" indent="0">
               <a:lnSpc>
@@ -2070,6 +2165,7 @@
                 <a:spcPts val="0"/>
               </a:spcAft>
               <a:buNone/>
+              <a:defRPr/>
             </a:lvl8pPr>
             <a:lvl9pPr marL="0" indent="0">
               <a:lnSpc>
@@ -2082,6 +2178,7 @@
                 <a:spcPts val="0"/>
               </a:spcAft>
               <a:buNone/>
+              <a:defRPr/>
             </a:lvl9pPr>
           </a:lstStyle>
           <a:p xmlns:a="http://schemas.openxmlformats.org/drawingml/2006/main"/>
@@ -2181,6 +2278,7 @@
                 <a:spcPts val="0"/>
               </a:spcAft>
               <a:buNone/>
+              <a:defRPr/>
             </a:lvl1pPr>
             <a:lvl2pPr marL="0" indent="0">
               <a:lnSpc>
@@ -2193,6 +2291,7 @@
                 <a:spcPts val="0"/>
               </a:spcAft>
               <a:buNone/>
+              <a:defRPr/>
             </a:lvl2pPr>
             <a:lvl3pPr marL="0" indent="0">
               <a:lnSpc>
@@ -2205,6 +2304,7 @@
                 <a:spcPts val="0"/>
               </a:spcAft>
               <a:buNone/>
+              <a:defRPr/>
             </a:lvl3pPr>
             <a:lvl4pPr marL="0" indent="0">
               <a:lnSpc>
@@ -2217,6 +2317,7 @@
                 <a:spcPts val="0"/>
               </a:spcAft>
               <a:buNone/>
+              <a:defRPr/>
             </a:lvl4pPr>
             <a:lvl5pPr marL="0" indent="0">
               <a:lnSpc>
@@ -2229,6 +2330,7 @@
                 <a:spcPts val="0"/>
               </a:spcAft>
               <a:buNone/>
+              <a:defRPr/>
             </a:lvl5pPr>
             <a:lvl6pPr marL="0" indent="0">
               <a:lnSpc>
@@ -2241,6 +2343,7 @@
                 <a:spcPts val="0"/>
               </a:spcAft>
               <a:buNone/>
+              <a:defRPr/>
             </a:lvl6pPr>
             <a:lvl7pPr marL="0" indent="0">
               <a:lnSpc>
@@ -2253,6 +2356,7 @@
                 <a:spcPts val="0"/>
               </a:spcAft>
               <a:buNone/>
+              <a:defRPr/>
             </a:lvl7pPr>
             <a:lvl8pPr marL="0" indent="0">
               <a:lnSpc>
@@ -2265,6 +2369,7 @@
                 <a:spcPts val="0"/>
               </a:spcAft>
               <a:buNone/>
+              <a:defRPr/>
             </a:lvl8pPr>
             <a:lvl9pPr marL="0" indent="0">
               <a:lnSpc>
@@ -2277,6 +2382,7 @@
                 <a:spcPts val="0"/>
               </a:spcAft>
               <a:buNone/>
+              <a:defRPr/>
             </a:lvl9pPr>
           </a:lstStyle>
           <a:p xmlns:a="http://schemas.openxmlformats.org/drawingml/2006/main"/>
@@ -2328,6 +2434,7 @@
                 <a:spcPts val="1200"/>
               </a:spcAft>
               <a:buChar char="•"/>
+              <a:defRPr/>
             </a:lvl1pPr>
             <a:lvl2pPr marL="533400" indent="-228600">
               <a:lnSpc>
@@ -2340,6 +2447,7 @@
                 <a:spcPts val="1200"/>
               </a:spcAft>
               <a:buChar char="•"/>
+              <a:defRPr/>
             </a:lvl2pPr>
             <a:lvl3pPr marL="838200" indent="-228600">
               <a:lnSpc>
@@ -2352,6 +2460,7 @@
                 <a:spcPts val="1200"/>
               </a:spcAft>
               <a:buChar char="•"/>
+              <a:defRPr/>
             </a:lvl3pPr>
             <a:lvl4pPr marL="1143000" indent="-228600">
               <a:lnSpc>
@@ -2364,6 +2473,7 @@
                 <a:spcPts val="1200"/>
               </a:spcAft>
               <a:buChar char="•"/>
+              <a:defRPr/>
             </a:lvl4pPr>
             <a:lvl5pPr marL="1447800" indent="-228600">
               <a:lnSpc>
@@ -2376,6 +2486,7 @@
                 <a:spcPts val="1200"/>
               </a:spcAft>
               <a:buChar char="•"/>
+              <a:defRPr/>
             </a:lvl5pPr>
             <a:lvl6pPr marL="1752600" indent="-228600">
               <a:lnSpc>
@@ -2388,6 +2499,7 @@
                 <a:spcPts val="1200"/>
               </a:spcAft>
               <a:buChar char="•"/>
+              <a:defRPr/>
             </a:lvl6pPr>
             <a:lvl7pPr marL="2057400" indent="-228600">
               <a:lnSpc>
@@ -2400,6 +2512,7 @@
                 <a:spcPts val="1200"/>
               </a:spcAft>
               <a:buChar char="•"/>
+              <a:defRPr/>
             </a:lvl7pPr>
             <a:lvl8pPr marL="2362200" indent="-228600">
               <a:lnSpc>
@@ -2412,6 +2525,7 @@
                 <a:spcPts val="1200"/>
               </a:spcAft>
               <a:buChar char="•"/>
+              <a:defRPr/>
             </a:lvl8pPr>
             <a:lvl9pPr marL="2667000" indent="-228600">
               <a:lnSpc>
@@ -2424,6 +2538,7 @@
                 <a:spcPts val="1200"/>
               </a:spcAft>
               <a:buChar char="•"/>
+              <a:defRPr/>
             </a:lvl9pPr>
           </a:lstStyle>
           <a:p xmlns:a="http://schemas.openxmlformats.org/drawingml/2006/main"/>
@@ -2523,6 +2638,7 @@
                 <a:spcPts val="0"/>
               </a:spcAft>
               <a:buNone/>
+              <a:defRPr/>
             </a:lvl1pPr>
             <a:lvl2pPr marL="0" indent="0">
               <a:lnSpc>
@@ -2535,6 +2651,7 @@
                 <a:spcPts val="0"/>
               </a:spcAft>
               <a:buNone/>
+              <a:defRPr/>
             </a:lvl2pPr>
             <a:lvl3pPr marL="0" indent="0">
               <a:lnSpc>
@@ -2547,6 +2664,7 @@
                 <a:spcPts val="0"/>
               </a:spcAft>
               <a:buNone/>
+              <a:defRPr/>
             </a:lvl3pPr>
             <a:lvl4pPr marL="0" indent="0">
               <a:lnSpc>
@@ -2559,6 +2677,7 @@
                 <a:spcPts val="0"/>
               </a:spcAft>
               <a:buNone/>
+              <a:defRPr/>
             </a:lvl4pPr>
             <a:lvl5pPr marL="0" indent="0">
               <a:lnSpc>
@@ -2571,6 +2690,7 @@
                 <a:spcPts val="0"/>
               </a:spcAft>
               <a:buNone/>
+              <a:defRPr/>
             </a:lvl5pPr>
             <a:lvl6pPr marL="0" indent="0">
               <a:lnSpc>
@@ -2583,6 +2703,7 @@
                 <a:spcPts val="0"/>
               </a:spcAft>
               <a:buNone/>
+              <a:defRPr/>
             </a:lvl6pPr>
             <a:lvl7pPr marL="0" indent="0">
               <a:lnSpc>
@@ -2595,6 +2716,7 @@
                 <a:spcPts val="0"/>
               </a:spcAft>
               <a:buNone/>
+              <a:defRPr/>
             </a:lvl7pPr>
             <a:lvl8pPr marL="0" indent="0">
               <a:lnSpc>
@@ -2607,6 +2729,7 @@
                 <a:spcPts val="0"/>
               </a:spcAft>
               <a:buNone/>
+              <a:defRPr/>
             </a:lvl8pPr>
             <a:lvl9pPr marL="0" indent="0">
               <a:lnSpc>
@@ -2619,6 +2742,7 @@
                 <a:spcPts val="0"/>
               </a:spcAft>
               <a:buNone/>
+              <a:defRPr/>
             </a:lvl9pPr>
           </a:lstStyle>
           <a:p xmlns:a="http://schemas.openxmlformats.org/drawingml/2006/main"/>
@@ -2670,6 +2794,7 @@
                 <a:spcPts val="1200"/>
               </a:spcAft>
               <a:buChar char="•"/>
+              <a:defRPr/>
             </a:lvl1pPr>
             <a:lvl2pPr marL="533400" indent="-228600">
               <a:lnSpc>
@@ -2682,6 +2807,7 @@
                 <a:spcPts val="1200"/>
               </a:spcAft>
               <a:buChar char="•"/>
+              <a:defRPr/>
             </a:lvl2pPr>
             <a:lvl3pPr marL="838200" indent="-228600">
               <a:lnSpc>
@@ -2694,6 +2820,7 @@
                 <a:spcPts val="1200"/>
               </a:spcAft>
               <a:buChar char="•"/>
+              <a:defRPr/>
             </a:lvl3pPr>
             <a:lvl4pPr marL="1143000" indent="-228600">
               <a:lnSpc>
@@ -2706,6 +2833,7 @@
                 <a:spcPts val="1200"/>
               </a:spcAft>
               <a:buChar char="•"/>
+              <a:defRPr/>
             </a:lvl4pPr>
             <a:lvl5pPr marL="1447800" indent="-228600">
               <a:lnSpc>
@@ -2718,6 +2846,7 @@
                 <a:spcPts val="1200"/>
               </a:spcAft>
               <a:buChar char="•"/>
+              <a:defRPr/>
             </a:lvl5pPr>
             <a:lvl6pPr marL="1752600" indent="-228600">
               <a:lnSpc>
@@ -2730,6 +2859,7 @@
                 <a:spcPts val="1200"/>
               </a:spcAft>
               <a:buChar char="•"/>
+              <a:defRPr/>
             </a:lvl6pPr>
             <a:lvl7pPr marL="2057400" indent="-228600">
               <a:lnSpc>
@@ -2742,6 +2872,7 @@
                 <a:spcPts val="1200"/>
               </a:spcAft>
               <a:buChar char="•"/>
+              <a:defRPr/>
             </a:lvl7pPr>
             <a:lvl8pPr marL="2362200" indent="-228600">
               <a:lnSpc>
@@ -2754,6 +2885,7 @@
                 <a:spcPts val="1200"/>
               </a:spcAft>
               <a:buChar char="•"/>
+              <a:defRPr/>
             </a:lvl8pPr>
             <a:lvl9pPr marL="2667000" indent="-228600">
               <a:lnSpc>
@@ -2766,6 +2898,7 @@
                 <a:spcPts val="1200"/>
               </a:spcAft>
               <a:buChar char="•"/>
+              <a:defRPr/>
             </a:lvl9pPr>
           </a:lstStyle>
           <a:p xmlns:a="http://schemas.openxmlformats.org/drawingml/2006/main"/>
@@ -2817,6 +2950,7 @@
                 <a:spcPts val="1200"/>
               </a:spcAft>
               <a:buChar char="•"/>
+              <a:defRPr/>
             </a:lvl1pPr>
             <a:lvl2pPr marL="533400" indent="-228600">
               <a:lnSpc>
@@ -2829,6 +2963,7 @@
                 <a:spcPts val="1200"/>
               </a:spcAft>
               <a:buChar char="•"/>
+              <a:defRPr/>
             </a:lvl2pPr>
             <a:lvl3pPr marL="838200" indent="-228600">
               <a:lnSpc>
@@ -2841,6 +2976,7 @@
                 <a:spcPts val="1200"/>
               </a:spcAft>
               <a:buChar char="•"/>
+              <a:defRPr/>
             </a:lvl3pPr>
             <a:lvl4pPr marL="1143000" indent="-228600">
               <a:lnSpc>
@@ -2853,6 +2989,7 @@
                 <a:spcPts val="1200"/>
               </a:spcAft>
               <a:buChar char="•"/>
+              <a:defRPr/>
             </a:lvl4pPr>
             <a:lvl5pPr marL="1447800" indent="-228600">
               <a:lnSpc>
@@ -2865,6 +3002,7 @@
                 <a:spcPts val="1200"/>
               </a:spcAft>
               <a:buChar char="•"/>
+              <a:defRPr/>
             </a:lvl5pPr>
             <a:lvl6pPr marL="1752600" indent="-228600">
               <a:lnSpc>
@@ -2877,6 +3015,7 @@
                 <a:spcPts val="1200"/>
               </a:spcAft>
               <a:buChar char="•"/>
+              <a:defRPr/>
             </a:lvl6pPr>
             <a:lvl7pPr marL="2057400" indent="-228600">
               <a:lnSpc>
@@ -2889,6 +3028,7 @@
                 <a:spcPts val="1200"/>
               </a:spcAft>
               <a:buChar char="•"/>
+              <a:defRPr/>
             </a:lvl7pPr>
             <a:lvl8pPr marL="2362200" indent="-228600">
               <a:lnSpc>
@@ -2901,6 +3041,7 @@
                 <a:spcPts val="1200"/>
               </a:spcAft>
               <a:buChar char="•"/>
+              <a:defRPr/>
             </a:lvl8pPr>
             <a:lvl9pPr marL="2667000" indent="-228600">
               <a:lnSpc>
@@ -2913,6 +3054,7 @@
                 <a:spcPts val="1200"/>
               </a:spcAft>
               <a:buChar char="•"/>
+              <a:defRPr/>
             </a:lvl9pPr>
           </a:lstStyle>
           <a:p xmlns:a="http://schemas.openxmlformats.org/drawingml/2006/main"/>
@@ -3012,6 +3154,7 @@
                 <a:spcPts val="0"/>
               </a:spcAft>
               <a:buNone/>
+              <a:defRPr/>
             </a:lvl1pPr>
             <a:lvl2pPr marL="0" indent="0">
               <a:lnSpc>
@@ -3024,6 +3167,7 @@
                 <a:spcPts val="0"/>
               </a:spcAft>
               <a:buNone/>
+              <a:defRPr/>
             </a:lvl2pPr>
             <a:lvl3pPr marL="0" indent="0">
               <a:lnSpc>
@@ -3036,6 +3180,7 @@
                 <a:spcPts val="0"/>
               </a:spcAft>
               <a:buNone/>
+              <a:defRPr/>
             </a:lvl3pPr>
             <a:lvl4pPr marL="0" indent="0">
               <a:lnSpc>
@@ -3048,6 +3193,7 @@
                 <a:spcPts val="0"/>
               </a:spcAft>
               <a:buNone/>
+              <a:defRPr/>
             </a:lvl4pPr>
             <a:lvl5pPr marL="0" indent="0">
               <a:lnSpc>
@@ -3060,6 +3206,7 @@
                 <a:spcPts val="0"/>
               </a:spcAft>
               <a:buNone/>
+              <a:defRPr/>
             </a:lvl5pPr>
             <a:lvl6pPr marL="0" indent="0">
               <a:lnSpc>
@@ -3072,6 +3219,7 @@
                 <a:spcPts val="0"/>
               </a:spcAft>
               <a:buNone/>
+              <a:defRPr/>
             </a:lvl6pPr>
             <a:lvl7pPr marL="0" indent="0">
               <a:lnSpc>
@@ -3084,6 +3232,7 @@
                 <a:spcPts val="0"/>
               </a:spcAft>
               <a:buNone/>
+              <a:defRPr/>
             </a:lvl7pPr>
             <a:lvl8pPr marL="0" indent="0">
               <a:lnSpc>
@@ -3096,6 +3245,7 @@
                 <a:spcPts val="0"/>
               </a:spcAft>
               <a:buNone/>
+              <a:defRPr/>
             </a:lvl8pPr>
             <a:lvl9pPr marL="0" indent="0">
               <a:lnSpc>
@@ -3108,6 +3258,7 @@
                 <a:spcPts val="0"/>
               </a:spcAft>
               <a:buNone/>
+              <a:defRPr/>
             </a:lvl9pPr>
           </a:lstStyle>
           <a:p xmlns:a="http://schemas.openxmlformats.org/drawingml/2006/main"/>
@@ -3159,6 +3310,7 @@
                 <a:spcPts val="1200"/>
               </a:spcAft>
               <a:buChar char="•"/>
+              <a:defRPr/>
             </a:lvl1pPr>
             <a:lvl2pPr marL="533400" indent="-228600">
               <a:lnSpc>
@@ -3171,6 +3323,7 @@
                 <a:spcPts val="1200"/>
               </a:spcAft>
               <a:buChar char="•"/>
+              <a:defRPr/>
             </a:lvl2pPr>
             <a:lvl3pPr marL="838200" indent="-228600">
               <a:lnSpc>
@@ -3183,6 +3336,7 @@
                 <a:spcPts val="1200"/>
               </a:spcAft>
               <a:buChar char="•"/>
+              <a:defRPr/>
             </a:lvl3pPr>
             <a:lvl4pPr marL="1143000" indent="-228600">
               <a:lnSpc>
@@ -3195,6 +3349,7 @@
                 <a:spcPts val="1200"/>
               </a:spcAft>
               <a:buChar char="•"/>
+              <a:defRPr/>
             </a:lvl4pPr>
             <a:lvl5pPr marL="1447800" indent="-228600">
               <a:lnSpc>
@@ -3207,6 +3362,7 @@
                 <a:spcPts val="1200"/>
               </a:spcAft>
               <a:buChar char="•"/>
+              <a:defRPr/>
             </a:lvl5pPr>
             <a:lvl6pPr marL="1752600" indent="-228600">
               <a:lnSpc>
@@ -3219,6 +3375,7 @@
                 <a:spcPts val="1200"/>
               </a:spcAft>
               <a:buChar char="•"/>
+              <a:defRPr/>
             </a:lvl6pPr>
             <a:lvl7pPr marL="2057400" indent="-228600">
               <a:lnSpc>
@@ -3231,6 +3388,7 @@
                 <a:spcPts val="1200"/>
               </a:spcAft>
               <a:buChar char="•"/>
+              <a:defRPr/>
             </a:lvl7pPr>
             <a:lvl8pPr marL="2362200" indent="-228600">
               <a:lnSpc>
@@ -3243,6 +3401,7 @@
                 <a:spcPts val="1200"/>
               </a:spcAft>
               <a:buChar char="•"/>
+              <a:defRPr/>
             </a:lvl8pPr>
             <a:lvl9pPr marL="2667000" indent="-228600">
               <a:lnSpc>
@@ -3255,6 +3414,7 @@
                 <a:spcPts val="1200"/>
               </a:spcAft>
               <a:buChar char="•"/>
+              <a:defRPr/>
             </a:lvl9pPr>
           </a:lstStyle>
           <a:p xmlns:a="http://schemas.openxmlformats.org/drawingml/2006/main"/>
@@ -3303,12 +3463,12 @@
   </p:cSld>
   <p:clrMap bg1="lt1" tx1="dk1" bg2="lt2" tx2="dk2" accent1="accent1" accent2="accent2" accent3="accent3" accent4="accent4" accent5="accent5" accent6="accent6" hlink="hlink" folHlink="folHlink"/>
   <p:sldLayoutIdLst>
-    <p:sldLayoutId xmlns:r="http://schemas.openxmlformats.org/officeDocument/2006/relationships" id="2147483649" r:id="Re7c3bf5f629e4390"/>
-    <p:sldLayoutId xmlns:r="http://schemas.openxmlformats.org/officeDocument/2006/relationships" id="2147483650" r:id="Ree63cf4b4fdc436d"/>
-    <p:sldLayoutId xmlns:r="http://schemas.openxmlformats.org/officeDocument/2006/relationships" id="2147483651" r:id="Rf6882c7454444a18"/>
-    <p:sldLayoutId xmlns:r="http://schemas.openxmlformats.org/officeDocument/2006/relationships" id="2147483652" r:id="R7d71579d07e542d2"/>
-    <p:sldLayoutId xmlns:r="http://schemas.openxmlformats.org/officeDocument/2006/relationships" id="2147483653" r:id="R5d6eb7e42bcf459c"/>
-    <p:sldLayoutId xmlns:r="http://schemas.openxmlformats.org/officeDocument/2006/relationships" id="2147483654" r:id="R0898b5613dc647ba"/>
+    <p:sldLayoutId xmlns:r="http://schemas.openxmlformats.org/officeDocument/2006/relationships" id="2147483649" r:id="R256f94a42a124705"/>
+    <p:sldLayoutId xmlns:r="http://schemas.openxmlformats.org/officeDocument/2006/relationships" id="2147483650" r:id="R986c21bd6457487d"/>
+    <p:sldLayoutId xmlns:r="http://schemas.openxmlformats.org/officeDocument/2006/relationships" id="2147483651" r:id="Re98ed80dff254d64"/>
+    <p:sldLayoutId xmlns:r="http://schemas.openxmlformats.org/officeDocument/2006/relationships" id="2147483652" r:id="R38b2178ca3a74e77"/>
+    <p:sldLayoutId xmlns:r="http://schemas.openxmlformats.org/officeDocument/2006/relationships" id="2147483653" r:id="R29ed1c1b489c4a86"/>
+    <p:sldLayoutId xmlns:r="http://schemas.openxmlformats.org/officeDocument/2006/relationships" id="2147483654" r:id="Rd3eb627d8b1643b0"/>
   </p:sldLayoutIdLst>
   <p:txStyles>
     <p:titleStyle>
@@ -3856,14 +4016,14 @@
       </p:grpSpPr>
       <p:pic>
         <p:nvPicPr>
-          <p:cNvPr id="5" name=""/>
+          <p:cNvPr id="6" name=""/>
           <p:cNvPicPr>
             <a:picLocks xmlns:a="http://schemas.openxmlformats.org/drawingml/2006/main" noChangeAspect="1"/>
           </p:cNvPicPr>
           <p:nvPr/>
         </p:nvPicPr>
         <p:blipFill>
-          <a:blip xmlns:r="http://schemas.openxmlformats.org/officeDocument/2006/relationships" xmlns:a="http://schemas.openxmlformats.org/drawingml/2006/main" r:embed="R73cbc4f601124a11"/>
+          <a:blip xmlns:r="http://schemas.openxmlformats.org/officeDocument/2006/relationships" xmlns:a="http://schemas.openxmlformats.org/drawingml/2006/main" r:embed="Rea98c2d2b0b6443e"/>
           <a:srcRect xmlns:a="http://schemas.openxmlformats.org/drawingml/2006/main" l="0" t="27" r="0" b="27"/>
           <a:stretch xmlns:a="http://schemas.openxmlformats.org/drawingml/2006/main">
             <a:fillRect l="0" t="0" r="0" b="0"/>
@@ -3913,6 +4073,7 @@
           <a:lstStyle xmlns:a="http://schemas.openxmlformats.org/drawingml/2006/main"/>
           <a:p xmlns:a="http://schemas.openxmlformats.org/drawingml/2006/main">
             <a:pPr>
+              <a:buNone/>
               <a:defRPr sz="6150" b="1">
                 <a:solidFill>
                   <a:srgbClr val="FFFFFF"/>
@@ -3970,6 +4131,7 @@
           <a:lstStyle xmlns:a="http://schemas.openxmlformats.org/drawingml/2006/main"/>
           <a:p xmlns:a="http://schemas.openxmlformats.org/drawingml/2006/main">
             <a:pPr>
+              <a:buNone/>
               <a:defRPr sz="2400" b="0">
                 <a:solidFill>
                   <a:srgbClr val="FFFFFF"/>
@@ -4027,6 +4189,7 @@
           <a:lstStyle xmlns:a="http://schemas.openxmlformats.org/drawingml/2006/main"/>
           <a:p xmlns:a="http://schemas.openxmlformats.org/drawingml/2006/main">
             <a:pPr>
+              <a:buNone/>
               <a:defRPr sz="2250" b="0">
                 <a:solidFill>
                   <a:srgbClr val="A7E2D7"/>
@@ -4050,6 +4213,7 @@
           </a:p>
           <a:p xmlns:a="http://schemas.openxmlformats.org/drawingml/2006/main">
             <a:pPr>
+              <a:buNone/>
               <a:defRPr sz="2250" b="0">
                 <a:solidFill>
                   <a:srgbClr val="A7E2D7"/>
@@ -4136,6 +4300,7 @@
           <a:lstStyle xmlns:a="http://schemas.openxmlformats.org/drawingml/2006/main"/>
           <a:p xmlns:a="http://schemas.openxmlformats.org/drawingml/2006/main">
             <a:pPr>
+              <a:buNone/>
               <a:defRPr sz="11550" b="1">
                 <a:solidFill>
                   <a:srgbClr val="C1B4E7"/>
@@ -4193,6 +4358,7 @@
           <a:lstStyle xmlns:a="http://schemas.openxmlformats.org/drawingml/2006/main"/>
           <a:p xmlns:a="http://schemas.openxmlformats.org/drawingml/2006/main">
             <a:pPr>
+              <a:buNone/>
               <a:defRPr sz="1875" b="0">
                 <a:solidFill>
                   <a:srgbClr val="45516A"/>
@@ -4216,6 +4382,7 @@
           </a:p>
           <a:p xmlns:a="http://schemas.openxmlformats.org/drawingml/2006/main">
             <a:pPr>
+              <a:buNone/>
               <a:defRPr sz="1875" b="0">
                 <a:solidFill>
                   <a:srgbClr val="45516A"/>
@@ -4273,6 +4440,7 @@
           <a:lstStyle xmlns:a="http://schemas.openxmlformats.org/drawingml/2006/main"/>
           <a:p xmlns:a="http://schemas.openxmlformats.org/drawingml/2006/main">
             <a:pPr>
+              <a:buNone/>
               <a:defRPr sz="4275" b="1">
                 <a:solidFill>
                   <a:srgbClr val="172137"/>
@@ -4312,7 +4480,7 @@
         </p:nvSpPr>
         <p:spPr>
           <a:xfrm xmlns:a="http://schemas.openxmlformats.org/drawingml/2006/main">
-            <a:off x="3248025" y="2752725"/>
+            <a:off x="3248025" y="3619500"/>
             <a:ext cx="7620000" cy="314325"/>
           </a:xfrm>
           <a:prstGeom xmlns:a="http://schemas.openxmlformats.org/drawingml/2006/main" prst="rect">
@@ -4330,6 +4498,7 @@
           <a:lstStyle xmlns:a="http://schemas.openxmlformats.org/drawingml/2006/main"/>
           <a:p xmlns:a="http://schemas.openxmlformats.org/drawingml/2006/main">
             <a:pPr>
+              <a:buNone/>
               <a:defRPr sz="1800" b="1">
                 <a:solidFill>
                   <a:srgbClr val="6044B6"/>
@@ -4369,8 +4538,8 @@
         </p:nvSpPr>
         <p:spPr>
           <a:xfrm xmlns:a="http://schemas.openxmlformats.org/drawingml/2006/main">
-            <a:off x="3219450" y="3190875"/>
-            <a:ext cx="8191500" cy="1066800"/>
+            <a:off x="3219450" y="4010025"/>
+            <a:ext cx="8191500" cy="800100"/>
           </a:xfrm>
           <a:prstGeom xmlns:a="http://schemas.openxmlformats.org/drawingml/2006/main" prst="rect">
             <a:avLst/>
@@ -4387,6 +4556,7 @@
           <a:lstStyle xmlns:a="http://schemas.openxmlformats.org/drawingml/2006/main"/>
           <a:p xmlns:a="http://schemas.openxmlformats.org/drawingml/2006/main">
             <a:pPr>
+              <a:buNone/>
               <a:defRPr sz="2700" b="0">
                 <a:solidFill>
                   <a:srgbClr val="172137"/>
@@ -4397,7 +4567,7 @@
               </a:defRPr>
             </a:pPr>
             <a:r>
-              <a:rPr sz="2700" b="0">
+              <a:rPr sz="2400" b="0">
                 <a:solidFill>
                   <a:srgbClr val="172137"/>
                 </a:solidFill>
@@ -4410,6 +4580,7 @@
           </a:p>
           <a:p xmlns:a="http://schemas.openxmlformats.org/drawingml/2006/main">
             <a:pPr>
+              <a:buNone/>
               <a:defRPr sz="2700" b="0">
                 <a:solidFill>
                   <a:srgbClr val="172137"/>
@@ -4420,7 +4591,7 @@
               </a:defRPr>
             </a:pPr>
             <a:r>
-              <a:rPr sz="2700" b="0">
+              <a:rPr sz="2400" b="0">
                 <a:solidFill>
                   <a:srgbClr val="172137"/>
                 </a:solidFill>
@@ -4449,7 +4620,7 @@
         </p:nvSpPr>
         <p:spPr>
           <a:xfrm xmlns:a="http://schemas.openxmlformats.org/drawingml/2006/main">
-            <a:off x="3248025" y="4667250"/>
+            <a:off x="3248025" y="5143500"/>
             <a:ext cx="7620000" cy="314325"/>
           </a:xfrm>
           <a:prstGeom xmlns:a="http://schemas.openxmlformats.org/drawingml/2006/main" prst="rect">
@@ -4467,6 +4638,7 @@
           <a:lstStyle xmlns:a="http://schemas.openxmlformats.org/drawingml/2006/main"/>
           <a:p xmlns:a="http://schemas.openxmlformats.org/drawingml/2006/main">
             <a:pPr>
+              <a:buNone/>
               <a:defRPr sz="1800" b="1">
                 <a:solidFill>
                   <a:srgbClr val="6044B6"/>
@@ -4506,8 +4678,8 @@
         </p:nvSpPr>
         <p:spPr>
           <a:xfrm xmlns:a="http://schemas.openxmlformats.org/drawingml/2006/main">
-            <a:off x="3219450" y="5105400"/>
-            <a:ext cx="8191500" cy="1047750"/>
+            <a:off x="3219450" y="5534025"/>
+            <a:ext cx="8191500" cy="800100"/>
           </a:xfrm>
           <a:prstGeom xmlns:a="http://schemas.openxmlformats.org/drawingml/2006/main" prst="rect">
             <a:avLst/>
@@ -4524,6 +4696,7 @@
           <a:lstStyle xmlns:a="http://schemas.openxmlformats.org/drawingml/2006/main"/>
           <a:p xmlns:a="http://schemas.openxmlformats.org/drawingml/2006/main">
             <a:pPr>
+              <a:buNone/>
               <a:defRPr sz="2550" b="0">
                 <a:solidFill>
                   <a:srgbClr val="172137"/>
@@ -4534,7 +4707,7 @@
               </a:defRPr>
             </a:pPr>
             <a:r>
-              <a:rPr sz="2550" b="0">
+              <a:rPr sz="2250" b="0">
                 <a:solidFill>
                   <a:srgbClr val="172137"/>
                 </a:solidFill>
@@ -4547,6 +4720,7 @@
           </a:p>
           <a:p xmlns:a="http://schemas.openxmlformats.org/drawingml/2006/main">
             <a:pPr>
+              <a:buNone/>
               <a:defRPr sz="2550" b="0">
                 <a:solidFill>
                   <a:srgbClr val="172137"/>
@@ -4557,7 +4731,7 @@
               </a:defRPr>
             </a:pPr>
             <a:r>
-              <a:rPr sz="2550" b="0">
+              <a:rPr sz="2250" b="0">
                 <a:solidFill>
                   <a:srgbClr val="172137"/>
                 </a:solidFill>
@@ -4566,6 +4740,109 @@
                 <a:cs typeface="Arial"/>
               </a:rPr>
               <a:t>Mejorar código con pruebas que lo respalden.</a:t>
+            </a:r>
+          </a:p>
+        </p:txBody>
+      </p:sp>
+      <p:sp>
+        <p:nvSpPr>
+          <p:cNvPr id="9" name="Module context">
+            <a:extLst xmlns:a="http://schemas.openxmlformats.org/drawingml/2006/main">
+              <a:ext uri="{FF2B5EF4-FFF2-40B4-BE49-F238E27FC236}">
+                <a16:creationId xmlns:a16="http://schemas.microsoft.com/office/drawing/2014/main" id="{2ED2A792-6946-498C-B877-86F299CD7624}"/>
+              </a:ext>
+            </a:extLst>
+          </p:cNvPr>
+          <p:cNvSpPr>
+            <a:spLocks xmlns:a="http://schemas.openxmlformats.org/drawingml/2006/main" noGrp="1"/>
+          </p:cNvSpPr>
+          <p:nvPr/>
+        </p:nvSpPr>
+        <p:spPr>
+          <a:xfrm xmlns:a="http://schemas.openxmlformats.org/drawingml/2006/main">
+            <a:off x="3219450" y="2390775"/>
+            <a:ext cx="8191500" cy="1028700"/>
+          </a:xfrm>
+          <a:prstGeom xmlns:a="http://schemas.openxmlformats.org/drawingml/2006/main" prst="rect">
+            <a:avLst/>
+          </a:prstGeom>
+          <a:noFill xmlns:a="http://schemas.openxmlformats.org/drawingml/2006/main"/>
+          <a:ln xmlns:a="http://schemas.openxmlformats.org/drawingml/2006/main" w="0">
+            <a:noFill/>
+          </a:ln>
+        </p:spPr>
+        <p:txBody>
+          <a:bodyPr xmlns:a="http://schemas.openxmlformats.org/drawingml/2006/main" wrap="square" lIns="0" tIns="0" rIns="0" bIns="0" anchor="t">
+            <a:noAutofit/>
+          </a:bodyPr>
+          <a:lstStyle xmlns:a="http://schemas.openxmlformats.org/drawingml/2006/main"/>
+          <a:p xmlns:a="http://schemas.openxmlformats.org/drawingml/2006/main">
+            <a:pPr>
+              <a:defRPr sz="2100">
+                <a:solidFill>
+                  <a:srgbClr val="45516A"/>
+                </a:solidFill>
+                <a:latin typeface="Arial"/>
+                <a:ea typeface="Arial"/>
+                <a:cs typeface="Arial"/>
+              </a:defRPr>
+            </a:pPr>
+            <a:r>
+              <a:rPr sz="2100">
+                <a:solidFill>
+                  <a:srgbClr val="45516A"/>
+                </a:solidFill>
+                <a:latin typeface="Arial"/>
+                <a:ea typeface="Arial"/>
+                <a:cs typeface="Arial"/>
+              </a:rPr>
+              <a:t>Las pruebas comprueban el comportamiento esperado.</a:t>
+            </a:r>
+          </a:p>
+          <a:p xmlns:a="http://schemas.openxmlformats.org/drawingml/2006/main">
+            <a:pPr>
+              <a:defRPr sz="2100">
+                <a:solidFill>
+                  <a:srgbClr val="45516A"/>
+                </a:solidFill>
+                <a:latin typeface="Arial"/>
+                <a:ea typeface="Arial"/>
+                <a:cs typeface="Arial"/>
+              </a:defRPr>
+            </a:pPr>
+            <a:r>
+              <a:rPr sz="2100">
+                <a:solidFill>
+                  <a:srgbClr val="45516A"/>
+                </a:solidFill>
+                <a:latin typeface="Arial"/>
+                <a:ea typeface="Arial"/>
+                <a:cs typeface="Arial"/>
+              </a:rPr>
+              <a:t>Al modificar código, ayudan a detectar si dañamos</a:t>
+            </a:r>
+          </a:p>
+          <a:p xmlns:a="http://schemas.openxmlformats.org/drawingml/2006/main">
+            <a:pPr>
+              <a:defRPr sz="2100">
+                <a:solidFill>
+                  <a:srgbClr val="45516A"/>
+                </a:solidFill>
+                <a:latin typeface="Arial"/>
+                <a:ea typeface="Arial"/>
+                <a:cs typeface="Arial"/>
+              </a:defRPr>
+            </a:pPr>
+            <a:r>
+              <a:rPr sz="2100">
+                <a:solidFill>
+                  <a:srgbClr val="45516A"/>
+                </a:solidFill>
+                <a:latin typeface="Arial"/>
+                <a:ea typeface="Arial"/>
+                <a:cs typeface="Arial"/>
+              </a:rPr>
+              <a:t>una función que ya trabajaba correctamente.</a:t>
             </a:r>
           </a:p>
         </p:txBody>
@@ -4633,6 +4910,7 @@
           <a:lstStyle xmlns:a="http://schemas.openxmlformats.org/drawingml/2006/main"/>
           <a:p xmlns:a="http://schemas.openxmlformats.org/drawingml/2006/main">
             <a:pPr>
+              <a:buNone/>
               <a:defRPr sz="11550" b="1">
                 <a:solidFill>
                   <a:srgbClr val="C1B4E7"/>
@@ -4690,6 +4968,7 @@
           <a:lstStyle xmlns:a="http://schemas.openxmlformats.org/drawingml/2006/main"/>
           <a:p xmlns:a="http://schemas.openxmlformats.org/drawingml/2006/main">
             <a:pPr>
+              <a:buNone/>
               <a:defRPr sz="1875" b="0">
                 <a:solidFill>
                   <a:srgbClr val="45516A"/>
@@ -4713,6 +4992,7 @@
           </a:p>
           <a:p xmlns:a="http://schemas.openxmlformats.org/drawingml/2006/main">
             <a:pPr>
+              <a:buNone/>
               <a:defRPr sz="1875" b="0">
                 <a:solidFill>
                   <a:srgbClr val="45516A"/>
@@ -4770,6 +5050,7 @@
           <a:lstStyle xmlns:a="http://schemas.openxmlformats.org/drawingml/2006/main"/>
           <a:p xmlns:a="http://schemas.openxmlformats.org/drawingml/2006/main">
             <a:pPr>
+              <a:buNone/>
               <a:defRPr sz="4275" b="1">
                 <a:solidFill>
                   <a:srgbClr val="172137"/>
@@ -4793,6 +5074,7 @@
           </a:p>
           <a:p xmlns:a="http://schemas.openxmlformats.org/drawingml/2006/main">
             <a:pPr>
+              <a:buNone/>
               <a:defRPr sz="4275" b="1">
                 <a:solidFill>
                   <a:srgbClr val="172137"/>
@@ -4832,7 +5114,7 @@
         </p:nvSpPr>
         <p:spPr>
           <a:xfrm xmlns:a="http://schemas.openxmlformats.org/drawingml/2006/main">
-            <a:off x="3248025" y="2752725"/>
+            <a:off x="3248025" y="3619500"/>
             <a:ext cx="7620000" cy="314325"/>
           </a:xfrm>
           <a:prstGeom xmlns:a="http://schemas.openxmlformats.org/drawingml/2006/main" prst="rect">
@@ -4850,6 +5132,7 @@
           <a:lstStyle xmlns:a="http://schemas.openxmlformats.org/drawingml/2006/main"/>
           <a:p xmlns:a="http://schemas.openxmlformats.org/drawingml/2006/main">
             <a:pPr>
+              <a:buNone/>
               <a:defRPr sz="1800" b="1">
                 <a:solidFill>
                   <a:srgbClr val="6044B6"/>
@@ -4889,8 +5172,8 @@
         </p:nvSpPr>
         <p:spPr>
           <a:xfrm xmlns:a="http://schemas.openxmlformats.org/drawingml/2006/main">
-            <a:off x="3219450" y="3190875"/>
-            <a:ext cx="8191500" cy="1066800"/>
+            <a:off x="3219450" y="4010025"/>
+            <a:ext cx="8191500" cy="800100"/>
           </a:xfrm>
           <a:prstGeom xmlns:a="http://schemas.openxmlformats.org/drawingml/2006/main" prst="rect">
             <a:avLst/>
@@ -4907,6 +5190,7 @@
           <a:lstStyle xmlns:a="http://schemas.openxmlformats.org/drawingml/2006/main"/>
           <a:p xmlns:a="http://schemas.openxmlformats.org/drawingml/2006/main">
             <a:pPr>
+              <a:buNone/>
               <a:defRPr sz="2700" b="0">
                 <a:solidFill>
                   <a:srgbClr val="172137"/>
@@ -4917,7 +5201,7 @@
               </a:defRPr>
             </a:pPr>
             <a:r>
-              <a:rPr sz="2700" b="0">
+              <a:rPr sz="2400" b="0">
                 <a:solidFill>
                   <a:srgbClr val="172137"/>
                 </a:solidFill>
@@ -4930,6 +5214,7 @@
           </a:p>
           <a:p xmlns:a="http://schemas.openxmlformats.org/drawingml/2006/main">
             <a:pPr>
+              <a:buNone/>
               <a:defRPr sz="2700" b="0">
                 <a:solidFill>
                   <a:srgbClr val="172137"/>
@@ -4940,7 +5225,7 @@
               </a:defRPr>
             </a:pPr>
             <a:r>
-              <a:rPr sz="2700" b="0">
+              <a:rPr sz="2400" b="0">
                 <a:solidFill>
                   <a:srgbClr val="172137"/>
                 </a:solidFill>
@@ -4969,7 +5254,7 @@
         </p:nvSpPr>
         <p:spPr>
           <a:xfrm xmlns:a="http://schemas.openxmlformats.org/drawingml/2006/main">
-            <a:off x="3248025" y="4667250"/>
+            <a:off x="3248025" y="5143500"/>
             <a:ext cx="7620000" cy="314325"/>
           </a:xfrm>
           <a:prstGeom xmlns:a="http://schemas.openxmlformats.org/drawingml/2006/main" prst="rect">
@@ -4987,6 +5272,7 @@
           <a:lstStyle xmlns:a="http://schemas.openxmlformats.org/drawingml/2006/main"/>
           <a:p xmlns:a="http://schemas.openxmlformats.org/drawingml/2006/main">
             <a:pPr>
+              <a:buNone/>
               <a:defRPr sz="1800" b="1">
                 <a:solidFill>
                   <a:srgbClr val="6044B6"/>
@@ -5026,8 +5312,8 @@
         </p:nvSpPr>
         <p:spPr>
           <a:xfrm xmlns:a="http://schemas.openxmlformats.org/drawingml/2006/main">
-            <a:off x="3219450" y="5105400"/>
-            <a:ext cx="8191500" cy="1047750"/>
+            <a:off x="3219450" y="5534025"/>
+            <a:ext cx="8191500" cy="800100"/>
           </a:xfrm>
           <a:prstGeom xmlns:a="http://schemas.openxmlformats.org/drawingml/2006/main" prst="rect">
             <a:avLst/>
@@ -5044,6 +5330,7 @@
           <a:lstStyle xmlns:a="http://schemas.openxmlformats.org/drawingml/2006/main"/>
           <a:p xmlns:a="http://schemas.openxmlformats.org/drawingml/2006/main">
             <a:pPr>
+              <a:buNone/>
               <a:defRPr sz="2550" b="0">
                 <a:solidFill>
                   <a:srgbClr val="172137"/>
@@ -5054,7 +5341,7 @@
               </a:defRPr>
             </a:pPr>
             <a:r>
-              <a:rPr sz="2550" b="0">
+              <a:rPr sz="2250" b="0">
                 <a:solidFill>
                   <a:srgbClr val="172137"/>
                 </a:solidFill>
@@ -5067,6 +5354,7 @@
           </a:p>
           <a:p xmlns:a="http://schemas.openxmlformats.org/drawingml/2006/main">
             <a:pPr>
+              <a:buNone/>
               <a:defRPr sz="2550" b="0">
                 <a:solidFill>
                   <a:srgbClr val="172137"/>
@@ -5077,7 +5365,7 @@
               </a:defRPr>
             </a:pPr>
             <a:r>
-              <a:rPr sz="2550" b="0">
+              <a:rPr sz="2250" b="0">
                 <a:solidFill>
                   <a:srgbClr val="172137"/>
                 </a:solidFill>
@@ -5086,6 +5374,109 @@
                 <a:cs typeface="Arial"/>
               </a:rPr>
               <a:t>la recuperación del sistema.</a:t>
+            </a:r>
+          </a:p>
+        </p:txBody>
+      </p:sp>
+      <p:sp>
+        <p:nvSpPr>
+          <p:cNvPr id="9" name="Module context">
+            <a:extLst xmlns:a="http://schemas.openxmlformats.org/drawingml/2006/main">
+              <a:ext uri="{FF2B5EF4-FFF2-40B4-BE49-F238E27FC236}">
+                <a16:creationId xmlns:a16="http://schemas.microsoft.com/office/drawing/2014/main" id="{66439BBC-AB78-4B23-90E9-B0A87367C094}"/>
+              </a:ext>
+            </a:extLst>
+          </p:cNvPr>
+          <p:cNvSpPr>
+            <a:spLocks xmlns:a="http://schemas.openxmlformats.org/drawingml/2006/main" noGrp="1"/>
+          </p:cNvSpPr>
+          <p:nvPr/>
+        </p:nvSpPr>
+        <p:spPr>
+          <a:xfrm xmlns:a="http://schemas.openxmlformats.org/drawingml/2006/main">
+            <a:off x="3219450" y="2390775"/>
+            <a:ext cx="8191500" cy="1028700"/>
+          </a:xfrm>
+          <a:prstGeom xmlns:a="http://schemas.openxmlformats.org/drawingml/2006/main" prst="rect">
+            <a:avLst/>
+          </a:prstGeom>
+          <a:noFill xmlns:a="http://schemas.openxmlformats.org/drawingml/2006/main"/>
+          <a:ln xmlns:a="http://schemas.openxmlformats.org/drawingml/2006/main" w="0">
+            <a:noFill/>
+          </a:ln>
+        </p:spPr>
+        <p:txBody>
+          <a:bodyPr xmlns:a="http://schemas.openxmlformats.org/drawingml/2006/main" wrap="square" lIns="0" tIns="0" rIns="0" bIns="0" anchor="t">
+            <a:noAutofit/>
+          </a:bodyPr>
+          <a:lstStyle xmlns:a="http://schemas.openxmlformats.org/drawingml/2006/main"/>
+          <a:p xmlns:a="http://schemas.openxmlformats.org/drawingml/2006/main">
+            <a:pPr>
+              <a:defRPr sz="2100">
+                <a:solidFill>
+                  <a:srgbClr val="45516A"/>
+                </a:solidFill>
+                <a:latin typeface="Arial"/>
+                <a:ea typeface="Arial"/>
+                <a:cs typeface="Arial"/>
+              </a:defRPr>
+            </a:pPr>
+            <a:r>
+              <a:rPr sz="2100">
+                <a:solidFill>
+                  <a:srgbClr val="45516A"/>
+                </a:solidFill>
+                <a:latin typeface="Arial"/>
+                <a:ea typeface="Arial"/>
+                <a:cs typeface="Arial"/>
+              </a:rPr>
+              <a:t>Un servicio externo puede fallar. Guardar los avisos</a:t>
+            </a:r>
+          </a:p>
+          <a:p xmlns:a="http://schemas.openxmlformats.org/drawingml/2006/main">
+            <a:pPr>
+              <a:defRPr sz="2100">
+                <a:solidFill>
+                  <a:srgbClr val="45516A"/>
+                </a:solidFill>
+                <a:latin typeface="Arial"/>
+                <a:ea typeface="Arial"/>
+                <a:cs typeface="Arial"/>
+              </a:defRPr>
+            </a:pPr>
+            <a:r>
+              <a:rPr sz="2100">
+                <a:solidFill>
+                  <a:srgbClr val="45516A"/>
+                </a:solidFill>
+                <a:latin typeface="Arial"/>
+                <a:ea typeface="Arial"/>
+                <a:cs typeface="Arial"/>
+              </a:rPr>
+              <a:t>pendientes permite reintentar una notificación</a:t>
+            </a:r>
+          </a:p>
+          <a:p xmlns:a="http://schemas.openxmlformats.org/drawingml/2006/main">
+            <a:pPr>
+              <a:defRPr sz="2100">
+                <a:solidFill>
+                  <a:srgbClr val="45516A"/>
+                </a:solidFill>
+                <a:latin typeface="Arial"/>
+                <a:ea typeface="Arial"/>
+                <a:cs typeface="Arial"/>
+              </a:defRPr>
+            </a:pPr>
+            <a:r>
+              <a:rPr sz="2100">
+                <a:solidFill>
+                  <a:srgbClr val="45516A"/>
+                </a:solidFill>
+                <a:latin typeface="Arial"/>
+                <a:ea typeface="Arial"/>
+                <a:cs typeface="Arial"/>
+              </a:rPr>
+              <a:t>sin volver a crear el pedido.</a:t>
             </a:r>
           </a:p>
         </p:txBody>
@@ -5153,6 +5544,7 @@
           <a:lstStyle xmlns:a="http://schemas.openxmlformats.org/drawingml/2006/main"/>
           <a:p xmlns:a="http://schemas.openxmlformats.org/drawingml/2006/main">
             <a:pPr>
+              <a:buNone/>
               <a:defRPr sz="11550" b="1">
                 <a:solidFill>
                   <a:srgbClr val="C1B4E7"/>
@@ -5210,6 +5602,7 @@
           <a:lstStyle xmlns:a="http://schemas.openxmlformats.org/drawingml/2006/main"/>
           <a:p xmlns:a="http://schemas.openxmlformats.org/drawingml/2006/main">
             <a:pPr>
+              <a:buNone/>
               <a:defRPr sz="1875" b="0">
                 <a:solidFill>
                   <a:srgbClr val="45516A"/>
@@ -5233,6 +5626,7 @@
           </a:p>
           <a:p xmlns:a="http://schemas.openxmlformats.org/drawingml/2006/main">
             <a:pPr>
+              <a:buNone/>
               <a:defRPr sz="1875" b="0">
                 <a:solidFill>
                   <a:srgbClr val="45516A"/>
@@ -5290,6 +5684,7 @@
           <a:lstStyle xmlns:a="http://schemas.openxmlformats.org/drawingml/2006/main"/>
           <a:p xmlns:a="http://schemas.openxmlformats.org/drawingml/2006/main">
             <a:pPr>
+              <a:buNone/>
               <a:defRPr sz="4275" b="1">
                 <a:solidFill>
                   <a:srgbClr val="172137"/>
@@ -5313,6 +5708,7 @@
           </a:p>
           <a:p xmlns:a="http://schemas.openxmlformats.org/drawingml/2006/main">
             <a:pPr>
+              <a:buNone/>
               <a:defRPr sz="4275" b="1">
                 <a:solidFill>
                   <a:srgbClr val="172137"/>
@@ -5352,7 +5748,7 @@
         </p:nvSpPr>
         <p:spPr>
           <a:xfrm xmlns:a="http://schemas.openxmlformats.org/drawingml/2006/main">
-            <a:off x="3248025" y="2752725"/>
+            <a:off x="3248025" y="3619500"/>
             <a:ext cx="7620000" cy="314325"/>
           </a:xfrm>
           <a:prstGeom xmlns:a="http://schemas.openxmlformats.org/drawingml/2006/main" prst="rect">
@@ -5370,6 +5766,7 @@
           <a:lstStyle xmlns:a="http://schemas.openxmlformats.org/drawingml/2006/main"/>
           <a:p xmlns:a="http://schemas.openxmlformats.org/drawingml/2006/main">
             <a:pPr>
+              <a:buNone/>
               <a:defRPr sz="1800" b="1">
                 <a:solidFill>
                   <a:srgbClr val="6044B6"/>
@@ -5409,8 +5806,8 @@
         </p:nvSpPr>
         <p:spPr>
           <a:xfrm xmlns:a="http://schemas.openxmlformats.org/drawingml/2006/main">
-            <a:off x="3219450" y="3190875"/>
-            <a:ext cx="8191500" cy="1066800"/>
+            <a:off x="3219450" y="4010025"/>
+            <a:ext cx="8191500" cy="800100"/>
           </a:xfrm>
           <a:prstGeom xmlns:a="http://schemas.openxmlformats.org/drawingml/2006/main" prst="rect">
             <a:avLst/>
@@ -5427,6 +5824,7 @@
           <a:lstStyle xmlns:a="http://schemas.openxmlformats.org/drawingml/2006/main"/>
           <a:p xmlns:a="http://schemas.openxmlformats.org/drawingml/2006/main">
             <a:pPr>
+              <a:buNone/>
               <a:defRPr sz="2700" b="0">
                 <a:solidFill>
                   <a:srgbClr val="172137"/>
@@ -5437,7 +5835,7 @@
               </a:defRPr>
             </a:pPr>
             <a:r>
-              <a:rPr sz="2700" b="0">
+              <a:rPr sz="2400" b="0">
                 <a:solidFill>
                   <a:srgbClr val="172137"/>
                 </a:solidFill>
@@ -5450,6 +5848,7 @@
           </a:p>
           <a:p xmlns:a="http://schemas.openxmlformats.org/drawingml/2006/main">
             <a:pPr>
+              <a:buNone/>
               <a:defRPr sz="2700" b="0">
                 <a:solidFill>
                   <a:srgbClr val="172137"/>
@@ -5460,7 +5859,7 @@
               </a:defRPr>
             </a:pPr>
             <a:r>
-              <a:rPr sz="2700" b="0">
+              <a:rPr sz="2400" b="0">
                 <a:solidFill>
                   <a:srgbClr val="172137"/>
                 </a:solidFill>
@@ -5489,7 +5888,7 @@
         </p:nvSpPr>
         <p:spPr>
           <a:xfrm xmlns:a="http://schemas.openxmlformats.org/drawingml/2006/main">
-            <a:off x="3248025" y="4667250"/>
+            <a:off x="3248025" y="5143500"/>
             <a:ext cx="7620000" cy="314325"/>
           </a:xfrm>
           <a:prstGeom xmlns:a="http://schemas.openxmlformats.org/drawingml/2006/main" prst="rect">
@@ -5507,6 +5906,7 @@
           <a:lstStyle xmlns:a="http://schemas.openxmlformats.org/drawingml/2006/main"/>
           <a:p xmlns:a="http://schemas.openxmlformats.org/drawingml/2006/main">
             <a:pPr>
+              <a:buNone/>
               <a:defRPr sz="1800" b="1">
                 <a:solidFill>
                   <a:srgbClr val="6044B6"/>
@@ -5546,8 +5946,8 @@
         </p:nvSpPr>
         <p:spPr>
           <a:xfrm xmlns:a="http://schemas.openxmlformats.org/drawingml/2006/main">
-            <a:off x="3219450" y="5105400"/>
-            <a:ext cx="8191500" cy="1047750"/>
+            <a:off x="3219450" y="5534025"/>
+            <a:ext cx="8191500" cy="800100"/>
           </a:xfrm>
           <a:prstGeom xmlns:a="http://schemas.openxmlformats.org/drawingml/2006/main" prst="rect">
             <a:avLst/>
@@ -5564,6 +5964,7 @@
           <a:lstStyle xmlns:a="http://schemas.openxmlformats.org/drawingml/2006/main"/>
           <a:p xmlns:a="http://schemas.openxmlformats.org/drawingml/2006/main">
             <a:pPr>
+              <a:buNone/>
               <a:defRPr sz="2550" b="0">
                 <a:solidFill>
                   <a:srgbClr val="172137"/>
@@ -5574,7 +5975,7 @@
               </a:defRPr>
             </a:pPr>
             <a:r>
-              <a:rPr sz="2550" b="0">
+              <a:rPr sz="2250" b="0">
                 <a:solidFill>
                   <a:srgbClr val="172137"/>
                 </a:solidFill>
@@ -5587,6 +5988,7 @@
           </a:p>
           <a:p xmlns:a="http://schemas.openxmlformats.org/drawingml/2006/main">
             <a:pPr>
+              <a:buNone/>
               <a:defRPr sz="2550" b="0">
                 <a:solidFill>
                   <a:srgbClr val="172137"/>
@@ -5597,7 +5999,7 @@
               </a:defRPr>
             </a:pPr>
             <a:r>
-              <a:rPr sz="2550" b="0">
+              <a:rPr sz="2250" b="0">
                 <a:solidFill>
                   <a:srgbClr val="172137"/>
                 </a:solidFill>
@@ -5606,6 +6008,109 @@
                 <a:cs typeface="Arial"/>
               </a:rPr>
               <a:t>problemas con métricas y trazas.</a:t>
+            </a:r>
+          </a:p>
+        </p:txBody>
+      </p:sp>
+      <p:sp>
+        <p:nvSpPr>
+          <p:cNvPr id="9" name="Module context">
+            <a:extLst xmlns:a="http://schemas.openxmlformats.org/drawingml/2006/main">
+              <a:ext uri="{FF2B5EF4-FFF2-40B4-BE49-F238E27FC236}">
+                <a16:creationId xmlns:a16="http://schemas.microsoft.com/office/drawing/2014/main" id="{65E0378C-E562-45DA-B568-FA47CCE18704}"/>
+              </a:ext>
+            </a:extLst>
+          </p:cNvPr>
+          <p:cNvSpPr>
+            <a:spLocks xmlns:a="http://schemas.openxmlformats.org/drawingml/2006/main" noGrp="1"/>
+          </p:cNvSpPr>
+          <p:nvPr/>
+        </p:nvSpPr>
+        <p:spPr>
+          <a:xfrm xmlns:a="http://schemas.openxmlformats.org/drawingml/2006/main">
+            <a:off x="3219450" y="2390775"/>
+            <a:ext cx="8191500" cy="1028700"/>
+          </a:xfrm>
+          <a:prstGeom xmlns:a="http://schemas.openxmlformats.org/drawingml/2006/main" prst="rect">
+            <a:avLst/>
+          </a:prstGeom>
+          <a:noFill xmlns:a="http://schemas.openxmlformats.org/drawingml/2006/main"/>
+          <a:ln xmlns:a="http://schemas.openxmlformats.org/drawingml/2006/main" w="0">
+            <a:noFill/>
+          </a:ln>
+        </p:spPr>
+        <p:txBody>
+          <a:bodyPr xmlns:a="http://schemas.openxmlformats.org/drawingml/2006/main" wrap="square" lIns="0" tIns="0" rIns="0" bIns="0" anchor="t">
+            <a:noAutofit/>
+          </a:bodyPr>
+          <a:lstStyle xmlns:a="http://schemas.openxmlformats.org/drawingml/2006/main"/>
+          <a:p xmlns:a="http://schemas.openxmlformats.org/drawingml/2006/main">
+            <a:pPr>
+              <a:defRPr sz="2100">
+                <a:solidFill>
+                  <a:srgbClr val="45516A"/>
+                </a:solidFill>
+                <a:latin typeface="Arial"/>
+                <a:ea typeface="Arial"/>
+                <a:cs typeface="Arial"/>
+              </a:defRPr>
+            </a:pPr>
+            <a:r>
+              <a:rPr sz="2100">
+                <a:solidFill>
+                  <a:srgbClr val="45516A"/>
+                </a:solidFill>
+                <a:latin typeface="Arial"/>
+                <a:ea typeface="Arial"/>
+                <a:cs typeface="Arial"/>
+              </a:rPr>
+              <a:t>Docker ayuda a ejecutar el mismo entorno en el equipo.</a:t>
+            </a:r>
+          </a:p>
+          <a:p xmlns:a="http://schemas.openxmlformats.org/drawingml/2006/main">
+            <a:pPr>
+              <a:defRPr sz="2100">
+                <a:solidFill>
+                  <a:srgbClr val="45516A"/>
+                </a:solidFill>
+                <a:latin typeface="Arial"/>
+                <a:ea typeface="Arial"/>
+                <a:cs typeface="Arial"/>
+              </a:defRPr>
+            </a:pPr>
+            <a:r>
+              <a:rPr sz="2100">
+                <a:solidFill>
+                  <a:srgbClr val="45516A"/>
+                </a:solidFill>
+                <a:latin typeface="Arial"/>
+                <a:ea typeface="Arial"/>
+                <a:cs typeface="Arial"/>
+              </a:rPr>
+              <a:t>La telemetría muestra qué sucede en cada petición</a:t>
+            </a:r>
+          </a:p>
+          <a:p xmlns:a="http://schemas.openxmlformats.org/drawingml/2006/main">
+            <a:pPr>
+              <a:defRPr sz="2100">
+                <a:solidFill>
+                  <a:srgbClr val="45516A"/>
+                </a:solidFill>
+                <a:latin typeface="Arial"/>
+                <a:ea typeface="Arial"/>
+                <a:cs typeface="Arial"/>
+              </a:defRPr>
+            </a:pPr>
+            <a:r>
+              <a:rPr sz="2100">
+                <a:solidFill>
+                  <a:srgbClr val="45516A"/>
+                </a:solidFill>
+                <a:latin typeface="Arial"/>
+                <a:ea typeface="Arial"/>
+                <a:cs typeface="Arial"/>
+              </a:rPr>
+              <a:t>para encontrar errores y demoras.</a:t>
             </a:r>
           </a:p>
         </p:txBody>
@@ -5673,6 +6178,7 @@
           <a:lstStyle xmlns:a="http://schemas.openxmlformats.org/drawingml/2006/main"/>
           <a:p xmlns:a="http://schemas.openxmlformats.org/drawingml/2006/main">
             <a:pPr>
+              <a:buNone/>
               <a:defRPr sz="11550" b="1">
                 <a:solidFill>
                   <a:srgbClr val="C1B4E7"/>
@@ -5730,6 +6236,7 @@
           <a:lstStyle xmlns:a="http://schemas.openxmlformats.org/drawingml/2006/main"/>
           <a:p xmlns:a="http://schemas.openxmlformats.org/drawingml/2006/main">
             <a:pPr>
+              <a:buNone/>
               <a:defRPr sz="1875" b="0">
                 <a:solidFill>
                   <a:srgbClr val="45516A"/>
@@ -5753,6 +6260,7 @@
           </a:p>
           <a:p xmlns:a="http://schemas.openxmlformats.org/drawingml/2006/main">
             <a:pPr>
+              <a:buNone/>
               <a:defRPr sz="1875" b="0">
                 <a:solidFill>
                   <a:srgbClr val="45516A"/>
@@ -5810,6 +6318,7 @@
           <a:lstStyle xmlns:a="http://schemas.openxmlformats.org/drawingml/2006/main"/>
           <a:p xmlns:a="http://schemas.openxmlformats.org/drawingml/2006/main">
             <a:pPr>
+              <a:buNone/>
               <a:defRPr sz="4275" b="1">
                 <a:solidFill>
                   <a:srgbClr val="172137"/>
@@ -5833,6 +6342,7 @@
           </a:p>
           <a:p xmlns:a="http://schemas.openxmlformats.org/drawingml/2006/main">
             <a:pPr>
+              <a:buNone/>
               <a:defRPr sz="4275" b="1">
                 <a:solidFill>
                   <a:srgbClr val="172137"/>
@@ -5872,7 +6382,7 @@
         </p:nvSpPr>
         <p:spPr>
           <a:xfrm xmlns:a="http://schemas.openxmlformats.org/drawingml/2006/main">
-            <a:off x="3248025" y="2752725"/>
+            <a:off x="3248025" y="3619500"/>
             <a:ext cx="7620000" cy="314325"/>
           </a:xfrm>
           <a:prstGeom xmlns:a="http://schemas.openxmlformats.org/drawingml/2006/main" prst="rect">
@@ -5890,6 +6400,7 @@
           <a:lstStyle xmlns:a="http://schemas.openxmlformats.org/drawingml/2006/main"/>
           <a:p xmlns:a="http://schemas.openxmlformats.org/drawingml/2006/main">
             <a:pPr>
+              <a:buNone/>
               <a:defRPr sz="1800" b="1">
                 <a:solidFill>
                   <a:srgbClr val="6044B6"/>
@@ -5929,8 +6440,8 @@
         </p:nvSpPr>
         <p:spPr>
           <a:xfrm xmlns:a="http://schemas.openxmlformats.org/drawingml/2006/main">
-            <a:off x="3219450" y="3190875"/>
-            <a:ext cx="8191500" cy="1066800"/>
+            <a:off x="3219450" y="4010025"/>
+            <a:ext cx="8191500" cy="800100"/>
           </a:xfrm>
           <a:prstGeom xmlns:a="http://schemas.openxmlformats.org/drawingml/2006/main" prst="rect">
             <a:avLst/>
@@ -5947,6 +6458,7 @@
           <a:lstStyle xmlns:a="http://schemas.openxmlformats.org/drawingml/2006/main"/>
           <a:p xmlns:a="http://schemas.openxmlformats.org/drawingml/2006/main">
             <a:pPr>
+              <a:buNone/>
               <a:defRPr sz="2700" b="0">
                 <a:solidFill>
                   <a:srgbClr val="172137"/>
@@ -5957,7 +6469,7 @@
               </a:defRPr>
             </a:pPr>
             <a:r>
-              <a:rPr sz="2700" b="0">
+              <a:rPr sz="2400" b="0">
                 <a:solidFill>
                   <a:srgbClr val="172137"/>
                 </a:solidFill>
@@ -5970,6 +6482,7 @@
           </a:p>
           <a:p xmlns:a="http://schemas.openxmlformats.org/drawingml/2006/main">
             <a:pPr>
+              <a:buNone/>
               <a:defRPr sz="2700" b="0">
                 <a:solidFill>
                   <a:srgbClr val="172137"/>
@@ -5980,7 +6493,7 @@
               </a:defRPr>
             </a:pPr>
             <a:r>
-              <a:rPr sz="2700" b="0">
+              <a:rPr sz="2400" b="0">
                 <a:solidFill>
                   <a:srgbClr val="172137"/>
                 </a:solidFill>
@@ -6009,7 +6522,7 @@
         </p:nvSpPr>
         <p:spPr>
           <a:xfrm xmlns:a="http://schemas.openxmlformats.org/drawingml/2006/main">
-            <a:off x="3248025" y="4667250"/>
+            <a:off x="3248025" y="5143500"/>
             <a:ext cx="7620000" cy="314325"/>
           </a:xfrm>
           <a:prstGeom xmlns:a="http://schemas.openxmlformats.org/drawingml/2006/main" prst="rect">
@@ -6027,6 +6540,7 @@
           <a:lstStyle xmlns:a="http://schemas.openxmlformats.org/drawingml/2006/main"/>
           <a:p xmlns:a="http://schemas.openxmlformats.org/drawingml/2006/main">
             <a:pPr>
+              <a:buNone/>
               <a:defRPr sz="1800" b="1">
                 <a:solidFill>
                   <a:srgbClr val="6044B6"/>
@@ -6066,8 +6580,8 @@
         </p:nvSpPr>
         <p:spPr>
           <a:xfrm xmlns:a="http://schemas.openxmlformats.org/drawingml/2006/main">
-            <a:off x="3219450" y="5105400"/>
-            <a:ext cx="8191500" cy="1047750"/>
+            <a:off x="3219450" y="5534025"/>
+            <a:ext cx="8191500" cy="800100"/>
           </a:xfrm>
           <a:prstGeom xmlns:a="http://schemas.openxmlformats.org/drawingml/2006/main" prst="rect">
             <a:avLst/>
@@ -6084,6 +6598,7 @@
           <a:lstStyle xmlns:a="http://schemas.openxmlformats.org/drawingml/2006/main"/>
           <a:p xmlns:a="http://schemas.openxmlformats.org/drawingml/2006/main">
             <a:pPr>
+              <a:buNone/>
               <a:defRPr sz="2550" b="0">
                 <a:solidFill>
                   <a:srgbClr val="172137"/>
@@ -6094,7 +6609,7 @@
               </a:defRPr>
             </a:pPr>
             <a:r>
-              <a:rPr sz="2550" b="0">
+              <a:rPr sz="2250" b="0">
                 <a:solidFill>
                   <a:srgbClr val="172137"/>
                 </a:solidFill>
@@ -6107,6 +6622,7 @@
           </a:p>
           <a:p xmlns:a="http://schemas.openxmlformats.org/drawingml/2006/main">
             <a:pPr>
+              <a:buNone/>
               <a:defRPr sz="2550" b="0">
                 <a:solidFill>
                   <a:srgbClr val="172137"/>
@@ -6117,7 +6633,7 @@
               </a:defRPr>
             </a:pPr>
             <a:r>
-              <a:rPr sz="2550" b="0">
+              <a:rPr sz="2250" b="0">
                 <a:solidFill>
                   <a:srgbClr val="172137"/>
                 </a:solidFill>
@@ -6126,6 +6642,109 @@
                 <a:cs typeface="Arial"/>
               </a:rPr>
               <a:t>y justificar tus decisiones.</a:t>
+            </a:r>
+          </a:p>
+        </p:txBody>
+      </p:sp>
+      <p:sp>
+        <p:nvSpPr>
+          <p:cNvPr id="9" name="Module context">
+            <a:extLst xmlns:a="http://schemas.openxmlformats.org/drawingml/2006/main">
+              <a:ext uri="{FF2B5EF4-FFF2-40B4-BE49-F238E27FC236}">
+                <a16:creationId xmlns:a16="http://schemas.microsoft.com/office/drawing/2014/main" id="{F932CE8D-F249-418E-B979-704F680BB683}"/>
+              </a:ext>
+            </a:extLst>
+          </p:cNvPr>
+          <p:cNvSpPr>
+            <a:spLocks xmlns:a="http://schemas.openxmlformats.org/drawingml/2006/main" noGrp="1"/>
+          </p:cNvSpPr>
+          <p:nvPr/>
+        </p:nvSpPr>
+        <p:spPr>
+          <a:xfrm xmlns:a="http://schemas.openxmlformats.org/drawingml/2006/main">
+            <a:off x="3219450" y="2390775"/>
+            <a:ext cx="8191500" cy="1028700"/>
+          </a:xfrm>
+          <a:prstGeom xmlns:a="http://schemas.openxmlformats.org/drawingml/2006/main" prst="rect">
+            <a:avLst/>
+          </a:prstGeom>
+          <a:noFill xmlns:a="http://schemas.openxmlformats.org/drawingml/2006/main"/>
+          <a:ln xmlns:a="http://schemas.openxmlformats.org/drawingml/2006/main" w="0">
+            <a:noFill/>
+          </a:ln>
+        </p:spPr>
+        <p:txBody>
+          <a:bodyPr xmlns:a="http://schemas.openxmlformats.org/drawingml/2006/main" wrap="square" lIns="0" tIns="0" rIns="0" bIns="0" anchor="t">
+            <a:noAutofit/>
+          </a:bodyPr>
+          <a:lstStyle xmlns:a="http://schemas.openxmlformats.org/drawingml/2006/main"/>
+          <a:p xmlns:a="http://schemas.openxmlformats.org/drawingml/2006/main">
+            <a:pPr>
+              <a:defRPr sz="2100">
+                <a:solidFill>
+                  <a:srgbClr val="45516A"/>
+                </a:solidFill>
+                <a:latin typeface="Arial"/>
+                <a:ea typeface="Arial"/>
+                <a:cs typeface="Arial"/>
+              </a:defRPr>
+            </a:pPr>
+            <a:r>
+              <a:rPr sz="2100">
+                <a:solidFill>
+                  <a:srgbClr val="45516A"/>
+                </a:solidFill>
+                <a:latin typeface="Arial"/>
+                <a:ea typeface="Arial"/>
+                <a:cs typeface="Arial"/>
+              </a:rPr>
+              <a:t>La entrega reúne lo aprendido en un cambio completo.</a:t>
+            </a:r>
+          </a:p>
+          <a:p xmlns:a="http://schemas.openxmlformats.org/drawingml/2006/main">
+            <a:pPr>
+              <a:defRPr sz="2100">
+                <a:solidFill>
+                  <a:srgbClr val="45516A"/>
+                </a:solidFill>
+                <a:latin typeface="Arial"/>
+                <a:ea typeface="Arial"/>
+                <a:cs typeface="Arial"/>
+              </a:defRPr>
+            </a:pPr>
+            <a:r>
+              <a:rPr sz="2100">
+                <a:solidFill>
+                  <a:srgbClr val="45516A"/>
+                </a:solidFill>
+                <a:latin typeface="Arial"/>
+                <a:ea typeface="Arial"/>
+                <a:cs typeface="Arial"/>
+              </a:rPr>
+              <a:t>Demostrarás cómo funciona y explicarás sus decisiones,</a:t>
+            </a:r>
+          </a:p>
+          <a:p xmlns:a="http://schemas.openxmlformats.org/drawingml/2006/main">
+            <a:pPr>
+              <a:defRPr sz="2100">
+                <a:solidFill>
+                  <a:srgbClr val="45516A"/>
+                </a:solidFill>
+                <a:latin typeface="Arial"/>
+                <a:ea typeface="Arial"/>
+                <a:cs typeface="Arial"/>
+              </a:defRPr>
+            </a:pPr>
+            <a:r>
+              <a:rPr sz="2100">
+                <a:solidFill>
+                  <a:srgbClr val="45516A"/>
+                </a:solidFill>
+                <a:latin typeface="Arial"/>
+                <a:ea typeface="Arial"/>
+                <a:cs typeface="Arial"/>
+              </a:rPr>
+              <a:t>la evidencia y los pendientes para producción.</a:t>
             </a:r>
           </a:p>
         </p:txBody>
@@ -6161,14 +6780,14 @@
       </p:grpSpPr>
       <p:pic>
         <p:nvPicPr>
-          <p:cNvPr id="7" name=""/>
+          <p:cNvPr id="8" name=""/>
           <p:cNvPicPr>
             <a:picLocks xmlns:a="http://schemas.openxmlformats.org/drawingml/2006/main" noChangeAspect="1"/>
           </p:cNvPicPr>
           <p:nvPr/>
         </p:nvPicPr>
         <p:blipFill>
-          <a:blip xmlns:r="http://schemas.openxmlformats.org/officeDocument/2006/relationships" xmlns:a="http://schemas.openxmlformats.org/drawingml/2006/main" r:embed="Rd7d085a144fe4197"/>
+          <a:blip xmlns:r="http://schemas.openxmlformats.org/officeDocument/2006/relationships" xmlns:a="http://schemas.openxmlformats.org/drawingml/2006/main" r:embed="R495f4baf13ac4bd3"/>
           <a:srcRect xmlns:a="http://schemas.openxmlformats.org/drawingml/2006/main" l="0" t="27" r="0" b="27"/>
           <a:stretch xmlns:a="http://schemas.openxmlformats.org/drawingml/2006/main">
             <a:fillRect l="0" t="0" r="0" b="0"/>
@@ -6218,6 +6837,7 @@
           <a:lstStyle xmlns:a="http://schemas.openxmlformats.org/drawingml/2006/main"/>
           <a:p xmlns:a="http://schemas.openxmlformats.org/drawingml/2006/main">
             <a:pPr>
+              <a:buNone/>
               <a:defRPr sz="4875" b="1">
                 <a:solidFill>
                   <a:srgbClr val="FFFFFF"/>
@@ -6275,6 +6895,7 @@
           <a:lstStyle xmlns:a="http://schemas.openxmlformats.org/drawingml/2006/main"/>
           <a:p xmlns:a="http://schemas.openxmlformats.org/drawingml/2006/main">
             <a:pPr>
+              <a:buNone/>
               <a:defRPr sz="2700" b="0">
                 <a:solidFill>
                   <a:srgbClr val="FFFFFF"/>
@@ -6332,6 +6953,7 @@
           <a:lstStyle xmlns:a="http://schemas.openxmlformats.org/drawingml/2006/main"/>
           <a:p xmlns:a="http://schemas.openxmlformats.org/drawingml/2006/main">
             <a:pPr>
+              <a:buNone/>
               <a:defRPr sz="2700" b="0">
                 <a:solidFill>
                   <a:srgbClr val="FFFFFF"/>
@@ -6389,6 +7011,7 @@
           <a:lstStyle xmlns:a="http://schemas.openxmlformats.org/drawingml/2006/main"/>
           <a:p xmlns:a="http://schemas.openxmlformats.org/drawingml/2006/main">
             <a:pPr>
+              <a:buNone/>
               <a:defRPr sz="2700" b="0">
                 <a:solidFill>
                   <a:srgbClr val="FFFFFF"/>
@@ -6446,6 +7069,7 @@
           <a:lstStyle xmlns:a="http://schemas.openxmlformats.org/drawingml/2006/main"/>
           <a:p xmlns:a="http://schemas.openxmlformats.org/drawingml/2006/main">
             <a:pPr>
+              <a:buNone/>
               <a:defRPr sz="2100" b="0">
                 <a:solidFill>
                   <a:srgbClr val="A7E2D7"/>
@@ -6463,7 +7087,7 @@
                 <a:latin typeface="Arial"/>
                 <a:ea typeface="Arial"/>
                 <a:cs typeface="Arial"/>
-                <a:hlinkClick xmlns:r="http://schemas.openxmlformats.org/officeDocument/2006/relationships" r:id="R7fa304577f1c4e49"/>
+                <a:hlinkClick xmlns:r="http://schemas.openxmlformats.org/officeDocument/2006/relationships" r:id="R43c96bf8eb614e99"/>
               </a:rPr>
               <a:t>github.com/ychavez/CursoNETIA</a:t>
             </a:r>
@@ -6533,6 +7157,7 @@
           <a:lstStyle xmlns:a="http://schemas.openxmlformats.org/drawingml/2006/main"/>
           <a:p xmlns:a="http://schemas.openxmlformats.org/drawingml/2006/main">
             <a:pPr>
+              <a:buNone/>
               <a:defRPr sz="5400" b="1">
                 <a:solidFill>
                   <a:srgbClr val="6044B6"/>
@@ -6590,6 +7215,7 @@
           <a:lstStyle xmlns:a="http://schemas.openxmlformats.org/drawingml/2006/main"/>
           <a:p xmlns:a="http://schemas.openxmlformats.org/drawingml/2006/main">
             <a:pPr>
+              <a:buNone/>
               <a:defRPr sz="4125" b="1">
                 <a:solidFill>
                   <a:srgbClr val="172137"/>
@@ -6613,6 +7239,7 @@
           </a:p>
           <a:p xmlns:a="http://schemas.openxmlformats.org/drawingml/2006/main">
             <a:pPr>
+              <a:buNone/>
               <a:defRPr sz="4125" b="1">
                 <a:solidFill>
                   <a:srgbClr val="172137"/>
@@ -6670,6 +7297,7 @@
           <a:lstStyle xmlns:a="http://schemas.openxmlformats.org/drawingml/2006/main"/>
           <a:p xmlns:a="http://schemas.openxmlformats.org/drawingml/2006/main">
             <a:pPr>
+              <a:buNone/>
               <a:defRPr sz="2400" b="0">
                 <a:solidFill>
                   <a:srgbClr val="45516A"/>
@@ -6693,6 +7321,7 @@
           </a:p>
           <a:p xmlns:a="http://schemas.openxmlformats.org/drawingml/2006/main">
             <a:pPr>
+              <a:buNone/>
               <a:defRPr sz="2400" b="0">
                 <a:solidFill>
                   <a:srgbClr val="45516A"/>
@@ -6779,6 +7408,7 @@
           <a:lstStyle xmlns:a="http://schemas.openxmlformats.org/drawingml/2006/main"/>
           <a:p xmlns:a="http://schemas.openxmlformats.org/drawingml/2006/main">
             <a:pPr>
+              <a:buNone/>
               <a:defRPr sz="4350" b="1">
                 <a:solidFill>
                   <a:srgbClr val="FFFFFF"/>
@@ -6836,6 +7466,7 @@
           <a:lstStyle xmlns:a="http://schemas.openxmlformats.org/drawingml/2006/main"/>
           <a:p xmlns:a="http://schemas.openxmlformats.org/drawingml/2006/main">
             <a:pPr>
+              <a:buNone/>
               <a:defRPr sz="4350" b="0">
                 <a:solidFill>
                   <a:srgbClr val="FFFFFF"/>
@@ -6893,6 +7524,7 @@
           <a:lstStyle xmlns:a="http://schemas.openxmlformats.org/drawingml/2006/main"/>
           <a:p xmlns:a="http://schemas.openxmlformats.org/drawingml/2006/main">
             <a:pPr>
+              <a:buNone/>
               <a:defRPr sz="4350" b="1">
                 <a:solidFill>
                   <a:srgbClr val="A7E2D7"/>
@@ -6950,6 +7582,7 @@
           <a:lstStyle xmlns:a="http://schemas.openxmlformats.org/drawingml/2006/main"/>
           <a:p xmlns:a="http://schemas.openxmlformats.org/drawingml/2006/main">
             <a:pPr>
+              <a:buNone/>
               <a:defRPr sz="2250" b="0">
                 <a:solidFill>
                   <a:srgbClr val="FFFFFF"/>
@@ -6973,6 +7606,7 @@
           </a:p>
           <a:p xmlns:a="http://schemas.openxmlformats.org/drawingml/2006/main">
             <a:pPr>
+              <a:buNone/>
               <a:defRPr sz="2250" b="0">
                 <a:solidFill>
                   <a:srgbClr val="FFFFFF"/>
@@ -7059,6 +7693,7 @@
           <a:lstStyle xmlns:a="http://schemas.openxmlformats.org/drawingml/2006/main"/>
           <a:p xmlns:a="http://schemas.openxmlformats.org/drawingml/2006/main">
             <a:pPr>
+              <a:buNone/>
               <a:defRPr sz="11550" b="1">
                 <a:solidFill>
                   <a:srgbClr val="C1B4E7"/>
@@ -7116,6 +7751,7 @@
           <a:lstStyle xmlns:a="http://schemas.openxmlformats.org/drawingml/2006/main"/>
           <a:p xmlns:a="http://schemas.openxmlformats.org/drawingml/2006/main">
             <a:pPr>
+              <a:buNone/>
               <a:defRPr sz="1875" b="0">
                 <a:solidFill>
                   <a:srgbClr val="45516A"/>
@@ -7139,6 +7775,7 @@
           </a:p>
           <a:p xmlns:a="http://schemas.openxmlformats.org/drawingml/2006/main">
             <a:pPr>
+              <a:buNone/>
               <a:defRPr sz="1875" b="0">
                 <a:solidFill>
                   <a:srgbClr val="45516A"/>
@@ -7196,6 +7833,7 @@
           <a:lstStyle xmlns:a="http://schemas.openxmlformats.org/drawingml/2006/main"/>
           <a:p xmlns:a="http://schemas.openxmlformats.org/drawingml/2006/main">
             <a:pPr>
+              <a:buNone/>
               <a:defRPr sz="4275" b="1">
                 <a:solidFill>
                   <a:srgbClr val="172137"/>
@@ -7235,7 +7873,7 @@
         </p:nvSpPr>
         <p:spPr>
           <a:xfrm xmlns:a="http://schemas.openxmlformats.org/drawingml/2006/main">
-            <a:off x="3248025" y="2752725"/>
+            <a:off x="3248025" y="3619500"/>
             <a:ext cx="7620000" cy="314325"/>
           </a:xfrm>
           <a:prstGeom xmlns:a="http://schemas.openxmlformats.org/drawingml/2006/main" prst="rect">
@@ -7253,6 +7891,7 @@
           <a:lstStyle xmlns:a="http://schemas.openxmlformats.org/drawingml/2006/main"/>
           <a:p xmlns:a="http://schemas.openxmlformats.org/drawingml/2006/main">
             <a:pPr>
+              <a:buNone/>
               <a:defRPr sz="1800" b="1">
                 <a:solidFill>
                   <a:srgbClr val="6044B6"/>
@@ -7292,8 +7931,8 @@
         </p:nvSpPr>
         <p:spPr>
           <a:xfrm xmlns:a="http://schemas.openxmlformats.org/drawingml/2006/main">
-            <a:off x="3219450" y="3190875"/>
-            <a:ext cx="8191500" cy="1066800"/>
+            <a:off x="3219450" y="4010025"/>
+            <a:ext cx="8191500" cy="800100"/>
           </a:xfrm>
           <a:prstGeom xmlns:a="http://schemas.openxmlformats.org/drawingml/2006/main" prst="rect">
             <a:avLst/>
@@ -7310,6 +7949,7 @@
           <a:lstStyle xmlns:a="http://schemas.openxmlformats.org/drawingml/2006/main"/>
           <a:p xmlns:a="http://schemas.openxmlformats.org/drawingml/2006/main">
             <a:pPr>
+              <a:buNone/>
               <a:defRPr sz="2700" b="0">
                 <a:solidFill>
                   <a:srgbClr val="172137"/>
@@ -7320,7 +7960,7 @@
               </a:defRPr>
             </a:pPr>
             <a:r>
-              <a:rPr sz="2700" b="0">
+              <a:rPr sz="2400" b="0">
                 <a:solidFill>
                   <a:srgbClr val="172137"/>
                 </a:solidFill>
@@ -7333,6 +7973,7 @@
           </a:p>
           <a:p xmlns:a="http://schemas.openxmlformats.org/drawingml/2006/main">
             <a:pPr>
+              <a:buNone/>
               <a:defRPr sz="2700" b="0">
                 <a:solidFill>
                   <a:srgbClr val="172137"/>
@@ -7343,7 +7984,7 @@
               </a:defRPr>
             </a:pPr>
             <a:r>
-              <a:rPr sz="2700" b="0">
+              <a:rPr sz="2400" b="0">
                 <a:solidFill>
                   <a:srgbClr val="172137"/>
                 </a:solidFill>
@@ -7372,7 +8013,7 @@
         </p:nvSpPr>
         <p:spPr>
           <a:xfrm xmlns:a="http://schemas.openxmlformats.org/drawingml/2006/main">
-            <a:off x="3248025" y="4667250"/>
+            <a:off x="3248025" y="5143500"/>
             <a:ext cx="7620000" cy="314325"/>
           </a:xfrm>
           <a:prstGeom xmlns:a="http://schemas.openxmlformats.org/drawingml/2006/main" prst="rect">
@@ -7390,6 +8031,7 @@
           <a:lstStyle xmlns:a="http://schemas.openxmlformats.org/drawingml/2006/main"/>
           <a:p xmlns:a="http://schemas.openxmlformats.org/drawingml/2006/main">
             <a:pPr>
+              <a:buNone/>
               <a:defRPr sz="1800" b="1">
                 <a:solidFill>
                   <a:srgbClr val="6044B6"/>
@@ -7429,8 +8071,8 @@
         </p:nvSpPr>
         <p:spPr>
           <a:xfrm xmlns:a="http://schemas.openxmlformats.org/drawingml/2006/main">
-            <a:off x="3219450" y="5105400"/>
-            <a:ext cx="8191500" cy="1047750"/>
+            <a:off x="3219450" y="5534025"/>
+            <a:ext cx="8191500" cy="800100"/>
           </a:xfrm>
           <a:prstGeom xmlns:a="http://schemas.openxmlformats.org/drawingml/2006/main" prst="rect">
             <a:avLst/>
@@ -7447,6 +8089,7 @@
           <a:lstStyle xmlns:a="http://schemas.openxmlformats.org/drawingml/2006/main"/>
           <a:p xmlns:a="http://schemas.openxmlformats.org/drawingml/2006/main">
             <a:pPr>
+              <a:buNone/>
               <a:defRPr sz="2550" b="0">
                 <a:solidFill>
                   <a:srgbClr val="172137"/>
@@ -7457,7 +8100,7 @@
               </a:defRPr>
             </a:pPr>
             <a:r>
-              <a:rPr sz="2550" b="0">
+              <a:rPr sz="2250" b="0">
                 <a:solidFill>
                   <a:srgbClr val="172137"/>
                 </a:solidFill>
@@ -7470,6 +8113,7 @@
           </a:p>
           <a:p xmlns:a="http://schemas.openxmlformats.org/drawingml/2006/main">
             <a:pPr>
+              <a:buNone/>
               <a:defRPr sz="2550" b="0">
                 <a:solidFill>
                   <a:srgbClr val="172137"/>
@@ -7480,7 +8124,7 @@
               </a:defRPr>
             </a:pPr>
             <a:r>
-              <a:rPr sz="2550" b="0">
+              <a:rPr sz="2250" b="0">
                 <a:solidFill>
                   <a:srgbClr val="172137"/>
                 </a:solidFill>
@@ -7489,6 +8133,109 @@
                 <a:cs typeface="Arial"/>
               </a:rPr>
               <a:t>y comprobar sus propuestas.</a:t>
+            </a:r>
+          </a:p>
+        </p:txBody>
+      </p:sp>
+      <p:sp>
+        <p:nvSpPr>
+          <p:cNvPr id="9" name="Module context">
+            <a:extLst xmlns:a="http://schemas.openxmlformats.org/drawingml/2006/main">
+              <a:ext uri="{FF2B5EF4-FFF2-40B4-BE49-F238E27FC236}">
+                <a16:creationId xmlns:a16="http://schemas.microsoft.com/office/drawing/2014/main" id="{69799330-5E82-4C8B-A956-2338C955AADC}"/>
+              </a:ext>
+            </a:extLst>
+          </p:cNvPr>
+          <p:cNvSpPr>
+            <a:spLocks xmlns:a="http://schemas.openxmlformats.org/drawingml/2006/main" noGrp="1"/>
+          </p:cNvSpPr>
+          <p:nvPr/>
+        </p:nvSpPr>
+        <p:spPr>
+          <a:xfrm xmlns:a="http://schemas.openxmlformats.org/drawingml/2006/main">
+            <a:off x="3219450" y="2390775"/>
+            <a:ext cx="8191500" cy="1028700"/>
+          </a:xfrm>
+          <a:prstGeom xmlns:a="http://schemas.openxmlformats.org/drawingml/2006/main" prst="rect">
+            <a:avLst/>
+          </a:prstGeom>
+          <a:noFill xmlns:a="http://schemas.openxmlformats.org/drawingml/2006/main"/>
+          <a:ln xmlns:a="http://schemas.openxmlformats.org/drawingml/2006/main" w="0">
+            <a:noFill/>
+          </a:ln>
+        </p:spPr>
+        <p:txBody>
+          <a:bodyPr xmlns:a="http://schemas.openxmlformats.org/drawingml/2006/main" wrap="square" lIns="0" tIns="0" rIns="0" bIns="0" anchor="t">
+            <a:noAutofit/>
+          </a:bodyPr>
+          <a:lstStyle xmlns:a="http://schemas.openxmlformats.org/drawingml/2006/main"/>
+          <a:p xmlns:a="http://schemas.openxmlformats.org/drawingml/2006/main">
+            <a:pPr>
+              <a:defRPr sz="2100">
+                <a:solidFill>
+                  <a:srgbClr val="45516A"/>
+                </a:solidFill>
+                <a:latin typeface="Arial"/>
+                <a:ea typeface="Arial"/>
+                <a:cs typeface="Arial"/>
+              </a:defRPr>
+            </a:pPr>
+            <a:r>
+              <a:rPr sz="2100">
+                <a:solidFill>
+                  <a:srgbClr val="45516A"/>
+                </a:solidFill>
+                <a:latin typeface="Arial"/>
+                <a:ea typeface="Arial"/>
+                <a:cs typeface="Arial"/>
+              </a:rPr>
+              <a:t>Copilot necesita conocer las reglas del proyecto.</a:t>
+            </a:r>
+          </a:p>
+          <a:p xmlns:a="http://schemas.openxmlformats.org/drawingml/2006/main">
+            <a:pPr>
+              <a:defRPr sz="2100">
+                <a:solidFill>
+                  <a:srgbClr val="45516A"/>
+                </a:solidFill>
+                <a:latin typeface="Arial"/>
+                <a:ea typeface="Arial"/>
+                <a:cs typeface="Arial"/>
+              </a:defRPr>
+            </a:pPr>
+            <a:r>
+              <a:rPr sz="2100">
+                <a:solidFill>
+                  <a:srgbClr val="45516A"/>
+                </a:solidFill>
+                <a:latin typeface="Arial"/>
+                <a:ea typeface="Arial"/>
+                <a:cs typeface="Arial"/>
+              </a:rPr>
+              <a:t>Ese contexto ayuda a proponer cambios que podamos</a:t>
+            </a:r>
+          </a:p>
+          <a:p xmlns:a="http://schemas.openxmlformats.org/drawingml/2006/main">
+            <a:pPr>
+              <a:defRPr sz="2100">
+                <a:solidFill>
+                  <a:srgbClr val="45516A"/>
+                </a:solidFill>
+                <a:latin typeface="Arial"/>
+                <a:ea typeface="Arial"/>
+                <a:cs typeface="Arial"/>
+              </a:defRPr>
+            </a:pPr>
+            <a:r>
+              <a:rPr sz="2100">
+                <a:solidFill>
+                  <a:srgbClr val="45516A"/>
+                </a:solidFill>
+                <a:latin typeface="Arial"/>
+                <a:ea typeface="Arial"/>
+                <a:cs typeface="Arial"/>
+              </a:rPr>
+              <a:t>revisar y comprobar.</a:t>
             </a:r>
           </a:p>
         </p:txBody>
@@ -7556,6 +8303,7 @@
           <a:lstStyle xmlns:a="http://schemas.openxmlformats.org/drawingml/2006/main"/>
           <a:p xmlns:a="http://schemas.openxmlformats.org/drawingml/2006/main">
             <a:pPr>
+              <a:buNone/>
               <a:defRPr sz="11550" b="1">
                 <a:solidFill>
                   <a:srgbClr val="C1B4E7"/>
@@ -7613,6 +8361,7 @@
           <a:lstStyle xmlns:a="http://schemas.openxmlformats.org/drawingml/2006/main"/>
           <a:p xmlns:a="http://schemas.openxmlformats.org/drawingml/2006/main">
             <a:pPr>
+              <a:buNone/>
               <a:defRPr sz="1875" b="0">
                 <a:solidFill>
                   <a:srgbClr val="45516A"/>
@@ -7636,6 +8385,7 @@
           </a:p>
           <a:p xmlns:a="http://schemas.openxmlformats.org/drawingml/2006/main">
             <a:pPr>
+              <a:buNone/>
               <a:defRPr sz="1875" b="0">
                 <a:solidFill>
                   <a:srgbClr val="45516A"/>
@@ -7693,6 +8443,7 @@
           <a:lstStyle xmlns:a="http://schemas.openxmlformats.org/drawingml/2006/main"/>
           <a:p xmlns:a="http://schemas.openxmlformats.org/drawingml/2006/main">
             <a:pPr>
+              <a:buNone/>
               <a:defRPr sz="4275" b="1">
                 <a:solidFill>
                   <a:srgbClr val="172137"/>
@@ -7716,6 +8467,7 @@
           </a:p>
           <a:p xmlns:a="http://schemas.openxmlformats.org/drawingml/2006/main">
             <a:pPr>
+              <a:buNone/>
               <a:defRPr sz="4275" b="1">
                 <a:solidFill>
                   <a:srgbClr val="172137"/>
@@ -7755,7 +8507,7 @@
         </p:nvSpPr>
         <p:spPr>
           <a:xfrm xmlns:a="http://schemas.openxmlformats.org/drawingml/2006/main">
-            <a:off x="3248025" y="2752725"/>
+            <a:off x="3248025" y="3619500"/>
             <a:ext cx="7620000" cy="314325"/>
           </a:xfrm>
           <a:prstGeom xmlns:a="http://schemas.openxmlformats.org/drawingml/2006/main" prst="rect">
@@ -7773,6 +8525,7 @@
           <a:lstStyle xmlns:a="http://schemas.openxmlformats.org/drawingml/2006/main"/>
           <a:p xmlns:a="http://schemas.openxmlformats.org/drawingml/2006/main">
             <a:pPr>
+              <a:buNone/>
               <a:defRPr sz="1800" b="1">
                 <a:solidFill>
                   <a:srgbClr val="6044B6"/>
@@ -7812,8 +8565,8 @@
         </p:nvSpPr>
         <p:spPr>
           <a:xfrm xmlns:a="http://schemas.openxmlformats.org/drawingml/2006/main">
-            <a:off x="3219450" y="3190875"/>
-            <a:ext cx="8191500" cy="1066800"/>
+            <a:off x="3219450" y="4010025"/>
+            <a:ext cx="8191500" cy="800100"/>
           </a:xfrm>
           <a:prstGeom xmlns:a="http://schemas.openxmlformats.org/drawingml/2006/main" prst="rect">
             <a:avLst/>
@@ -7830,6 +8583,7 @@
           <a:lstStyle xmlns:a="http://schemas.openxmlformats.org/drawingml/2006/main"/>
           <a:p xmlns:a="http://schemas.openxmlformats.org/drawingml/2006/main">
             <a:pPr>
+              <a:buNone/>
               <a:defRPr sz="2700" b="0">
                 <a:solidFill>
                   <a:srgbClr val="172137"/>
@@ -7840,7 +8594,7 @@
               </a:defRPr>
             </a:pPr>
             <a:r>
-              <a:rPr sz="2700" b="0">
+              <a:rPr sz="2400" b="0">
                 <a:solidFill>
                   <a:srgbClr val="172137"/>
                 </a:solidFill>
@@ -7853,6 +8607,7 @@
           </a:p>
           <a:p xmlns:a="http://schemas.openxmlformats.org/drawingml/2006/main">
             <a:pPr>
+              <a:buNone/>
               <a:defRPr sz="2700" b="0">
                 <a:solidFill>
                   <a:srgbClr val="172137"/>
@@ -7863,7 +8618,7 @@
               </a:defRPr>
             </a:pPr>
             <a:r>
-              <a:rPr sz="2700" b="0">
+              <a:rPr sz="2400" b="0">
                 <a:solidFill>
                   <a:srgbClr val="172137"/>
                 </a:solidFill>
@@ -7892,7 +8647,7 @@
         </p:nvSpPr>
         <p:spPr>
           <a:xfrm xmlns:a="http://schemas.openxmlformats.org/drawingml/2006/main">
-            <a:off x="3248025" y="4667250"/>
+            <a:off x="3248025" y="5143500"/>
             <a:ext cx="7620000" cy="314325"/>
           </a:xfrm>
           <a:prstGeom xmlns:a="http://schemas.openxmlformats.org/drawingml/2006/main" prst="rect">
@@ -7910,6 +8665,7 @@
           <a:lstStyle xmlns:a="http://schemas.openxmlformats.org/drawingml/2006/main"/>
           <a:p xmlns:a="http://schemas.openxmlformats.org/drawingml/2006/main">
             <a:pPr>
+              <a:buNone/>
               <a:defRPr sz="1800" b="1">
                 <a:solidFill>
                   <a:srgbClr val="6044B6"/>
@@ -7949,8 +8705,8 @@
         </p:nvSpPr>
         <p:spPr>
           <a:xfrm xmlns:a="http://schemas.openxmlformats.org/drawingml/2006/main">
-            <a:off x="3219450" y="5105400"/>
-            <a:ext cx="8191500" cy="1047750"/>
+            <a:off x="3219450" y="5534025"/>
+            <a:ext cx="8191500" cy="800100"/>
           </a:xfrm>
           <a:prstGeom xmlns:a="http://schemas.openxmlformats.org/drawingml/2006/main" prst="rect">
             <a:avLst/>
@@ -7967,6 +8723,7 @@
           <a:lstStyle xmlns:a="http://schemas.openxmlformats.org/drawingml/2006/main"/>
           <a:p xmlns:a="http://schemas.openxmlformats.org/drawingml/2006/main">
             <a:pPr>
+              <a:buNone/>
               <a:defRPr sz="2550" b="0">
                 <a:solidFill>
                   <a:srgbClr val="172137"/>
@@ -7977,7 +8734,7 @@
               </a:defRPr>
             </a:pPr>
             <a:r>
-              <a:rPr sz="2550" b="0">
+              <a:rPr sz="2250" b="0">
                 <a:solidFill>
                   <a:srgbClr val="172137"/>
                 </a:solidFill>
@@ -7990,6 +8747,7 @@
           </a:p>
           <a:p xmlns:a="http://schemas.openxmlformats.org/drawingml/2006/main">
             <a:pPr>
+              <a:buNone/>
               <a:defRPr sz="2550" b="0">
                 <a:solidFill>
                   <a:srgbClr val="172137"/>
@@ -8000,7 +8758,7 @@
               </a:defRPr>
             </a:pPr>
             <a:r>
-              <a:rPr sz="2550" b="0">
+              <a:rPr sz="2250" b="0">
                 <a:solidFill>
                   <a:srgbClr val="172137"/>
                 </a:solidFill>
@@ -8009,6 +8767,86 @@
                 <a:cs typeface="Arial"/>
               </a:rPr>
               <a:t>y organizar las dependencias.</a:t>
+            </a:r>
+          </a:p>
+        </p:txBody>
+      </p:sp>
+      <p:sp>
+        <p:nvSpPr>
+          <p:cNvPr id="9" name="Module context">
+            <a:extLst xmlns:a="http://schemas.openxmlformats.org/drawingml/2006/main">
+              <a:ext uri="{FF2B5EF4-FFF2-40B4-BE49-F238E27FC236}">
+                <a16:creationId xmlns:a16="http://schemas.microsoft.com/office/drawing/2014/main" id="{F702F046-4E20-4413-AB42-B8E79BD0EE4F}"/>
+              </a:ext>
+            </a:extLst>
+          </p:cNvPr>
+          <p:cNvSpPr>
+            <a:spLocks xmlns:a="http://schemas.openxmlformats.org/drawingml/2006/main" noGrp="1"/>
+          </p:cNvSpPr>
+          <p:nvPr/>
+        </p:nvSpPr>
+        <p:spPr>
+          <a:xfrm xmlns:a="http://schemas.openxmlformats.org/drawingml/2006/main">
+            <a:off x="3219450" y="2390775"/>
+            <a:ext cx="8191500" cy="1028700"/>
+          </a:xfrm>
+          <a:prstGeom xmlns:a="http://schemas.openxmlformats.org/drawingml/2006/main" prst="rect">
+            <a:avLst/>
+          </a:prstGeom>
+          <a:noFill xmlns:a="http://schemas.openxmlformats.org/drawingml/2006/main"/>
+          <a:ln xmlns:a="http://schemas.openxmlformats.org/drawingml/2006/main" w="0">
+            <a:noFill/>
+          </a:ln>
+        </p:spPr>
+        <p:txBody>
+          <a:bodyPr xmlns:a="http://schemas.openxmlformats.org/drawingml/2006/main" wrap="square" lIns="0" tIns="0" rIns="0" bIns="0" anchor="t">
+            <a:noAutofit/>
+          </a:bodyPr>
+          <a:lstStyle xmlns:a="http://schemas.openxmlformats.org/drawingml/2006/main"/>
+          <a:p xmlns:a="http://schemas.openxmlformats.org/drawingml/2006/main">
+            <a:pPr>
+              <a:defRPr sz="2100">
+                <a:solidFill>
+                  <a:srgbClr val="45516A"/>
+                </a:solidFill>
+                <a:latin typeface="Arial"/>
+                <a:ea typeface="Arial"/>
+                <a:cs typeface="Arial"/>
+              </a:defRPr>
+            </a:pPr>
+            <a:r>
+              <a:rPr sz="2100">
+                <a:solidFill>
+                  <a:srgbClr val="45516A"/>
+                </a:solidFill>
+                <a:latin typeface="Arial"/>
+                <a:ea typeface="Arial"/>
+                <a:cs typeface="Arial"/>
+              </a:rPr>
+              <a:t>Cada capa tiene una responsabilidad. Cambiar la base</a:t>
+            </a:r>
+          </a:p>
+          <a:p xmlns:a="http://schemas.openxmlformats.org/drawingml/2006/main">
+            <a:pPr>
+              <a:defRPr sz="2100">
+                <a:solidFill>
+                  <a:srgbClr val="45516A"/>
+                </a:solidFill>
+                <a:latin typeface="Arial"/>
+                <a:ea typeface="Arial"/>
+                <a:cs typeface="Arial"/>
+              </a:defRPr>
+            </a:pPr>
+            <a:r>
+              <a:rPr sz="2100">
+                <a:solidFill>
+                  <a:srgbClr val="45516A"/>
+                </a:solidFill>
+                <a:latin typeface="Arial"/>
+                <a:ea typeface="Arial"/>
+                <a:cs typeface="Arial"/>
+              </a:rPr>
+              <a:t>de datos no obliga a reescribir las reglas de pedidos.</a:t>
             </a:r>
           </a:p>
         </p:txBody>
@@ -8076,6 +8914,7 @@
           <a:lstStyle xmlns:a="http://schemas.openxmlformats.org/drawingml/2006/main"/>
           <a:p xmlns:a="http://schemas.openxmlformats.org/drawingml/2006/main">
             <a:pPr>
+              <a:buNone/>
               <a:defRPr sz="11550" b="1">
                 <a:solidFill>
                   <a:srgbClr val="C1B4E7"/>
@@ -8133,6 +8972,7 @@
           <a:lstStyle xmlns:a="http://schemas.openxmlformats.org/drawingml/2006/main"/>
           <a:p xmlns:a="http://schemas.openxmlformats.org/drawingml/2006/main">
             <a:pPr>
+              <a:buNone/>
               <a:defRPr sz="1875" b="0">
                 <a:solidFill>
                   <a:srgbClr val="45516A"/>
@@ -8156,6 +8996,7 @@
           </a:p>
           <a:p xmlns:a="http://schemas.openxmlformats.org/drawingml/2006/main">
             <a:pPr>
+              <a:buNone/>
               <a:defRPr sz="1875" b="0">
                 <a:solidFill>
                   <a:srgbClr val="45516A"/>
@@ -8213,6 +9054,7 @@
           <a:lstStyle xmlns:a="http://schemas.openxmlformats.org/drawingml/2006/main"/>
           <a:p xmlns:a="http://schemas.openxmlformats.org/drawingml/2006/main">
             <a:pPr>
+              <a:buNone/>
               <a:defRPr sz="4275" b="1">
                 <a:solidFill>
                   <a:srgbClr val="172137"/>
@@ -8236,6 +9078,7 @@
           </a:p>
           <a:p xmlns:a="http://schemas.openxmlformats.org/drawingml/2006/main">
             <a:pPr>
+              <a:buNone/>
               <a:defRPr sz="4275" b="1">
                 <a:solidFill>
                   <a:srgbClr val="172137"/>
@@ -8275,7 +9118,7 @@
         </p:nvSpPr>
         <p:spPr>
           <a:xfrm xmlns:a="http://schemas.openxmlformats.org/drawingml/2006/main">
-            <a:off x="3248025" y="2752725"/>
+            <a:off x="3248025" y="3619500"/>
             <a:ext cx="7620000" cy="314325"/>
           </a:xfrm>
           <a:prstGeom xmlns:a="http://schemas.openxmlformats.org/drawingml/2006/main" prst="rect">
@@ -8293,6 +9136,7 @@
           <a:lstStyle xmlns:a="http://schemas.openxmlformats.org/drawingml/2006/main"/>
           <a:p xmlns:a="http://schemas.openxmlformats.org/drawingml/2006/main">
             <a:pPr>
+              <a:buNone/>
               <a:defRPr sz="1800" b="1">
                 <a:solidFill>
                   <a:srgbClr val="6044B6"/>
@@ -8332,8 +9176,8 @@
         </p:nvSpPr>
         <p:spPr>
           <a:xfrm xmlns:a="http://schemas.openxmlformats.org/drawingml/2006/main">
-            <a:off x="3219450" y="3190875"/>
-            <a:ext cx="8191500" cy="1066800"/>
+            <a:off x="3219450" y="4010025"/>
+            <a:ext cx="8191500" cy="800100"/>
           </a:xfrm>
           <a:prstGeom xmlns:a="http://schemas.openxmlformats.org/drawingml/2006/main" prst="rect">
             <a:avLst/>
@@ -8350,6 +9194,7 @@
           <a:lstStyle xmlns:a="http://schemas.openxmlformats.org/drawingml/2006/main"/>
           <a:p xmlns:a="http://schemas.openxmlformats.org/drawingml/2006/main">
             <a:pPr>
+              <a:buNone/>
               <a:defRPr sz="2700" b="0">
                 <a:solidFill>
                   <a:srgbClr val="172137"/>
@@ -8360,7 +9205,7 @@
               </a:defRPr>
             </a:pPr>
             <a:r>
-              <a:rPr sz="2700" b="0">
+              <a:rPr sz="2400" b="0">
                 <a:solidFill>
                   <a:srgbClr val="172137"/>
                 </a:solidFill>
@@ -8373,6 +9218,7 @@
           </a:p>
           <a:p xmlns:a="http://schemas.openxmlformats.org/drawingml/2006/main">
             <a:pPr>
+              <a:buNone/>
               <a:defRPr sz="2700" b="0">
                 <a:solidFill>
                   <a:srgbClr val="172137"/>
@@ -8383,7 +9229,7 @@
               </a:defRPr>
             </a:pPr>
             <a:r>
-              <a:rPr sz="2700" b="0">
+              <a:rPr sz="2400" b="0">
                 <a:solidFill>
                   <a:srgbClr val="172137"/>
                 </a:solidFill>
@@ -8412,7 +9258,7 @@
         </p:nvSpPr>
         <p:spPr>
           <a:xfrm xmlns:a="http://schemas.openxmlformats.org/drawingml/2006/main">
-            <a:off x="3248025" y="4667250"/>
+            <a:off x="3248025" y="5143500"/>
             <a:ext cx="7620000" cy="314325"/>
           </a:xfrm>
           <a:prstGeom xmlns:a="http://schemas.openxmlformats.org/drawingml/2006/main" prst="rect">
@@ -8430,6 +9276,7 @@
           <a:lstStyle xmlns:a="http://schemas.openxmlformats.org/drawingml/2006/main"/>
           <a:p xmlns:a="http://schemas.openxmlformats.org/drawingml/2006/main">
             <a:pPr>
+              <a:buNone/>
               <a:defRPr sz="1800" b="1">
                 <a:solidFill>
                   <a:srgbClr val="6044B6"/>
@@ -8469,8 +9316,8 @@
         </p:nvSpPr>
         <p:spPr>
           <a:xfrm xmlns:a="http://schemas.openxmlformats.org/drawingml/2006/main">
-            <a:off x="3219450" y="5105400"/>
-            <a:ext cx="8191500" cy="1047750"/>
+            <a:off x="3219450" y="5534025"/>
+            <a:ext cx="8191500" cy="800100"/>
           </a:xfrm>
           <a:prstGeom xmlns:a="http://schemas.openxmlformats.org/drawingml/2006/main" prst="rect">
             <a:avLst/>
@@ -8487,6 +9334,7 @@
           <a:lstStyle xmlns:a="http://schemas.openxmlformats.org/drawingml/2006/main"/>
           <a:p xmlns:a="http://schemas.openxmlformats.org/drawingml/2006/main">
             <a:pPr>
+              <a:buNone/>
               <a:defRPr sz="2550" b="0">
                 <a:solidFill>
                   <a:srgbClr val="172137"/>
@@ -8497,7 +9345,7 @@
               </a:defRPr>
             </a:pPr>
             <a:r>
-              <a:rPr sz="2550" b="0">
+              <a:rPr sz="2250" b="0">
                 <a:solidFill>
                   <a:srgbClr val="172137"/>
                 </a:solidFill>
@@ -8510,6 +9358,7 @@
           </a:p>
           <a:p xmlns:a="http://schemas.openxmlformats.org/drawingml/2006/main">
             <a:pPr>
+              <a:buNone/>
               <a:defRPr sz="2550" b="0">
                 <a:solidFill>
                   <a:srgbClr val="172137"/>
@@ -8520,7 +9369,7 @@
               </a:defRPr>
             </a:pPr>
             <a:r>
-              <a:rPr sz="2550" b="0">
+              <a:rPr sz="2250" b="0">
                 <a:solidFill>
                   <a:srgbClr val="172137"/>
                 </a:solidFill>
@@ -8529,6 +9378,109 @@
                 <a:cs typeface="Arial"/>
               </a:rPr>
               <a:t>con IRepository&lt;T&gt;.</a:t>
+            </a:r>
+          </a:p>
+        </p:txBody>
+      </p:sp>
+      <p:sp>
+        <p:nvSpPr>
+          <p:cNvPr id="9" name="Module context">
+            <a:extLst xmlns:a="http://schemas.openxmlformats.org/drawingml/2006/main">
+              <a:ext uri="{FF2B5EF4-FFF2-40B4-BE49-F238E27FC236}">
+                <a16:creationId xmlns:a16="http://schemas.microsoft.com/office/drawing/2014/main" id="{9B268182-1117-4128-B1FD-AA3C8606662B}"/>
+              </a:ext>
+            </a:extLst>
+          </p:cNvPr>
+          <p:cNvSpPr>
+            <a:spLocks xmlns:a="http://schemas.openxmlformats.org/drawingml/2006/main" noGrp="1"/>
+          </p:cNvSpPr>
+          <p:nvPr/>
+        </p:nvSpPr>
+        <p:spPr>
+          <a:xfrm xmlns:a="http://schemas.openxmlformats.org/drawingml/2006/main">
+            <a:off x="3219450" y="2390775"/>
+            <a:ext cx="8191500" cy="1028700"/>
+          </a:xfrm>
+          <a:prstGeom xmlns:a="http://schemas.openxmlformats.org/drawingml/2006/main" prst="rect">
+            <a:avLst/>
+          </a:prstGeom>
+          <a:noFill xmlns:a="http://schemas.openxmlformats.org/drawingml/2006/main"/>
+          <a:ln xmlns:a="http://schemas.openxmlformats.org/drawingml/2006/main" w="0">
+            <a:noFill/>
+          </a:ln>
+        </p:spPr>
+        <p:txBody>
+          <a:bodyPr xmlns:a="http://schemas.openxmlformats.org/drawingml/2006/main" wrap="square" lIns="0" tIns="0" rIns="0" bIns="0" anchor="t">
+            <a:noAutofit/>
+          </a:bodyPr>
+          <a:lstStyle xmlns:a="http://schemas.openxmlformats.org/drawingml/2006/main"/>
+          <a:p xmlns:a="http://schemas.openxmlformats.org/drawingml/2006/main">
+            <a:pPr>
+              <a:defRPr sz="2100">
+                <a:solidFill>
+                  <a:srgbClr val="45516A"/>
+                </a:solidFill>
+                <a:latin typeface="Arial"/>
+                <a:ea typeface="Arial"/>
+                <a:cs typeface="Arial"/>
+              </a:defRPr>
+            </a:pPr>
+            <a:r>
+              <a:rPr sz="2100">
+                <a:solidFill>
+                  <a:srgbClr val="45516A"/>
+                </a:solidFill>
+                <a:latin typeface="Arial"/>
+                <a:ea typeface="Arial"/>
+                <a:cs typeface="Arial"/>
+              </a:rPr>
+              <a:t>Los patrones resuelven problemas frecuentes.</a:t>
+            </a:r>
+          </a:p>
+          <a:p xmlns:a="http://schemas.openxmlformats.org/drawingml/2006/main">
+            <a:pPr>
+              <a:defRPr sz="2100">
+                <a:solidFill>
+                  <a:srgbClr val="45516A"/>
+                </a:solidFill>
+                <a:latin typeface="Arial"/>
+                <a:ea typeface="Arial"/>
+                <a:cs typeface="Arial"/>
+              </a:defRPr>
+            </a:pPr>
+            <a:r>
+              <a:rPr sz="2100">
+                <a:solidFill>
+                  <a:srgbClr val="45516A"/>
+                </a:solidFill>
+                <a:latin typeface="Arial"/>
+                <a:ea typeface="Arial"/>
+                <a:cs typeface="Arial"/>
+              </a:rPr>
+              <a:t>Un repositorio permite trabajar con productos y pedidos</a:t>
+            </a:r>
+          </a:p>
+          <a:p xmlns:a="http://schemas.openxmlformats.org/drawingml/2006/main">
+            <a:pPr>
+              <a:defRPr sz="2100">
+                <a:solidFill>
+                  <a:srgbClr val="45516A"/>
+                </a:solidFill>
+                <a:latin typeface="Arial"/>
+                <a:ea typeface="Arial"/>
+                <a:cs typeface="Arial"/>
+              </a:defRPr>
+            </a:pPr>
+            <a:r>
+              <a:rPr sz="2100">
+                <a:solidFill>
+                  <a:srgbClr val="45516A"/>
+                </a:solidFill>
+                <a:latin typeface="Arial"/>
+                <a:ea typeface="Arial"/>
+                <a:cs typeface="Arial"/>
+              </a:rPr>
+              <a:t>sin depender de cómo se guardan.</a:t>
             </a:r>
           </a:p>
         </p:txBody>
@@ -8596,6 +9548,7 @@
           <a:lstStyle xmlns:a="http://schemas.openxmlformats.org/drawingml/2006/main"/>
           <a:p xmlns:a="http://schemas.openxmlformats.org/drawingml/2006/main">
             <a:pPr>
+              <a:buNone/>
               <a:defRPr sz="11550" b="1">
                 <a:solidFill>
                   <a:srgbClr val="C1B4E7"/>
@@ -8653,6 +9606,7 @@
           <a:lstStyle xmlns:a="http://schemas.openxmlformats.org/drawingml/2006/main"/>
           <a:p xmlns:a="http://schemas.openxmlformats.org/drawingml/2006/main">
             <a:pPr>
+              <a:buNone/>
               <a:defRPr sz="1875" b="0">
                 <a:solidFill>
                   <a:srgbClr val="45516A"/>
@@ -8676,6 +9630,7 @@
           </a:p>
           <a:p xmlns:a="http://schemas.openxmlformats.org/drawingml/2006/main">
             <a:pPr>
+              <a:buNone/>
               <a:defRPr sz="1875" b="0">
                 <a:solidFill>
                   <a:srgbClr val="45516A"/>
@@ -8733,6 +9688,7 @@
           <a:lstStyle xmlns:a="http://schemas.openxmlformats.org/drawingml/2006/main"/>
           <a:p xmlns:a="http://schemas.openxmlformats.org/drawingml/2006/main">
             <a:pPr>
+              <a:buNone/>
               <a:defRPr sz="4275" b="1">
                 <a:solidFill>
                   <a:srgbClr val="172137"/>
@@ -8772,7 +9728,7 @@
         </p:nvSpPr>
         <p:spPr>
           <a:xfrm xmlns:a="http://schemas.openxmlformats.org/drawingml/2006/main">
-            <a:off x="3248025" y="2752725"/>
+            <a:off x="3248025" y="3619500"/>
             <a:ext cx="7620000" cy="314325"/>
           </a:xfrm>
           <a:prstGeom xmlns:a="http://schemas.openxmlformats.org/drawingml/2006/main" prst="rect">
@@ -8790,6 +9746,7 @@
           <a:lstStyle xmlns:a="http://schemas.openxmlformats.org/drawingml/2006/main"/>
           <a:p xmlns:a="http://schemas.openxmlformats.org/drawingml/2006/main">
             <a:pPr>
+              <a:buNone/>
               <a:defRPr sz="1800" b="1">
                 <a:solidFill>
                   <a:srgbClr val="6044B6"/>
@@ -8829,8 +9786,8 @@
         </p:nvSpPr>
         <p:spPr>
           <a:xfrm xmlns:a="http://schemas.openxmlformats.org/drawingml/2006/main">
-            <a:off x="3219450" y="3190875"/>
-            <a:ext cx="8191500" cy="1066800"/>
+            <a:off x="3219450" y="4010025"/>
+            <a:ext cx="8191500" cy="800100"/>
           </a:xfrm>
           <a:prstGeom xmlns:a="http://schemas.openxmlformats.org/drawingml/2006/main" prst="rect">
             <a:avLst/>
@@ -8847,6 +9804,7 @@
           <a:lstStyle xmlns:a="http://schemas.openxmlformats.org/drawingml/2006/main"/>
           <a:p xmlns:a="http://schemas.openxmlformats.org/drawingml/2006/main">
             <a:pPr>
+              <a:buNone/>
               <a:defRPr sz="2700" b="0">
                 <a:solidFill>
                   <a:srgbClr val="172137"/>
@@ -8857,7 +9815,7 @@
               </a:defRPr>
             </a:pPr>
             <a:r>
-              <a:rPr sz="2700" b="0">
+              <a:rPr sz="2400" b="0">
                 <a:solidFill>
                   <a:srgbClr val="172137"/>
                 </a:solidFill>
@@ -8870,6 +9828,7 @@
           </a:p>
           <a:p xmlns:a="http://schemas.openxmlformats.org/drawingml/2006/main">
             <a:pPr>
+              <a:buNone/>
               <a:defRPr sz="2700" b="0">
                 <a:solidFill>
                   <a:srgbClr val="172137"/>
@@ -8880,7 +9839,7 @@
               </a:defRPr>
             </a:pPr>
             <a:r>
-              <a:rPr sz="2700" b="0">
+              <a:rPr sz="2400" b="0">
                 <a:solidFill>
                   <a:srgbClr val="172137"/>
                 </a:solidFill>
@@ -8909,7 +9868,7 @@
         </p:nvSpPr>
         <p:spPr>
           <a:xfrm xmlns:a="http://schemas.openxmlformats.org/drawingml/2006/main">
-            <a:off x="3248025" y="4667250"/>
+            <a:off x="3248025" y="5143500"/>
             <a:ext cx="7620000" cy="314325"/>
           </a:xfrm>
           <a:prstGeom xmlns:a="http://schemas.openxmlformats.org/drawingml/2006/main" prst="rect">
@@ -8927,6 +9886,7 @@
           <a:lstStyle xmlns:a="http://schemas.openxmlformats.org/drawingml/2006/main"/>
           <a:p xmlns:a="http://schemas.openxmlformats.org/drawingml/2006/main">
             <a:pPr>
+              <a:buNone/>
               <a:defRPr sz="1800" b="1">
                 <a:solidFill>
                   <a:srgbClr val="6044B6"/>
@@ -8966,8 +9926,8 @@
         </p:nvSpPr>
         <p:spPr>
           <a:xfrm xmlns:a="http://schemas.openxmlformats.org/drawingml/2006/main">
-            <a:off x="3219450" y="5105400"/>
-            <a:ext cx="8191500" cy="1047750"/>
+            <a:off x="3219450" y="5534025"/>
+            <a:ext cx="8191500" cy="800100"/>
           </a:xfrm>
           <a:prstGeom xmlns:a="http://schemas.openxmlformats.org/drawingml/2006/main" prst="rect">
             <a:avLst/>
@@ -8984,6 +9944,7 @@
           <a:lstStyle xmlns:a="http://schemas.openxmlformats.org/drawingml/2006/main"/>
           <a:p xmlns:a="http://schemas.openxmlformats.org/drawingml/2006/main">
             <a:pPr>
+              <a:buNone/>
               <a:defRPr sz="2550" b="0">
                 <a:solidFill>
                   <a:srgbClr val="172137"/>
@@ -8994,7 +9955,7 @@
               </a:defRPr>
             </a:pPr>
             <a:r>
-              <a:rPr sz="2550" b="0">
+              <a:rPr sz="2250" b="0">
                 <a:solidFill>
                   <a:srgbClr val="172137"/>
                 </a:solidFill>
@@ -9007,6 +9968,7 @@
           </a:p>
           <a:p xmlns:a="http://schemas.openxmlformats.org/drawingml/2006/main">
             <a:pPr>
+              <a:buNone/>
               <a:defRPr sz="2550" b="0">
                 <a:solidFill>
                   <a:srgbClr val="172137"/>
@@ -9017,7 +9979,7 @@
               </a:defRPr>
             </a:pPr>
             <a:r>
-              <a:rPr sz="2550" b="0">
+              <a:rPr sz="2250" b="0">
                 <a:solidFill>
                   <a:srgbClr val="172137"/>
                 </a:solidFill>
@@ -9026,6 +9988,109 @@
                 <a:cs typeface="Arial"/>
               </a:rPr>
               <a:t>y documentar errores con OpenAPI.</a:t>
+            </a:r>
+          </a:p>
+        </p:txBody>
+      </p:sp>
+      <p:sp>
+        <p:nvSpPr>
+          <p:cNvPr id="9" name="Module context">
+            <a:extLst xmlns:a="http://schemas.openxmlformats.org/drawingml/2006/main">
+              <a:ext uri="{FF2B5EF4-FFF2-40B4-BE49-F238E27FC236}">
+                <a16:creationId xmlns:a16="http://schemas.microsoft.com/office/drawing/2014/main" id="{320223D1-B857-4632-B2C3-62984DA30488}"/>
+              </a:ext>
+            </a:extLst>
+          </p:cNvPr>
+          <p:cNvSpPr>
+            <a:spLocks xmlns:a="http://schemas.openxmlformats.org/drawingml/2006/main" noGrp="1"/>
+          </p:cNvSpPr>
+          <p:nvPr/>
+        </p:nvSpPr>
+        <p:spPr>
+          <a:xfrm xmlns:a="http://schemas.openxmlformats.org/drawingml/2006/main">
+            <a:off x="3219450" y="2390775"/>
+            <a:ext cx="8191500" cy="1028700"/>
+          </a:xfrm>
+          <a:prstGeom xmlns:a="http://schemas.openxmlformats.org/drawingml/2006/main" prst="rect">
+            <a:avLst/>
+          </a:prstGeom>
+          <a:noFill xmlns:a="http://schemas.openxmlformats.org/drawingml/2006/main"/>
+          <a:ln xmlns:a="http://schemas.openxmlformats.org/drawingml/2006/main" w="0">
+            <a:noFill/>
+          </a:ln>
+        </p:spPr>
+        <p:txBody>
+          <a:bodyPr xmlns:a="http://schemas.openxmlformats.org/drawingml/2006/main" wrap="square" lIns="0" tIns="0" rIns="0" bIns="0" anchor="t">
+            <a:noAutofit/>
+          </a:bodyPr>
+          <a:lstStyle xmlns:a="http://schemas.openxmlformats.org/drawingml/2006/main"/>
+          <a:p xmlns:a="http://schemas.openxmlformats.org/drawingml/2006/main">
+            <a:pPr>
+              <a:defRPr sz="2100">
+                <a:solidFill>
+                  <a:srgbClr val="45516A"/>
+                </a:solidFill>
+                <a:latin typeface="Arial"/>
+                <a:ea typeface="Arial"/>
+                <a:cs typeface="Arial"/>
+              </a:defRPr>
+            </a:pPr>
+            <a:r>
+              <a:rPr sz="2100">
+                <a:solidFill>
+                  <a:srgbClr val="45516A"/>
+                </a:solidFill>
+                <a:latin typeface="Arial"/>
+                <a:ea typeface="Arial"/>
+                <a:cs typeface="Arial"/>
+              </a:rPr>
+              <a:t>La API es la puerta de entrada de la aplicación.</a:t>
+            </a:r>
+          </a:p>
+          <a:p xmlns:a="http://schemas.openxmlformats.org/drawingml/2006/main">
+            <a:pPr>
+              <a:defRPr sz="2100">
+                <a:solidFill>
+                  <a:srgbClr val="45516A"/>
+                </a:solidFill>
+                <a:latin typeface="Arial"/>
+                <a:ea typeface="Arial"/>
+                <a:cs typeface="Arial"/>
+              </a:defRPr>
+            </a:pPr>
+            <a:r>
+              <a:rPr sz="2100">
+                <a:solidFill>
+                  <a:srgbClr val="45516A"/>
+                </a:solidFill>
+                <a:latin typeface="Arial"/>
+                <a:ea typeface="Arial"/>
+                <a:cs typeface="Arial"/>
+              </a:rPr>
+              <a:t>Define qué pueden solicitar otros sistemas y cómo</a:t>
+            </a:r>
+          </a:p>
+          <a:p xmlns:a="http://schemas.openxmlformats.org/drawingml/2006/main">
+            <a:pPr>
+              <a:defRPr sz="2100">
+                <a:solidFill>
+                  <a:srgbClr val="45516A"/>
+                </a:solidFill>
+                <a:latin typeface="Arial"/>
+                <a:ea typeface="Arial"/>
+                <a:cs typeface="Arial"/>
+              </a:defRPr>
+            </a:pPr>
+            <a:r>
+              <a:rPr sz="2100">
+                <a:solidFill>
+                  <a:srgbClr val="45516A"/>
+                </a:solidFill>
+                <a:latin typeface="Arial"/>
+                <a:ea typeface="Arial"/>
+                <a:cs typeface="Arial"/>
+              </a:rPr>
+              <a:t>recibirán resultados o errores.</a:t>
             </a:r>
           </a:p>
         </p:txBody>
@@ -9093,6 +10158,7 @@
           <a:lstStyle xmlns:a="http://schemas.openxmlformats.org/drawingml/2006/main"/>
           <a:p xmlns:a="http://schemas.openxmlformats.org/drawingml/2006/main">
             <a:pPr>
+              <a:buNone/>
               <a:defRPr sz="11550" b="1">
                 <a:solidFill>
                   <a:srgbClr val="C1B4E7"/>
@@ -9150,6 +10216,7 @@
           <a:lstStyle xmlns:a="http://schemas.openxmlformats.org/drawingml/2006/main"/>
           <a:p xmlns:a="http://schemas.openxmlformats.org/drawingml/2006/main">
             <a:pPr>
+              <a:buNone/>
               <a:defRPr sz="1875" b="0">
                 <a:solidFill>
                   <a:srgbClr val="45516A"/>
@@ -9173,6 +10240,7 @@
           </a:p>
           <a:p xmlns:a="http://schemas.openxmlformats.org/drawingml/2006/main">
             <a:pPr>
+              <a:buNone/>
               <a:defRPr sz="1875" b="0">
                 <a:solidFill>
                   <a:srgbClr val="45516A"/>
@@ -9230,6 +10298,7 @@
           <a:lstStyle xmlns:a="http://schemas.openxmlformats.org/drawingml/2006/main"/>
           <a:p xmlns:a="http://schemas.openxmlformats.org/drawingml/2006/main">
             <a:pPr>
+              <a:buNone/>
               <a:defRPr sz="4275" b="1">
                 <a:solidFill>
                   <a:srgbClr val="172137"/>
@@ -9269,7 +10338,7 @@
         </p:nvSpPr>
         <p:spPr>
           <a:xfrm xmlns:a="http://schemas.openxmlformats.org/drawingml/2006/main">
-            <a:off x="3248025" y="2752725"/>
+            <a:off x="3248025" y="3619500"/>
             <a:ext cx="7620000" cy="314325"/>
           </a:xfrm>
           <a:prstGeom xmlns:a="http://schemas.openxmlformats.org/drawingml/2006/main" prst="rect">
@@ -9287,6 +10356,7 @@
           <a:lstStyle xmlns:a="http://schemas.openxmlformats.org/drawingml/2006/main"/>
           <a:p xmlns:a="http://schemas.openxmlformats.org/drawingml/2006/main">
             <a:pPr>
+              <a:buNone/>
               <a:defRPr sz="1800" b="1">
                 <a:solidFill>
                   <a:srgbClr val="6044B6"/>
@@ -9326,8 +10396,8 @@
         </p:nvSpPr>
         <p:spPr>
           <a:xfrm xmlns:a="http://schemas.openxmlformats.org/drawingml/2006/main">
-            <a:off x="3219450" y="3190875"/>
-            <a:ext cx="8191500" cy="1066800"/>
+            <a:off x="3219450" y="4010025"/>
+            <a:ext cx="8191500" cy="800100"/>
           </a:xfrm>
           <a:prstGeom xmlns:a="http://schemas.openxmlformats.org/drawingml/2006/main" prst="rect">
             <a:avLst/>
@@ -9344,6 +10414,7 @@
           <a:lstStyle xmlns:a="http://schemas.openxmlformats.org/drawingml/2006/main"/>
           <a:p xmlns:a="http://schemas.openxmlformats.org/drawingml/2006/main">
             <a:pPr>
+              <a:buNone/>
               <a:defRPr sz="2700" b="0">
                 <a:solidFill>
                   <a:srgbClr val="172137"/>
@@ -9354,7 +10425,7 @@
               </a:defRPr>
             </a:pPr>
             <a:r>
-              <a:rPr sz="2700" b="0">
+              <a:rPr sz="2400" b="0">
                 <a:solidFill>
                   <a:srgbClr val="172137"/>
                 </a:solidFill>
@@ -9367,6 +10438,7 @@
           </a:p>
           <a:p xmlns:a="http://schemas.openxmlformats.org/drawingml/2006/main">
             <a:pPr>
+              <a:buNone/>
               <a:defRPr sz="2700" b="0">
                 <a:solidFill>
                   <a:srgbClr val="172137"/>
@@ -9377,7 +10449,7 @@
               </a:defRPr>
             </a:pPr>
             <a:r>
-              <a:rPr sz="2700" b="0">
+              <a:rPr sz="2400" b="0">
                 <a:solidFill>
                   <a:srgbClr val="172137"/>
                 </a:solidFill>
@@ -9406,7 +10478,7 @@
         </p:nvSpPr>
         <p:spPr>
           <a:xfrm xmlns:a="http://schemas.openxmlformats.org/drawingml/2006/main">
-            <a:off x="3248025" y="4667250"/>
+            <a:off x="3248025" y="5143500"/>
             <a:ext cx="7620000" cy="314325"/>
           </a:xfrm>
           <a:prstGeom xmlns:a="http://schemas.openxmlformats.org/drawingml/2006/main" prst="rect">
@@ -9424,6 +10496,7 @@
           <a:lstStyle xmlns:a="http://schemas.openxmlformats.org/drawingml/2006/main"/>
           <a:p xmlns:a="http://schemas.openxmlformats.org/drawingml/2006/main">
             <a:pPr>
+              <a:buNone/>
               <a:defRPr sz="1800" b="1">
                 <a:solidFill>
                   <a:srgbClr val="6044B6"/>
@@ -9463,8 +10536,8 @@
         </p:nvSpPr>
         <p:spPr>
           <a:xfrm xmlns:a="http://schemas.openxmlformats.org/drawingml/2006/main">
-            <a:off x="3219450" y="5105400"/>
-            <a:ext cx="8191500" cy="1047750"/>
+            <a:off x="3219450" y="5534025"/>
+            <a:ext cx="8191500" cy="800100"/>
           </a:xfrm>
           <a:prstGeom xmlns:a="http://schemas.openxmlformats.org/drawingml/2006/main" prst="rect">
             <a:avLst/>
@@ -9481,6 +10554,7 @@
           <a:lstStyle xmlns:a="http://schemas.openxmlformats.org/drawingml/2006/main"/>
           <a:p xmlns:a="http://schemas.openxmlformats.org/drawingml/2006/main">
             <a:pPr>
+              <a:buNone/>
               <a:defRPr sz="2550" b="0">
                 <a:solidFill>
                   <a:srgbClr val="172137"/>
@@ -9491,7 +10565,7 @@
               </a:defRPr>
             </a:pPr>
             <a:r>
-              <a:rPr sz="2550" b="0">
+              <a:rPr sz="2250" b="0">
                 <a:solidFill>
                   <a:srgbClr val="172137"/>
                 </a:solidFill>
@@ -9504,6 +10578,7 @@
           </a:p>
           <a:p xmlns:a="http://schemas.openxmlformats.org/drawingml/2006/main">
             <a:pPr>
+              <a:buNone/>
               <a:defRPr sz="2550" b="0">
                 <a:solidFill>
                   <a:srgbClr val="172137"/>
@@ -9514,7 +10589,7 @@
               </a:defRPr>
             </a:pPr>
             <a:r>
-              <a:rPr sz="2550" b="0">
+              <a:rPr sz="2250" b="0">
                 <a:solidFill>
                   <a:srgbClr val="172137"/>
                 </a:solidFill>
@@ -9523,6 +10598,109 @@
                 <a:cs typeface="Arial"/>
               </a:rPr>
               <a:t>y registrar cambios.</a:t>
+            </a:r>
+          </a:p>
+        </p:txBody>
+      </p:sp>
+      <p:sp>
+        <p:nvSpPr>
+          <p:cNvPr id="9" name="Module context">
+            <a:extLst xmlns:a="http://schemas.openxmlformats.org/drawingml/2006/main">
+              <a:ext uri="{FF2B5EF4-FFF2-40B4-BE49-F238E27FC236}">
+                <a16:creationId xmlns:a16="http://schemas.microsoft.com/office/drawing/2014/main" id="{C7C1FA40-2050-4A2B-BAC7-A2513D23DE77}"/>
+              </a:ext>
+            </a:extLst>
+          </p:cNvPr>
+          <p:cNvSpPr>
+            <a:spLocks xmlns:a="http://schemas.openxmlformats.org/drawingml/2006/main" noGrp="1"/>
+          </p:cNvSpPr>
+          <p:nvPr/>
+        </p:nvSpPr>
+        <p:spPr>
+          <a:xfrm xmlns:a="http://schemas.openxmlformats.org/drawingml/2006/main">
+            <a:off x="3219450" y="2390775"/>
+            <a:ext cx="8191500" cy="1028700"/>
+          </a:xfrm>
+          <a:prstGeom xmlns:a="http://schemas.openxmlformats.org/drawingml/2006/main" prst="rect">
+            <a:avLst/>
+          </a:prstGeom>
+          <a:noFill xmlns:a="http://schemas.openxmlformats.org/drawingml/2006/main"/>
+          <a:ln xmlns:a="http://schemas.openxmlformats.org/drawingml/2006/main" w="0">
+            <a:noFill/>
+          </a:ln>
+        </p:spPr>
+        <p:txBody>
+          <a:bodyPr xmlns:a="http://schemas.openxmlformats.org/drawingml/2006/main" wrap="square" lIns="0" tIns="0" rIns="0" bIns="0" anchor="t">
+            <a:noAutofit/>
+          </a:bodyPr>
+          <a:lstStyle xmlns:a="http://schemas.openxmlformats.org/drawingml/2006/main"/>
+          <a:p xmlns:a="http://schemas.openxmlformats.org/drawingml/2006/main">
+            <a:pPr>
+              <a:defRPr sz="2100">
+                <a:solidFill>
+                  <a:srgbClr val="45516A"/>
+                </a:solidFill>
+                <a:latin typeface="Arial"/>
+                <a:ea typeface="Arial"/>
+                <a:cs typeface="Arial"/>
+              </a:defRPr>
+            </a:pPr>
+            <a:r>
+              <a:rPr sz="2100">
+                <a:solidFill>
+                  <a:srgbClr val="45516A"/>
+                </a:solidFill>
+                <a:latin typeface="Arial"/>
+                <a:ea typeface="Arial"/>
+                <a:cs typeface="Arial"/>
+              </a:rPr>
+              <a:t>EF Core conecta el código con la base de datos.</a:t>
+            </a:r>
+          </a:p>
+          <a:p xmlns:a="http://schemas.openxmlformats.org/drawingml/2006/main">
+            <a:pPr>
+              <a:defRPr sz="2100">
+                <a:solidFill>
+                  <a:srgbClr val="45516A"/>
+                </a:solidFill>
+                <a:latin typeface="Arial"/>
+                <a:ea typeface="Arial"/>
+                <a:cs typeface="Arial"/>
+              </a:defRPr>
+            </a:pPr>
+            <a:r>
+              <a:rPr sz="2100">
+                <a:solidFill>
+                  <a:srgbClr val="45516A"/>
+                </a:solidFill>
+                <a:latin typeface="Arial"/>
+                <a:ea typeface="Arial"/>
+                <a:cs typeface="Arial"/>
+              </a:rPr>
+              <a:t>Las migraciones permiten cambiar su estructura</a:t>
+            </a:r>
+          </a:p>
+          <a:p xmlns:a="http://schemas.openxmlformats.org/drawingml/2006/main">
+            <a:pPr>
+              <a:defRPr sz="2100">
+                <a:solidFill>
+                  <a:srgbClr val="45516A"/>
+                </a:solidFill>
+                <a:latin typeface="Arial"/>
+                <a:ea typeface="Arial"/>
+                <a:cs typeface="Arial"/>
+              </a:defRPr>
+            </a:pPr>
+            <a:r>
+              <a:rPr sz="2100">
+                <a:solidFill>
+                  <a:srgbClr val="45516A"/>
+                </a:solidFill>
+                <a:latin typeface="Arial"/>
+                <a:ea typeface="Arial"/>
+                <a:cs typeface="Arial"/>
+              </a:rPr>
+              <a:t>de forma controlada.</a:t>
             </a:r>
           </a:p>
         </p:txBody>
@@ -9590,6 +10768,7 @@
           <a:lstStyle xmlns:a="http://schemas.openxmlformats.org/drawingml/2006/main"/>
           <a:p xmlns:a="http://schemas.openxmlformats.org/drawingml/2006/main">
             <a:pPr>
+              <a:buNone/>
               <a:defRPr sz="11550" b="1">
                 <a:solidFill>
                   <a:srgbClr val="C1B4E7"/>
@@ -9647,6 +10826,7 @@
           <a:lstStyle xmlns:a="http://schemas.openxmlformats.org/drawingml/2006/main"/>
           <a:p xmlns:a="http://schemas.openxmlformats.org/drawingml/2006/main">
             <a:pPr>
+              <a:buNone/>
               <a:defRPr sz="1875" b="0">
                 <a:solidFill>
                   <a:srgbClr val="45516A"/>
@@ -9670,6 +10850,7 @@
           </a:p>
           <a:p xmlns:a="http://schemas.openxmlformats.org/drawingml/2006/main">
             <a:pPr>
+              <a:buNone/>
               <a:defRPr sz="1875" b="0">
                 <a:solidFill>
                   <a:srgbClr val="45516A"/>
@@ -9727,6 +10908,7 @@
           <a:lstStyle xmlns:a="http://schemas.openxmlformats.org/drawingml/2006/main"/>
           <a:p xmlns:a="http://schemas.openxmlformats.org/drawingml/2006/main">
             <a:pPr>
+              <a:buNone/>
               <a:defRPr sz="4275" b="1">
                 <a:solidFill>
                   <a:srgbClr val="172137"/>
@@ -9750,6 +10932,7 @@
           </a:p>
           <a:p xmlns:a="http://schemas.openxmlformats.org/drawingml/2006/main">
             <a:pPr>
+              <a:buNone/>
               <a:defRPr sz="4275" b="1">
                 <a:solidFill>
                   <a:srgbClr val="172137"/>
@@ -9789,7 +10972,7 @@
         </p:nvSpPr>
         <p:spPr>
           <a:xfrm xmlns:a="http://schemas.openxmlformats.org/drawingml/2006/main">
-            <a:off x="3248025" y="2752725"/>
+            <a:off x="3248025" y="3619500"/>
             <a:ext cx="7620000" cy="314325"/>
           </a:xfrm>
           <a:prstGeom xmlns:a="http://schemas.openxmlformats.org/drawingml/2006/main" prst="rect">
@@ -9807,6 +10990,7 @@
           <a:lstStyle xmlns:a="http://schemas.openxmlformats.org/drawingml/2006/main"/>
           <a:p xmlns:a="http://schemas.openxmlformats.org/drawingml/2006/main">
             <a:pPr>
+              <a:buNone/>
               <a:defRPr sz="1800" b="1">
                 <a:solidFill>
                   <a:srgbClr val="6044B6"/>
@@ -9846,8 +11030,8 @@
         </p:nvSpPr>
         <p:spPr>
           <a:xfrm xmlns:a="http://schemas.openxmlformats.org/drawingml/2006/main">
-            <a:off x="3219450" y="3190875"/>
-            <a:ext cx="8191500" cy="1066800"/>
+            <a:off x="3219450" y="4010025"/>
+            <a:ext cx="8191500" cy="800100"/>
           </a:xfrm>
           <a:prstGeom xmlns:a="http://schemas.openxmlformats.org/drawingml/2006/main" prst="rect">
             <a:avLst/>
@@ -9864,6 +11048,7 @@
           <a:lstStyle xmlns:a="http://schemas.openxmlformats.org/drawingml/2006/main"/>
           <a:p xmlns:a="http://schemas.openxmlformats.org/drawingml/2006/main">
             <a:pPr>
+              <a:buNone/>
               <a:defRPr sz="2700" b="0">
                 <a:solidFill>
                   <a:srgbClr val="172137"/>
@@ -9874,7 +11059,7 @@
               </a:defRPr>
             </a:pPr>
             <a:r>
-              <a:rPr sz="2700" b="0">
+              <a:rPr sz="2400" b="0">
                 <a:solidFill>
                   <a:srgbClr val="172137"/>
                 </a:solidFill>
@@ -9887,6 +11072,7 @@
           </a:p>
           <a:p xmlns:a="http://schemas.openxmlformats.org/drawingml/2006/main">
             <a:pPr>
+              <a:buNone/>
               <a:defRPr sz="2700" b="0">
                 <a:solidFill>
                   <a:srgbClr val="172137"/>
@@ -9897,7 +11083,7 @@
               </a:defRPr>
             </a:pPr>
             <a:r>
-              <a:rPr sz="2700" b="0">
+              <a:rPr sz="2400" b="0">
                 <a:solidFill>
                   <a:srgbClr val="172137"/>
                 </a:solidFill>
@@ -9926,7 +11112,7 @@
         </p:nvSpPr>
         <p:spPr>
           <a:xfrm xmlns:a="http://schemas.openxmlformats.org/drawingml/2006/main">
-            <a:off x="3248025" y="4667250"/>
+            <a:off x="3248025" y="5143500"/>
             <a:ext cx="7620000" cy="314325"/>
           </a:xfrm>
           <a:prstGeom xmlns:a="http://schemas.openxmlformats.org/drawingml/2006/main" prst="rect">
@@ -9944,6 +11130,7 @@
           <a:lstStyle xmlns:a="http://schemas.openxmlformats.org/drawingml/2006/main"/>
           <a:p xmlns:a="http://schemas.openxmlformats.org/drawingml/2006/main">
             <a:pPr>
+              <a:buNone/>
               <a:defRPr sz="1800" b="1">
                 <a:solidFill>
                   <a:srgbClr val="6044B6"/>
@@ -9983,8 +11170,8 @@
         </p:nvSpPr>
         <p:spPr>
           <a:xfrm xmlns:a="http://schemas.openxmlformats.org/drawingml/2006/main">
-            <a:off x="3219450" y="5105400"/>
-            <a:ext cx="8191500" cy="1047750"/>
+            <a:off x="3219450" y="5534025"/>
+            <a:ext cx="8191500" cy="800100"/>
           </a:xfrm>
           <a:prstGeom xmlns:a="http://schemas.openxmlformats.org/drawingml/2006/main" prst="rect">
             <a:avLst/>
@@ -10001,6 +11188,7 @@
           <a:lstStyle xmlns:a="http://schemas.openxmlformats.org/drawingml/2006/main"/>
           <a:p xmlns:a="http://schemas.openxmlformats.org/drawingml/2006/main">
             <a:pPr>
+              <a:buNone/>
               <a:defRPr sz="2550" b="0">
                 <a:solidFill>
                   <a:srgbClr val="172137"/>
@@ -10011,7 +11199,7 @@
               </a:defRPr>
             </a:pPr>
             <a:r>
-              <a:rPr sz="2550" b="0">
+              <a:rPr sz="2250" b="0">
                 <a:solidFill>
                   <a:srgbClr val="172137"/>
                 </a:solidFill>
@@ -10024,6 +11212,7 @@
           </a:p>
           <a:p xmlns:a="http://schemas.openxmlformats.org/drawingml/2006/main">
             <a:pPr>
+              <a:buNone/>
               <a:defRPr sz="2550" b="0">
                 <a:solidFill>
                   <a:srgbClr val="172137"/>
@@ -10034,7 +11223,7 @@
               </a:defRPr>
             </a:pPr>
             <a:r>
-              <a:rPr sz="2550" b="0">
+              <a:rPr sz="2250" b="0">
                 <a:solidFill>
                   <a:srgbClr val="172137"/>
                 </a:solidFill>
@@ -10043,6 +11232,109 @@
                 <a:cs typeface="Arial"/>
               </a:rPr>
               <a:t>o modificar cada pedido.</a:t>
+            </a:r>
+          </a:p>
+        </p:txBody>
+      </p:sp>
+      <p:sp>
+        <p:nvSpPr>
+          <p:cNvPr id="9" name="Module context">
+            <a:extLst xmlns:a="http://schemas.openxmlformats.org/drawingml/2006/main">
+              <a:ext uri="{FF2B5EF4-FFF2-40B4-BE49-F238E27FC236}">
+                <a16:creationId xmlns:a16="http://schemas.microsoft.com/office/drawing/2014/main" id="{16A341A1-90D9-48A4-B3AA-6BE5443CC4F1}"/>
+              </a:ext>
+            </a:extLst>
+          </p:cNvPr>
+          <p:cNvSpPr>
+            <a:spLocks xmlns:a="http://schemas.openxmlformats.org/drawingml/2006/main" noGrp="1"/>
+          </p:cNvSpPr>
+          <p:nvPr/>
+        </p:nvSpPr>
+        <p:spPr>
+          <a:xfrm xmlns:a="http://schemas.openxmlformats.org/drawingml/2006/main">
+            <a:off x="3219450" y="2390775"/>
+            <a:ext cx="8191500" cy="1028700"/>
+          </a:xfrm>
+          <a:prstGeom xmlns:a="http://schemas.openxmlformats.org/drawingml/2006/main" prst="rect">
+            <a:avLst/>
+          </a:prstGeom>
+          <a:noFill xmlns:a="http://schemas.openxmlformats.org/drawingml/2006/main"/>
+          <a:ln xmlns:a="http://schemas.openxmlformats.org/drawingml/2006/main" w="0">
+            <a:noFill/>
+          </a:ln>
+        </p:spPr>
+        <p:txBody>
+          <a:bodyPr xmlns:a="http://schemas.openxmlformats.org/drawingml/2006/main" wrap="square" lIns="0" tIns="0" rIns="0" bIns="0" anchor="t">
+            <a:noAutofit/>
+          </a:bodyPr>
+          <a:lstStyle xmlns:a="http://schemas.openxmlformats.org/drawingml/2006/main"/>
+          <a:p xmlns:a="http://schemas.openxmlformats.org/drawingml/2006/main">
+            <a:pPr>
+              <a:defRPr sz="2100">
+                <a:solidFill>
+                  <a:srgbClr val="45516A"/>
+                </a:solidFill>
+                <a:latin typeface="Arial"/>
+                <a:ea typeface="Arial"/>
+                <a:cs typeface="Arial"/>
+              </a:defRPr>
+            </a:pPr>
+            <a:r>
+              <a:rPr sz="2100">
+                <a:solidFill>
+                  <a:srgbClr val="45516A"/>
+                </a:solidFill>
+                <a:latin typeface="Arial"/>
+                <a:ea typeface="Arial"/>
+                <a:cs typeface="Arial"/>
+              </a:rPr>
+              <a:t>La autenticación identifica al usuario. Los permisos</a:t>
+            </a:r>
+          </a:p>
+          <a:p xmlns:a="http://schemas.openxmlformats.org/drawingml/2006/main">
+            <a:pPr>
+              <a:defRPr sz="2100">
+                <a:solidFill>
+                  <a:srgbClr val="45516A"/>
+                </a:solidFill>
+                <a:latin typeface="Arial"/>
+                <a:ea typeface="Arial"/>
+                <a:cs typeface="Arial"/>
+              </a:defRPr>
+            </a:pPr>
+            <a:r>
+              <a:rPr sz="2100">
+                <a:solidFill>
+                  <a:srgbClr val="45516A"/>
+                </a:solidFill>
+                <a:latin typeface="Arial"/>
+                <a:ea typeface="Arial"/>
+                <a:cs typeface="Arial"/>
+              </a:rPr>
+              <a:t>definen qué puede hacer. En AulaPedidos también</a:t>
+            </a:r>
+          </a:p>
+          <a:p xmlns:a="http://schemas.openxmlformats.org/drawingml/2006/main">
+            <a:pPr>
+              <a:defRPr sz="2100">
+                <a:solidFill>
+                  <a:srgbClr val="45516A"/>
+                </a:solidFill>
+                <a:latin typeface="Arial"/>
+                <a:ea typeface="Arial"/>
+                <a:cs typeface="Arial"/>
+              </a:defRPr>
+            </a:pPr>
+            <a:r>
+              <a:rPr sz="2100">
+                <a:solidFill>
+                  <a:srgbClr val="45516A"/>
+                </a:solidFill>
+                <a:latin typeface="Arial"/>
+                <a:ea typeface="Arial"/>
+                <a:cs typeface="Arial"/>
+              </a:rPr>
+              <a:t>comprobamos a quién pertenece cada pedido.</a:t>
             </a:r>
           </a:p>
         </p:txBody>

</xml_diff>

<commit_message>
Quita rotulos de clase y objetivos de la presentacion
</commit_message>
<xml_diff>
--- a/instructor/clases/00-presentacion-alumnos.pptx
+++ b/instructor/clases/00-presentacion-alumnos.pptx
@@ -2,36 +2,36 @@
 <file path=ppt/presentation.xml><?xml version="1.0" encoding="utf-8"?>
 <p:presentation xmlns:p="http://schemas.openxmlformats.org/presentationml/2006/main">
   <p:sldMasterIdLst>
-    <p:sldMasterId xmlns:r="http://schemas.openxmlformats.org/officeDocument/2006/relationships" id="2147483648" r:id="R7292d5d1c3dd4a04"/>
+    <p:sldMasterId xmlns:r="http://schemas.openxmlformats.org/officeDocument/2006/relationships" id="2147483648" r:id="Ra98d7b5705274a51"/>
   </p:sldMasterIdLst>
   <p:notesMasterIdLst>
-    <p:notesMasterId xmlns:r="http://schemas.openxmlformats.org/officeDocument/2006/relationships" r:id="R0536126daf0f4e30"/>
+    <p:notesMasterId xmlns:r="http://schemas.openxmlformats.org/officeDocument/2006/relationships" r:id="R4a0ff3912799417e"/>
   </p:notesMasterIdLst>
   <p:sldIdLst>
-    <p:sldId xmlns:r="http://schemas.openxmlformats.org/officeDocument/2006/relationships" id="256" r:id="R125b37a3f4764d11"/>
-    <p:sldId xmlns:r="http://schemas.openxmlformats.org/officeDocument/2006/relationships" id="257" r:id="Reead87a5c7064933"/>
-    <p:sldId xmlns:r="http://schemas.openxmlformats.org/officeDocument/2006/relationships" id="258" r:id="R5717ff53a5014aaf"/>
-    <p:sldId xmlns:r="http://schemas.openxmlformats.org/officeDocument/2006/relationships" id="259" r:id="R72a1d59440c54a1a"/>
-    <p:sldId xmlns:r="http://schemas.openxmlformats.org/officeDocument/2006/relationships" id="260" r:id="Ra6810493637d4c67"/>
-    <p:sldId xmlns:r="http://schemas.openxmlformats.org/officeDocument/2006/relationships" id="261" r:id="R60ba766a920e4cd7"/>
-    <p:sldId xmlns:r="http://schemas.openxmlformats.org/officeDocument/2006/relationships" id="262" r:id="R56ce4b529003498d"/>
-    <p:sldId xmlns:r="http://schemas.openxmlformats.org/officeDocument/2006/relationships" id="263" r:id="R18044a75b9a94559"/>
-    <p:sldId xmlns:r="http://schemas.openxmlformats.org/officeDocument/2006/relationships" id="264" r:id="R9466a2f8a08642e5"/>
-    <p:sldId xmlns:r="http://schemas.openxmlformats.org/officeDocument/2006/relationships" id="265" r:id="R7582d86178d3444c"/>
-    <p:sldId xmlns:r="http://schemas.openxmlformats.org/officeDocument/2006/relationships" id="266" r:id="R9a23ae910eab4d2b"/>
-    <p:sldId xmlns:r="http://schemas.openxmlformats.org/officeDocument/2006/relationships" id="267" r:id="R2e9b111f03e343a8"/>
-    <p:sldId xmlns:r="http://schemas.openxmlformats.org/officeDocument/2006/relationships" id="268" r:id="R84b7157f662140a8"/>
-    <p:sldId xmlns:r="http://schemas.openxmlformats.org/officeDocument/2006/relationships" id="269" r:id="R505e56fad8674615"/>
-    <p:sldId xmlns:r="http://schemas.openxmlformats.org/officeDocument/2006/relationships" id="270" r:id="R7ab1b0fb1dff4c42"/>
-    <p:sldId xmlns:r="http://schemas.openxmlformats.org/officeDocument/2006/relationships" id="271" r:id="R7bb3fab7926441a0"/>
-    <p:sldId xmlns:r="http://schemas.openxmlformats.org/officeDocument/2006/relationships" id="272" r:id="R7f8332e24bbe4bd0"/>
-    <p:sldId xmlns:r="http://schemas.openxmlformats.org/officeDocument/2006/relationships" id="273" r:id="Rd7f9e0c219474ad1"/>
-    <p:sldId xmlns:r="http://schemas.openxmlformats.org/officeDocument/2006/relationships" id="274" r:id="R00e5622186a24b50"/>
-    <p:sldId xmlns:r="http://schemas.openxmlformats.org/officeDocument/2006/relationships" id="275" r:id="R6eacc31723e74d93"/>
-    <p:sldId xmlns:r="http://schemas.openxmlformats.org/officeDocument/2006/relationships" id="276" r:id="Ra8a037d8655142e5"/>
-    <p:sldId xmlns:r="http://schemas.openxmlformats.org/officeDocument/2006/relationships" id="277" r:id="R8552fa5bb69e47db"/>
-    <p:sldId xmlns:r="http://schemas.openxmlformats.org/officeDocument/2006/relationships" id="278" r:id="Rc3e8086de52c4d21"/>
-    <p:sldId xmlns:r="http://schemas.openxmlformats.org/officeDocument/2006/relationships" id="279" r:id="R9cd6781c221a44fb"/>
+    <p:sldId xmlns:r="http://schemas.openxmlformats.org/officeDocument/2006/relationships" id="256" r:id="R2d40abf7bc744805"/>
+    <p:sldId xmlns:r="http://schemas.openxmlformats.org/officeDocument/2006/relationships" id="257" r:id="Rd807d35206754170"/>
+    <p:sldId xmlns:r="http://schemas.openxmlformats.org/officeDocument/2006/relationships" id="258" r:id="R3e7925a32a974e1e"/>
+    <p:sldId xmlns:r="http://schemas.openxmlformats.org/officeDocument/2006/relationships" id="259" r:id="R6d42c7341cb648da"/>
+    <p:sldId xmlns:r="http://schemas.openxmlformats.org/officeDocument/2006/relationships" id="260" r:id="R8f46de366c1f465e"/>
+    <p:sldId xmlns:r="http://schemas.openxmlformats.org/officeDocument/2006/relationships" id="261" r:id="R3d96b77eb71a4a81"/>
+    <p:sldId xmlns:r="http://schemas.openxmlformats.org/officeDocument/2006/relationships" id="262" r:id="R085ba209d9c24f25"/>
+    <p:sldId xmlns:r="http://schemas.openxmlformats.org/officeDocument/2006/relationships" id="263" r:id="R3ae81e9a11d54aa3"/>
+    <p:sldId xmlns:r="http://schemas.openxmlformats.org/officeDocument/2006/relationships" id="264" r:id="R5379997639e3463d"/>
+    <p:sldId xmlns:r="http://schemas.openxmlformats.org/officeDocument/2006/relationships" id="265" r:id="R6886977d00f64d9d"/>
+    <p:sldId xmlns:r="http://schemas.openxmlformats.org/officeDocument/2006/relationships" id="266" r:id="R46356fa2866c46b8"/>
+    <p:sldId xmlns:r="http://schemas.openxmlformats.org/officeDocument/2006/relationships" id="267" r:id="R2dcbb3e727d4441d"/>
+    <p:sldId xmlns:r="http://schemas.openxmlformats.org/officeDocument/2006/relationships" id="268" r:id="R93ad29b21c554d60"/>
+    <p:sldId xmlns:r="http://schemas.openxmlformats.org/officeDocument/2006/relationships" id="269" r:id="R1741469725354202"/>
+    <p:sldId xmlns:r="http://schemas.openxmlformats.org/officeDocument/2006/relationships" id="270" r:id="Ra45a5342c4664949"/>
+    <p:sldId xmlns:r="http://schemas.openxmlformats.org/officeDocument/2006/relationships" id="271" r:id="R8cdeed452c7a4b3e"/>
+    <p:sldId xmlns:r="http://schemas.openxmlformats.org/officeDocument/2006/relationships" id="272" r:id="R8edf135aa10a4a3d"/>
+    <p:sldId xmlns:r="http://schemas.openxmlformats.org/officeDocument/2006/relationships" id="273" r:id="R757b2d9d1ca048eb"/>
+    <p:sldId xmlns:r="http://schemas.openxmlformats.org/officeDocument/2006/relationships" id="274" r:id="Rc584049ad0294af0"/>
+    <p:sldId xmlns:r="http://schemas.openxmlformats.org/officeDocument/2006/relationships" id="275" r:id="Re55973c172a14205"/>
+    <p:sldId xmlns:r="http://schemas.openxmlformats.org/officeDocument/2006/relationships" id="276" r:id="R8811588968284bae"/>
+    <p:sldId xmlns:r="http://schemas.openxmlformats.org/officeDocument/2006/relationships" id="277" r:id="R2ffd8b1c916a4b18"/>
+    <p:sldId xmlns:r="http://schemas.openxmlformats.org/officeDocument/2006/relationships" id="278" r:id="R7b7c8167dbed49d3"/>
+    <p:sldId xmlns:r="http://schemas.openxmlformats.org/officeDocument/2006/relationships" id="279" r:id="Rc8f4741a5ac743bd"/>
   </p:sldIdLst>
   <p:sldSz cx="12192000" cy="6858000"/>
   <p:notesSz cx="6858000" cy="9144000"/>
@@ -4458,12 +4458,12 @@
   </p:cSld>
   <p:clrMap bg1="lt1" tx1="dk1" bg2="lt2" tx2="dk2" accent1="accent1" accent2="accent2" accent3="accent3" accent4="accent4" accent5="accent5" accent6="accent6" hlink="hlink" folHlink="folHlink"/>
   <p:sldLayoutIdLst>
-    <p:sldLayoutId xmlns:r="http://schemas.openxmlformats.org/officeDocument/2006/relationships" id="2147483649" r:id="R2c4a0b111a7f4390"/>
-    <p:sldLayoutId xmlns:r="http://schemas.openxmlformats.org/officeDocument/2006/relationships" id="2147483650" r:id="R1654d37788b3496e"/>
-    <p:sldLayoutId xmlns:r="http://schemas.openxmlformats.org/officeDocument/2006/relationships" id="2147483651" r:id="R7681381b5a1c4db3"/>
-    <p:sldLayoutId xmlns:r="http://schemas.openxmlformats.org/officeDocument/2006/relationships" id="2147483652" r:id="R8a9da7d90fa94f7d"/>
-    <p:sldLayoutId xmlns:r="http://schemas.openxmlformats.org/officeDocument/2006/relationships" id="2147483653" r:id="Raf43a24915424a63"/>
-    <p:sldLayoutId xmlns:r="http://schemas.openxmlformats.org/officeDocument/2006/relationships" id="2147483654" r:id="Rcbadf4b80606439c"/>
+    <p:sldLayoutId xmlns:r="http://schemas.openxmlformats.org/officeDocument/2006/relationships" id="2147483649" r:id="Ra3ed7ea170ce4180"/>
+    <p:sldLayoutId xmlns:r="http://schemas.openxmlformats.org/officeDocument/2006/relationships" id="2147483650" r:id="Rfecb903bc5594a2e"/>
+    <p:sldLayoutId xmlns:r="http://schemas.openxmlformats.org/officeDocument/2006/relationships" id="2147483651" r:id="Rf3cba8861cf04ba7"/>
+    <p:sldLayoutId xmlns:r="http://schemas.openxmlformats.org/officeDocument/2006/relationships" id="2147483652" r:id="R2c12459e63cc4276"/>
+    <p:sldLayoutId xmlns:r="http://schemas.openxmlformats.org/officeDocument/2006/relationships" id="2147483653" r:id="Re0195c3d6d35445b"/>
+    <p:sldLayoutId xmlns:r="http://schemas.openxmlformats.org/officeDocument/2006/relationships" id="2147483654" r:id="R9aa5fbedb6bc4005"/>
   </p:sldLayoutIdLst>
   <p:txStyles>
     <p:titleStyle>
@@ -5018,7 +5018,7 @@
           <p:nvPr/>
         </p:nvPicPr>
         <p:blipFill>
-          <a:blip xmlns:r="http://schemas.openxmlformats.org/officeDocument/2006/relationships" xmlns:a="http://schemas.openxmlformats.org/drawingml/2006/main" r:embed="Ref65ea9dcfc745ae"/>
+          <a:blip xmlns:r="http://schemas.openxmlformats.org/officeDocument/2006/relationships" xmlns:a="http://schemas.openxmlformats.org/drawingml/2006/main" r:embed="Rb14f9de00c974114"/>
           <a:srcRect xmlns:a="http://schemas.openxmlformats.org/drawingml/2006/main" l="0" t="27" r="0" b="27"/>
           <a:stretch xmlns:a="http://schemas.openxmlformats.org/drawingml/2006/main">
             <a:fillRect l="0" t="0" r="0" b="0"/>
@@ -5321,88 +5321,6 @@
       </p:sp>
       <p:sp>
         <p:nvSpPr>
-          <p:cNvPr id="2" name="Class duration">
-            <a:extLst xmlns:a="http://schemas.openxmlformats.org/drawingml/2006/main">
-              <a:ext uri="{FF2B5EF4-FFF2-40B4-BE49-F238E27FC236}">
-                <a16:creationId xmlns:a16="http://schemas.microsoft.com/office/drawing/2014/main" id="{6AECE2BA-C9FB-4EBD-BD9D-3652EC3A3166}"/>
-              </a:ext>
-            </a:extLst>
-          </p:cNvPr>
-          <p:cNvSpPr>
-            <a:spLocks xmlns:a="http://schemas.openxmlformats.org/drawingml/2006/main" noGrp="1"/>
-          </p:cNvSpPr>
-          <p:nvPr/>
-        </p:nvSpPr>
-        <p:spPr>
-          <a:xfrm xmlns:a="http://schemas.openxmlformats.org/drawingml/2006/main">
-            <a:off x="790575" y="2428875"/>
-            <a:ext cx="1952625" cy="857250"/>
-          </a:xfrm>
-          <a:prstGeom xmlns:a="http://schemas.openxmlformats.org/drawingml/2006/main" prst="rect">
-            <a:avLst/>
-          </a:prstGeom>
-          <a:noFill xmlns:a="http://schemas.openxmlformats.org/drawingml/2006/main"/>
-          <a:ln xmlns:a="http://schemas.openxmlformats.org/drawingml/2006/main" w="0">
-            <a:noFill/>
-          </a:ln>
-        </p:spPr>
-        <p:txBody>
-          <a:bodyPr xmlns:a="http://schemas.openxmlformats.org/drawingml/2006/main" wrap="square" lIns="0" tIns="0" rIns="0" bIns="0" anchor="t">
-            <a:noAutofit/>
-          </a:bodyPr>
-          <a:lstStyle xmlns:a="http://schemas.openxmlformats.org/drawingml/2006/main"/>
-          <a:p xmlns:a="http://schemas.openxmlformats.org/drawingml/2006/main">
-            <a:pPr>
-              <a:buNone/>
-              <a:defRPr sz="1875" b="0">
-                <a:solidFill>
-                  <a:srgbClr val="45516A"/>
-                </a:solidFill>
-                <a:latin typeface="Arial"/>
-                <a:ea typeface="Arial"/>
-                <a:cs typeface="Arial"/>
-              </a:defRPr>
-            </a:pPr>
-            <a:r>
-              <a:rPr sz="1875" b="0">
-                <a:solidFill>
-                  <a:srgbClr val="45516A"/>
-                </a:solidFill>
-                <a:latin typeface="Arial"/>
-                <a:ea typeface="Arial"/>
-                <a:cs typeface="Arial"/>
-              </a:rPr>
-              <a:t>CLASE</a:t>
-            </a:r>
-          </a:p>
-          <a:p xmlns:a="http://schemas.openxmlformats.org/drawingml/2006/main">
-            <a:pPr>
-              <a:buNone/>
-              <a:defRPr sz="1875" b="0">
-                <a:solidFill>
-                  <a:srgbClr val="45516A"/>
-                </a:solidFill>
-                <a:latin typeface="Arial"/>
-                <a:ea typeface="Arial"/>
-                <a:cs typeface="Arial"/>
-              </a:defRPr>
-            </a:pPr>
-            <a:r>
-              <a:rPr sz="1875" b="0">
-                <a:solidFill>
-                  <a:srgbClr val="45516A"/>
-                </a:solidFill>
-                <a:latin typeface="Arial"/>
-                <a:ea typeface="Arial"/>
-                <a:cs typeface="Arial"/>
-              </a:rPr>
-              <a:t>4 horas</a:t>
-            </a:r>
-          </a:p>
-        </p:txBody>
-      </p:sp>
-      <p:sp>
-        <p:nvSpPr>
           <p:cNvPr id="3" name="Class title">
             <a:extLst xmlns:a="http://schemas.openxmlformats.org/drawingml/2006/main">
               <a:ext uri="{FF2B5EF4-FFF2-40B4-BE49-F238E27FC236}">
@@ -5461,64 +5379,6 @@
       </p:sp>
       <p:sp>
         <p:nvSpPr>
-          <p:cNvPr id="4" name="Learning label">
-            <a:extLst xmlns:a="http://schemas.openxmlformats.org/drawingml/2006/main">
-              <a:ext uri="{FF2B5EF4-FFF2-40B4-BE49-F238E27FC236}">
-                <a16:creationId xmlns:a16="http://schemas.microsoft.com/office/drawing/2014/main" id="{28C032F3-CB01-458D-9BB3-C3B61A5E478C}"/>
-              </a:ext>
-            </a:extLst>
-          </p:cNvPr>
-          <p:cNvSpPr>
-            <a:spLocks xmlns:a="http://schemas.openxmlformats.org/drawingml/2006/main" noGrp="1"/>
-          </p:cNvSpPr>
-          <p:nvPr/>
-        </p:nvSpPr>
-        <p:spPr>
-          <a:xfrm xmlns:a="http://schemas.openxmlformats.org/drawingml/2006/main">
-            <a:off x="3248025" y="3619500"/>
-            <a:ext cx="7620000" cy="314325"/>
-          </a:xfrm>
-          <a:prstGeom xmlns:a="http://schemas.openxmlformats.org/drawingml/2006/main" prst="rect">
-            <a:avLst/>
-          </a:prstGeom>
-          <a:noFill xmlns:a="http://schemas.openxmlformats.org/drawingml/2006/main"/>
-          <a:ln xmlns:a="http://schemas.openxmlformats.org/drawingml/2006/main" w="0">
-            <a:noFill/>
-          </a:ln>
-        </p:spPr>
-        <p:txBody>
-          <a:bodyPr xmlns:a="http://schemas.openxmlformats.org/drawingml/2006/main" wrap="square" lIns="0" tIns="0" rIns="0" bIns="0" anchor="t">
-            <a:noAutofit/>
-          </a:bodyPr>
-          <a:lstStyle xmlns:a="http://schemas.openxmlformats.org/drawingml/2006/main"/>
-          <a:p xmlns:a="http://schemas.openxmlformats.org/drawingml/2006/main">
-            <a:pPr>
-              <a:buNone/>
-              <a:defRPr sz="1800" b="1">
-                <a:solidFill>
-                  <a:srgbClr val="6044B6"/>
-                </a:solidFill>
-                <a:latin typeface="Arial"/>
-                <a:ea typeface="Arial"/>
-                <a:cs typeface="Arial"/>
-              </a:defRPr>
-            </a:pPr>
-            <a:r>
-              <a:rPr sz="1800" b="1">
-                <a:solidFill>
-                  <a:srgbClr val="6044B6"/>
-                </a:solidFill>
-                <a:latin typeface="Arial"/>
-                <a:ea typeface="Arial"/>
-                <a:cs typeface="Arial"/>
-              </a:rPr>
-              <a:t>APRENDERÁS</a:t>
-            </a:r>
-          </a:p>
-        </p:txBody>
-      </p:sp>
-      <p:sp>
-        <p:nvSpPr>
           <p:cNvPr id="5" name="Learning outcome">
             <a:extLst xmlns:a="http://schemas.openxmlformats.org/drawingml/2006/main">
               <a:ext uri="{FF2B5EF4-FFF2-40B4-BE49-F238E27FC236}">
@@ -5533,7 +5393,7 @@
         </p:nvSpPr>
         <p:spPr>
           <a:xfrm xmlns:a="http://schemas.openxmlformats.org/drawingml/2006/main">
-            <a:off x="3219450" y="4010025"/>
+            <a:off x="3219450" y="3905250"/>
             <a:ext cx="8191500" cy="800100"/>
           </a:xfrm>
           <a:prstGeom xmlns:a="http://schemas.openxmlformats.org/drawingml/2006/main" prst="rect">
@@ -5601,64 +5461,6 @@
       </p:sp>
       <p:sp>
         <p:nvSpPr>
-          <p:cNvPr id="6" name="Practice label">
-            <a:extLst xmlns:a="http://schemas.openxmlformats.org/drawingml/2006/main">
-              <a:ext uri="{FF2B5EF4-FFF2-40B4-BE49-F238E27FC236}">
-                <a16:creationId xmlns:a16="http://schemas.microsoft.com/office/drawing/2014/main" id="{ED8B7F65-8688-40F7-8A47-5A5F55C464AD}"/>
-              </a:ext>
-            </a:extLst>
-          </p:cNvPr>
-          <p:cNvSpPr>
-            <a:spLocks xmlns:a="http://schemas.openxmlformats.org/drawingml/2006/main" noGrp="1"/>
-          </p:cNvSpPr>
-          <p:nvPr/>
-        </p:nvSpPr>
-        <p:spPr>
-          <a:xfrm xmlns:a="http://schemas.openxmlformats.org/drawingml/2006/main">
-            <a:off x="3248025" y="5143500"/>
-            <a:ext cx="7620000" cy="314325"/>
-          </a:xfrm>
-          <a:prstGeom xmlns:a="http://schemas.openxmlformats.org/drawingml/2006/main" prst="rect">
-            <a:avLst/>
-          </a:prstGeom>
-          <a:noFill xmlns:a="http://schemas.openxmlformats.org/drawingml/2006/main"/>
-          <a:ln xmlns:a="http://schemas.openxmlformats.org/drawingml/2006/main" w="0">
-            <a:noFill/>
-          </a:ln>
-        </p:spPr>
-        <p:txBody>
-          <a:bodyPr xmlns:a="http://schemas.openxmlformats.org/drawingml/2006/main" wrap="square" lIns="0" tIns="0" rIns="0" bIns="0" anchor="t">
-            <a:noAutofit/>
-          </a:bodyPr>
-          <a:lstStyle xmlns:a="http://schemas.openxmlformats.org/drawingml/2006/main"/>
-          <a:p xmlns:a="http://schemas.openxmlformats.org/drawingml/2006/main">
-            <a:pPr>
-              <a:buNone/>
-              <a:defRPr sz="1800" b="1">
-                <a:solidFill>
-                  <a:srgbClr val="6044B6"/>
-                </a:solidFill>
-                <a:latin typeface="Arial"/>
-                <a:ea typeface="Arial"/>
-                <a:cs typeface="Arial"/>
-              </a:defRPr>
-            </a:pPr>
-            <a:r>
-              <a:rPr sz="1800" b="1">
-                <a:solidFill>
-                  <a:srgbClr val="6044B6"/>
-                </a:solidFill>
-                <a:latin typeface="Arial"/>
-                <a:ea typeface="Arial"/>
-                <a:cs typeface="Arial"/>
-              </a:rPr>
-              <a:t>HARÁS</a:t>
-            </a:r>
-          </a:p>
-        </p:txBody>
-      </p:sp>
-      <p:sp>
-        <p:nvSpPr>
           <p:cNvPr id="7" name="Practice outcome">
             <a:extLst xmlns:a="http://schemas.openxmlformats.org/drawingml/2006/main">
               <a:ext uri="{FF2B5EF4-FFF2-40B4-BE49-F238E27FC236}">
@@ -5673,7 +5475,7 @@
         </p:nvSpPr>
         <p:spPr>
           <a:xfrm xmlns:a="http://schemas.openxmlformats.org/drawingml/2006/main">
-            <a:off x="3219450" y="5534025"/>
+            <a:off x="3219450" y="5143500"/>
             <a:ext cx="8191500" cy="800100"/>
           </a:xfrm>
           <a:prstGeom xmlns:a="http://schemas.openxmlformats.org/drawingml/2006/main" prst="rect">
@@ -5908,6 +5710,7 @@
           <a:lstStyle xmlns:a="http://schemas.openxmlformats.org/drawingml/2006/main"/>
           <a:p xmlns:a="http://schemas.openxmlformats.org/drawingml/2006/main">
             <a:pPr>
+              <a:buNone/>
               <a:defRPr sz="1800" b="1">
                 <a:solidFill>
                   <a:srgbClr val="A7E2D7"/>
@@ -5965,6 +5768,7 @@
           <a:lstStyle xmlns:a="http://schemas.openxmlformats.org/drawingml/2006/main"/>
           <a:p xmlns:a="http://schemas.openxmlformats.org/drawingml/2006/main">
             <a:pPr>
+              <a:buNone/>
               <a:defRPr sz="4050" b="1">
                 <a:solidFill>
                   <a:srgbClr val="FFFFFF"/>
@@ -6022,6 +5826,7 @@
           <a:lstStyle xmlns:a="http://schemas.openxmlformats.org/drawingml/2006/main"/>
           <a:p xmlns:a="http://schemas.openxmlformats.org/drawingml/2006/main">
             <a:pPr>
+              <a:buNone/>
               <a:defRPr sz="2400" b="0">
                 <a:solidFill>
                   <a:srgbClr val="FFFFFF"/>
@@ -6045,6 +5850,7 @@
           </a:p>
           <a:p xmlns:a="http://schemas.openxmlformats.org/drawingml/2006/main">
             <a:pPr>
+              <a:buNone/>
               <a:defRPr sz="2400" b="0">
                 <a:solidFill>
                   <a:srgbClr val="FFFFFF"/>
@@ -6068,6 +5874,7 @@
           </a:p>
           <a:p xmlns:a="http://schemas.openxmlformats.org/drawingml/2006/main">
             <a:pPr>
+              <a:buNone/>
               <a:defRPr sz="2400" b="0">
                 <a:solidFill>
                   <a:srgbClr val="FFFFFF"/>
@@ -6125,6 +5932,7 @@
           <a:lstStyle xmlns:a="http://schemas.openxmlformats.org/drawingml/2006/main"/>
           <a:p xmlns:a="http://schemas.openxmlformats.org/drawingml/2006/main">
             <a:pPr>
+              <a:buNone/>
               <a:defRPr sz="2250" b="0">
                 <a:solidFill>
                   <a:srgbClr val="D0D8E6"/>
@@ -6148,6 +5956,7 @@
           </a:p>
           <a:p xmlns:a="http://schemas.openxmlformats.org/drawingml/2006/main">
             <a:pPr>
+              <a:buNone/>
               <a:defRPr sz="2250" b="0">
                 <a:solidFill>
                   <a:srgbClr val="D0D8E6"/>
@@ -6171,6 +5980,7 @@
           </a:p>
           <a:p xmlns:a="http://schemas.openxmlformats.org/drawingml/2006/main">
             <a:pPr>
+              <a:buNone/>
               <a:defRPr sz="2250" b="0">
                 <a:solidFill>
                   <a:srgbClr val="D0D8E6"/>
@@ -6228,6 +6038,7 @@
           <a:lstStyle xmlns:a="http://schemas.openxmlformats.org/drawingml/2006/main"/>
           <a:p xmlns:a="http://schemas.openxmlformats.org/drawingml/2006/main">
             <a:pPr>
+              <a:buNone/>
               <a:defRPr sz="1800" b="1">
                 <a:solidFill>
                   <a:srgbClr val="A7E2D7"/>
@@ -6285,6 +6096,7 @@
           <a:lstStyle xmlns:a="http://schemas.openxmlformats.org/drawingml/2006/main"/>
           <a:p xmlns:a="http://schemas.openxmlformats.org/drawingml/2006/main">
             <a:pPr>
+              <a:buNone/>
               <a:defRPr sz="2250" b="0">
                 <a:solidFill>
                   <a:srgbClr val="FFFFFF"/>
@@ -6308,6 +6120,7 @@
           </a:p>
           <a:p xmlns:a="http://schemas.openxmlformats.org/drawingml/2006/main">
             <a:pPr>
+              <a:buNone/>
               <a:defRPr sz="2250" b="0">
                 <a:solidFill>
                   <a:srgbClr val="FFFFFF"/>
@@ -6420,88 +6233,6 @@
       </p:sp>
       <p:sp>
         <p:nvSpPr>
-          <p:cNvPr id="2" name="Class duration">
-            <a:extLst xmlns:a="http://schemas.openxmlformats.org/drawingml/2006/main">
-              <a:ext uri="{FF2B5EF4-FFF2-40B4-BE49-F238E27FC236}">
-                <a16:creationId xmlns:a16="http://schemas.microsoft.com/office/drawing/2014/main" id="{C6987BAA-2E72-4498-8C86-C0E6F812A29D}"/>
-              </a:ext>
-            </a:extLst>
-          </p:cNvPr>
-          <p:cNvSpPr>
-            <a:spLocks xmlns:a="http://schemas.openxmlformats.org/drawingml/2006/main" noGrp="1"/>
-          </p:cNvSpPr>
-          <p:nvPr/>
-        </p:nvSpPr>
-        <p:spPr>
-          <a:xfrm xmlns:a="http://schemas.openxmlformats.org/drawingml/2006/main">
-            <a:off x="790575" y="2428875"/>
-            <a:ext cx="1952625" cy="857250"/>
-          </a:xfrm>
-          <a:prstGeom xmlns:a="http://schemas.openxmlformats.org/drawingml/2006/main" prst="rect">
-            <a:avLst/>
-          </a:prstGeom>
-          <a:noFill xmlns:a="http://schemas.openxmlformats.org/drawingml/2006/main"/>
-          <a:ln xmlns:a="http://schemas.openxmlformats.org/drawingml/2006/main" w="0">
-            <a:noFill/>
-          </a:ln>
-        </p:spPr>
-        <p:txBody>
-          <a:bodyPr xmlns:a="http://schemas.openxmlformats.org/drawingml/2006/main" wrap="square" lIns="0" tIns="0" rIns="0" bIns="0" anchor="t">
-            <a:noAutofit/>
-          </a:bodyPr>
-          <a:lstStyle xmlns:a="http://schemas.openxmlformats.org/drawingml/2006/main"/>
-          <a:p xmlns:a="http://schemas.openxmlformats.org/drawingml/2006/main">
-            <a:pPr>
-              <a:buNone/>
-              <a:defRPr sz="1875" b="0">
-                <a:solidFill>
-                  <a:srgbClr val="45516A"/>
-                </a:solidFill>
-                <a:latin typeface="Arial"/>
-                <a:ea typeface="Arial"/>
-                <a:cs typeface="Arial"/>
-              </a:defRPr>
-            </a:pPr>
-            <a:r>
-              <a:rPr sz="1875" b="0">
-                <a:solidFill>
-                  <a:srgbClr val="45516A"/>
-                </a:solidFill>
-                <a:latin typeface="Arial"/>
-                <a:ea typeface="Arial"/>
-                <a:cs typeface="Arial"/>
-              </a:rPr>
-              <a:t>CLASE</a:t>
-            </a:r>
-          </a:p>
-          <a:p xmlns:a="http://schemas.openxmlformats.org/drawingml/2006/main">
-            <a:pPr>
-              <a:buNone/>
-              <a:defRPr sz="1875" b="0">
-                <a:solidFill>
-                  <a:srgbClr val="45516A"/>
-                </a:solidFill>
-                <a:latin typeface="Arial"/>
-                <a:ea typeface="Arial"/>
-                <a:cs typeface="Arial"/>
-              </a:defRPr>
-            </a:pPr>
-            <a:r>
-              <a:rPr sz="1875" b="0">
-                <a:solidFill>
-                  <a:srgbClr val="45516A"/>
-                </a:solidFill>
-                <a:latin typeface="Arial"/>
-                <a:ea typeface="Arial"/>
-                <a:cs typeface="Arial"/>
-              </a:rPr>
-              <a:t>4 horas</a:t>
-            </a:r>
-          </a:p>
-        </p:txBody>
-      </p:sp>
-      <p:sp>
-        <p:nvSpPr>
           <p:cNvPr id="3" name="Class title">
             <a:extLst xmlns:a="http://schemas.openxmlformats.org/drawingml/2006/main">
               <a:ext uri="{FF2B5EF4-FFF2-40B4-BE49-F238E27FC236}">
@@ -6560,64 +6291,6 @@
       </p:sp>
       <p:sp>
         <p:nvSpPr>
-          <p:cNvPr id="4" name="Learning label">
-            <a:extLst xmlns:a="http://schemas.openxmlformats.org/drawingml/2006/main">
-              <a:ext uri="{FF2B5EF4-FFF2-40B4-BE49-F238E27FC236}">
-                <a16:creationId xmlns:a16="http://schemas.microsoft.com/office/drawing/2014/main" id="{151439FE-A64C-47AD-846B-BB96243D9D0D}"/>
-              </a:ext>
-            </a:extLst>
-          </p:cNvPr>
-          <p:cNvSpPr>
-            <a:spLocks xmlns:a="http://schemas.openxmlformats.org/drawingml/2006/main" noGrp="1"/>
-          </p:cNvSpPr>
-          <p:nvPr/>
-        </p:nvSpPr>
-        <p:spPr>
-          <a:xfrm xmlns:a="http://schemas.openxmlformats.org/drawingml/2006/main">
-            <a:off x="3248025" y="3619500"/>
-            <a:ext cx="7620000" cy="314325"/>
-          </a:xfrm>
-          <a:prstGeom xmlns:a="http://schemas.openxmlformats.org/drawingml/2006/main" prst="rect">
-            <a:avLst/>
-          </a:prstGeom>
-          <a:noFill xmlns:a="http://schemas.openxmlformats.org/drawingml/2006/main"/>
-          <a:ln xmlns:a="http://schemas.openxmlformats.org/drawingml/2006/main" w="0">
-            <a:noFill/>
-          </a:ln>
-        </p:spPr>
-        <p:txBody>
-          <a:bodyPr xmlns:a="http://schemas.openxmlformats.org/drawingml/2006/main" wrap="square" lIns="0" tIns="0" rIns="0" bIns="0" anchor="t">
-            <a:noAutofit/>
-          </a:bodyPr>
-          <a:lstStyle xmlns:a="http://schemas.openxmlformats.org/drawingml/2006/main"/>
-          <a:p xmlns:a="http://schemas.openxmlformats.org/drawingml/2006/main">
-            <a:pPr>
-              <a:buNone/>
-              <a:defRPr sz="1800" b="1">
-                <a:solidFill>
-                  <a:srgbClr val="6044B6"/>
-                </a:solidFill>
-                <a:latin typeface="Arial"/>
-                <a:ea typeface="Arial"/>
-                <a:cs typeface="Arial"/>
-              </a:defRPr>
-            </a:pPr>
-            <a:r>
-              <a:rPr sz="1800" b="1">
-                <a:solidFill>
-                  <a:srgbClr val="6044B6"/>
-                </a:solidFill>
-                <a:latin typeface="Arial"/>
-                <a:ea typeface="Arial"/>
-                <a:cs typeface="Arial"/>
-              </a:rPr>
-              <a:t>APRENDERÁS</a:t>
-            </a:r>
-          </a:p>
-        </p:txBody>
-      </p:sp>
-      <p:sp>
-        <p:nvSpPr>
           <p:cNvPr id="5" name="Learning outcome">
             <a:extLst xmlns:a="http://schemas.openxmlformats.org/drawingml/2006/main">
               <a:ext uri="{FF2B5EF4-FFF2-40B4-BE49-F238E27FC236}">
@@ -6632,7 +6305,7 @@
         </p:nvSpPr>
         <p:spPr>
           <a:xfrm xmlns:a="http://schemas.openxmlformats.org/drawingml/2006/main">
-            <a:off x="3219450" y="4010025"/>
+            <a:off x="3219450" y="3905250"/>
             <a:ext cx="8191500" cy="800100"/>
           </a:xfrm>
           <a:prstGeom xmlns:a="http://schemas.openxmlformats.org/drawingml/2006/main" prst="rect">
@@ -6700,64 +6373,6 @@
       </p:sp>
       <p:sp>
         <p:nvSpPr>
-          <p:cNvPr id="6" name="Practice label">
-            <a:extLst xmlns:a="http://schemas.openxmlformats.org/drawingml/2006/main">
-              <a:ext uri="{FF2B5EF4-FFF2-40B4-BE49-F238E27FC236}">
-                <a16:creationId xmlns:a16="http://schemas.microsoft.com/office/drawing/2014/main" id="{2AE8AC63-71B8-48B5-9CEC-EC3937FCD824}"/>
-              </a:ext>
-            </a:extLst>
-          </p:cNvPr>
-          <p:cNvSpPr>
-            <a:spLocks xmlns:a="http://schemas.openxmlformats.org/drawingml/2006/main" noGrp="1"/>
-          </p:cNvSpPr>
-          <p:nvPr/>
-        </p:nvSpPr>
-        <p:spPr>
-          <a:xfrm xmlns:a="http://schemas.openxmlformats.org/drawingml/2006/main">
-            <a:off x="3248025" y="5143500"/>
-            <a:ext cx="7620000" cy="314325"/>
-          </a:xfrm>
-          <a:prstGeom xmlns:a="http://schemas.openxmlformats.org/drawingml/2006/main" prst="rect">
-            <a:avLst/>
-          </a:prstGeom>
-          <a:noFill xmlns:a="http://schemas.openxmlformats.org/drawingml/2006/main"/>
-          <a:ln xmlns:a="http://schemas.openxmlformats.org/drawingml/2006/main" w="0">
-            <a:noFill/>
-          </a:ln>
-        </p:spPr>
-        <p:txBody>
-          <a:bodyPr xmlns:a="http://schemas.openxmlformats.org/drawingml/2006/main" wrap="square" lIns="0" tIns="0" rIns="0" bIns="0" anchor="t">
-            <a:noAutofit/>
-          </a:bodyPr>
-          <a:lstStyle xmlns:a="http://schemas.openxmlformats.org/drawingml/2006/main"/>
-          <a:p xmlns:a="http://schemas.openxmlformats.org/drawingml/2006/main">
-            <a:pPr>
-              <a:buNone/>
-              <a:defRPr sz="1800" b="1">
-                <a:solidFill>
-                  <a:srgbClr val="6044B6"/>
-                </a:solidFill>
-                <a:latin typeface="Arial"/>
-                <a:ea typeface="Arial"/>
-                <a:cs typeface="Arial"/>
-              </a:defRPr>
-            </a:pPr>
-            <a:r>
-              <a:rPr sz="1800" b="1">
-                <a:solidFill>
-                  <a:srgbClr val="6044B6"/>
-                </a:solidFill>
-                <a:latin typeface="Arial"/>
-                <a:ea typeface="Arial"/>
-                <a:cs typeface="Arial"/>
-              </a:rPr>
-              <a:t>HARÁS</a:t>
-            </a:r>
-          </a:p>
-        </p:txBody>
-      </p:sp>
-      <p:sp>
-        <p:nvSpPr>
           <p:cNvPr id="7" name="Practice outcome">
             <a:extLst xmlns:a="http://schemas.openxmlformats.org/drawingml/2006/main">
               <a:ext uri="{FF2B5EF4-FFF2-40B4-BE49-F238E27FC236}">
@@ -6772,7 +6387,7 @@
         </p:nvSpPr>
         <p:spPr>
           <a:xfrm xmlns:a="http://schemas.openxmlformats.org/drawingml/2006/main">
-            <a:off x="3219450" y="5534025"/>
+            <a:off x="3219450" y="5143500"/>
             <a:ext cx="8191500" cy="800100"/>
           </a:xfrm>
           <a:prstGeom xmlns:a="http://schemas.openxmlformats.org/drawingml/2006/main" prst="rect">
@@ -7007,6 +6622,7 @@
           <a:lstStyle xmlns:a="http://schemas.openxmlformats.org/drawingml/2006/main"/>
           <a:p xmlns:a="http://schemas.openxmlformats.org/drawingml/2006/main">
             <a:pPr>
+              <a:buNone/>
               <a:defRPr sz="1800" b="1">
                 <a:solidFill>
                   <a:srgbClr val="A7E2D7"/>
@@ -7064,6 +6680,7 @@
           <a:lstStyle xmlns:a="http://schemas.openxmlformats.org/drawingml/2006/main"/>
           <a:p xmlns:a="http://schemas.openxmlformats.org/drawingml/2006/main">
             <a:pPr>
+              <a:buNone/>
               <a:defRPr sz="4050" b="1">
                 <a:solidFill>
                   <a:srgbClr val="FFFFFF"/>
@@ -7121,6 +6738,7 @@
           <a:lstStyle xmlns:a="http://schemas.openxmlformats.org/drawingml/2006/main"/>
           <a:p xmlns:a="http://schemas.openxmlformats.org/drawingml/2006/main">
             <a:pPr>
+              <a:buNone/>
               <a:defRPr sz="2400" b="0">
                 <a:solidFill>
                   <a:srgbClr val="FFFFFF"/>
@@ -7144,6 +6762,7 @@
           </a:p>
           <a:p xmlns:a="http://schemas.openxmlformats.org/drawingml/2006/main">
             <a:pPr>
+              <a:buNone/>
               <a:defRPr sz="2400" b="0">
                 <a:solidFill>
                   <a:srgbClr val="FFFFFF"/>
@@ -7167,6 +6786,7 @@
           </a:p>
           <a:p xmlns:a="http://schemas.openxmlformats.org/drawingml/2006/main">
             <a:pPr>
+              <a:buNone/>
               <a:defRPr sz="2400" b="0">
                 <a:solidFill>
                   <a:srgbClr val="FFFFFF"/>
@@ -7224,6 +6844,7 @@
           <a:lstStyle xmlns:a="http://schemas.openxmlformats.org/drawingml/2006/main"/>
           <a:p xmlns:a="http://schemas.openxmlformats.org/drawingml/2006/main">
             <a:pPr>
+              <a:buNone/>
               <a:defRPr sz="2250" b="0">
                 <a:solidFill>
                   <a:srgbClr val="D0D8E6"/>
@@ -7247,6 +6868,7 @@
           </a:p>
           <a:p xmlns:a="http://schemas.openxmlformats.org/drawingml/2006/main">
             <a:pPr>
+              <a:buNone/>
               <a:defRPr sz="2250" b="0">
                 <a:solidFill>
                   <a:srgbClr val="D0D8E6"/>
@@ -7270,6 +6892,7 @@
           </a:p>
           <a:p xmlns:a="http://schemas.openxmlformats.org/drawingml/2006/main">
             <a:pPr>
+              <a:buNone/>
               <a:defRPr sz="2250" b="0">
                 <a:solidFill>
                   <a:srgbClr val="D0D8E6"/>
@@ -7327,6 +6950,7 @@
           <a:lstStyle xmlns:a="http://schemas.openxmlformats.org/drawingml/2006/main"/>
           <a:p xmlns:a="http://schemas.openxmlformats.org/drawingml/2006/main">
             <a:pPr>
+              <a:buNone/>
               <a:defRPr sz="1800" b="1">
                 <a:solidFill>
                   <a:srgbClr val="A7E2D7"/>
@@ -7384,6 +7008,7 @@
           <a:lstStyle xmlns:a="http://schemas.openxmlformats.org/drawingml/2006/main"/>
           <a:p xmlns:a="http://schemas.openxmlformats.org/drawingml/2006/main">
             <a:pPr>
+              <a:buNone/>
               <a:defRPr sz="2250" b="0">
                 <a:solidFill>
                   <a:srgbClr val="FFFFFF"/>
@@ -7407,6 +7032,7 @@
           </a:p>
           <a:p xmlns:a="http://schemas.openxmlformats.org/drawingml/2006/main">
             <a:pPr>
+              <a:buNone/>
               <a:defRPr sz="2250" b="0">
                 <a:solidFill>
                   <a:srgbClr val="FFFFFF"/>
@@ -7430,6 +7056,7 @@
           </a:p>
           <a:p xmlns:a="http://schemas.openxmlformats.org/drawingml/2006/main">
             <a:pPr>
+              <a:buNone/>
               <a:defRPr sz="2250" b="0">
                 <a:solidFill>
                   <a:srgbClr val="FFFFFF"/>
@@ -7542,88 +7169,6 @@
       </p:sp>
       <p:sp>
         <p:nvSpPr>
-          <p:cNvPr id="2" name="Class duration">
-            <a:extLst xmlns:a="http://schemas.openxmlformats.org/drawingml/2006/main">
-              <a:ext uri="{FF2B5EF4-FFF2-40B4-BE49-F238E27FC236}">
-                <a16:creationId xmlns:a16="http://schemas.microsoft.com/office/drawing/2014/main" id="{88DF5405-B46E-4AE0-8554-E89F65C48B2B}"/>
-              </a:ext>
-            </a:extLst>
-          </p:cNvPr>
-          <p:cNvSpPr>
-            <a:spLocks xmlns:a="http://schemas.openxmlformats.org/drawingml/2006/main" noGrp="1"/>
-          </p:cNvSpPr>
-          <p:nvPr/>
-        </p:nvSpPr>
-        <p:spPr>
-          <a:xfrm xmlns:a="http://schemas.openxmlformats.org/drawingml/2006/main">
-            <a:off x="790575" y="2428875"/>
-            <a:ext cx="1952625" cy="857250"/>
-          </a:xfrm>
-          <a:prstGeom xmlns:a="http://schemas.openxmlformats.org/drawingml/2006/main" prst="rect">
-            <a:avLst/>
-          </a:prstGeom>
-          <a:noFill xmlns:a="http://schemas.openxmlformats.org/drawingml/2006/main"/>
-          <a:ln xmlns:a="http://schemas.openxmlformats.org/drawingml/2006/main" w="0">
-            <a:noFill/>
-          </a:ln>
-        </p:spPr>
-        <p:txBody>
-          <a:bodyPr xmlns:a="http://schemas.openxmlformats.org/drawingml/2006/main" wrap="square" lIns="0" tIns="0" rIns="0" bIns="0" anchor="t">
-            <a:noAutofit/>
-          </a:bodyPr>
-          <a:lstStyle xmlns:a="http://schemas.openxmlformats.org/drawingml/2006/main"/>
-          <a:p xmlns:a="http://schemas.openxmlformats.org/drawingml/2006/main">
-            <a:pPr>
-              <a:buNone/>
-              <a:defRPr sz="1875" b="0">
-                <a:solidFill>
-                  <a:srgbClr val="45516A"/>
-                </a:solidFill>
-                <a:latin typeface="Arial"/>
-                <a:ea typeface="Arial"/>
-                <a:cs typeface="Arial"/>
-              </a:defRPr>
-            </a:pPr>
-            <a:r>
-              <a:rPr sz="1875" b="0">
-                <a:solidFill>
-                  <a:srgbClr val="45516A"/>
-                </a:solidFill>
-                <a:latin typeface="Arial"/>
-                <a:ea typeface="Arial"/>
-                <a:cs typeface="Arial"/>
-              </a:rPr>
-              <a:t>CLASE</a:t>
-            </a:r>
-          </a:p>
-          <a:p xmlns:a="http://schemas.openxmlformats.org/drawingml/2006/main">
-            <a:pPr>
-              <a:buNone/>
-              <a:defRPr sz="1875" b="0">
-                <a:solidFill>
-                  <a:srgbClr val="45516A"/>
-                </a:solidFill>
-                <a:latin typeface="Arial"/>
-                <a:ea typeface="Arial"/>
-                <a:cs typeface="Arial"/>
-              </a:defRPr>
-            </a:pPr>
-            <a:r>
-              <a:rPr sz="1875" b="0">
-                <a:solidFill>
-                  <a:srgbClr val="45516A"/>
-                </a:solidFill>
-                <a:latin typeface="Arial"/>
-                <a:ea typeface="Arial"/>
-                <a:cs typeface="Arial"/>
-              </a:rPr>
-              <a:t>4 horas</a:t>
-            </a:r>
-          </a:p>
-        </p:txBody>
-      </p:sp>
-      <p:sp>
-        <p:nvSpPr>
           <p:cNvPr id="3" name="Class title">
             <a:extLst xmlns:a="http://schemas.openxmlformats.org/drawingml/2006/main">
               <a:ext uri="{FF2B5EF4-FFF2-40B4-BE49-F238E27FC236}">
@@ -7706,64 +7251,6 @@
       </p:sp>
       <p:sp>
         <p:nvSpPr>
-          <p:cNvPr id="4" name="Learning label">
-            <a:extLst xmlns:a="http://schemas.openxmlformats.org/drawingml/2006/main">
-              <a:ext uri="{FF2B5EF4-FFF2-40B4-BE49-F238E27FC236}">
-                <a16:creationId xmlns:a16="http://schemas.microsoft.com/office/drawing/2014/main" id="{944D773D-DF45-4B07-A429-178679A9F5FA}"/>
-              </a:ext>
-            </a:extLst>
-          </p:cNvPr>
-          <p:cNvSpPr>
-            <a:spLocks xmlns:a="http://schemas.openxmlformats.org/drawingml/2006/main" noGrp="1"/>
-          </p:cNvSpPr>
-          <p:nvPr/>
-        </p:nvSpPr>
-        <p:spPr>
-          <a:xfrm xmlns:a="http://schemas.openxmlformats.org/drawingml/2006/main">
-            <a:off x="3248025" y="3619500"/>
-            <a:ext cx="7620000" cy="314325"/>
-          </a:xfrm>
-          <a:prstGeom xmlns:a="http://schemas.openxmlformats.org/drawingml/2006/main" prst="rect">
-            <a:avLst/>
-          </a:prstGeom>
-          <a:noFill xmlns:a="http://schemas.openxmlformats.org/drawingml/2006/main"/>
-          <a:ln xmlns:a="http://schemas.openxmlformats.org/drawingml/2006/main" w="0">
-            <a:noFill/>
-          </a:ln>
-        </p:spPr>
-        <p:txBody>
-          <a:bodyPr xmlns:a="http://schemas.openxmlformats.org/drawingml/2006/main" wrap="square" lIns="0" tIns="0" rIns="0" bIns="0" anchor="t">
-            <a:noAutofit/>
-          </a:bodyPr>
-          <a:lstStyle xmlns:a="http://schemas.openxmlformats.org/drawingml/2006/main"/>
-          <a:p xmlns:a="http://schemas.openxmlformats.org/drawingml/2006/main">
-            <a:pPr>
-              <a:buNone/>
-              <a:defRPr sz="1800" b="1">
-                <a:solidFill>
-                  <a:srgbClr val="6044B6"/>
-                </a:solidFill>
-                <a:latin typeface="Arial"/>
-                <a:ea typeface="Arial"/>
-                <a:cs typeface="Arial"/>
-              </a:defRPr>
-            </a:pPr>
-            <a:r>
-              <a:rPr sz="1800" b="1">
-                <a:solidFill>
-                  <a:srgbClr val="6044B6"/>
-                </a:solidFill>
-                <a:latin typeface="Arial"/>
-                <a:ea typeface="Arial"/>
-                <a:cs typeface="Arial"/>
-              </a:rPr>
-              <a:t>APRENDERÁS</a:t>
-            </a:r>
-          </a:p>
-        </p:txBody>
-      </p:sp>
-      <p:sp>
-        <p:nvSpPr>
           <p:cNvPr id="5" name="Learning outcome">
             <a:extLst xmlns:a="http://schemas.openxmlformats.org/drawingml/2006/main">
               <a:ext uri="{FF2B5EF4-FFF2-40B4-BE49-F238E27FC236}">
@@ -7778,7 +7265,7 @@
         </p:nvSpPr>
         <p:spPr>
           <a:xfrm xmlns:a="http://schemas.openxmlformats.org/drawingml/2006/main">
-            <a:off x="3219450" y="4010025"/>
+            <a:off x="3219450" y="3905250"/>
             <a:ext cx="8191500" cy="800100"/>
           </a:xfrm>
           <a:prstGeom xmlns:a="http://schemas.openxmlformats.org/drawingml/2006/main" prst="rect">
@@ -7846,64 +7333,6 @@
       </p:sp>
       <p:sp>
         <p:nvSpPr>
-          <p:cNvPr id="6" name="Practice label">
-            <a:extLst xmlns:a="http://schemas.openxmlformats.org/drawingml/2006/main">
-              <a:ext uri="{FF2B5EF4-FFF2-40B4-BE49-F238E27FC236}">
-                <a16:creationId xmlns:a16="http://schemas.microsoft.com/office/drawing/2014/main" id="{CB579CF3-B3A4-45D2-8C06-7534F57C3A16}"/>
-              </a:ext>
-            </a:extLst>
-          </p:cNvPr>
-          <p:cNvSpPr>
-            <a:spLocks xmlns:a="http://schemas.openxmlformats.org/drawingml/2006/main" noGrp="1"/>
-          </p:cNvSpPr>
-          <p:nvPr/>
-        </p:nvSpPr>
-        <p:spPr>
-          <a:xfrm xmlns:a="http://schemas.openxmlformats.org/drawingml/2006/main">
-            <a:off x="3248025" y="5143500"/>
-            <a:ext cx="7620000" cy="314325"/>
-          </a:xfrm>
-          <a:prstGeom xmlns:a="http://schemas.openxmlformats.org/drawingml/2006/main" prst="rect">
-            <a:avLst/>
-          </a:prstGeom>
-          <a:noFill xmlns:a="http://schemas.openxmlformats.org/drawingml/2006/main"/>
-          <a:ln xmlns:a="http://schemas.openxmlformats.org/drawingml/2006/main" w="0">
-            <a:noFill/>
-          </a:ln>
-        </p:spPr>
-        <p:txBody>
-          <a:bodyPr xmlns:a="http://schemas.openxmlformats.org/drawingml/2006/main" wrap="square" lIns="0" tIns="0" rIns="0" bIns="0" anchor="t">
-            <a:noAutofit/>
-          </a:bodyPr>
-          <a:lstStyle xmlns:a="http://schemas.openxmlformats.org/drawingml/2006/main"/>
-          <a:p xmlns:a="http://schemas.openxmlformats.org/drawingml/2006/main">
-            <a:pPr>
-              <a:buNone/>
-              <a:defRPr sz="1800" b="1">
-                <a:solidFill>
-                  <a:srgbClr val="6044B6"/>
-                </a:solidFill>
-                <a:latin typeface="Arial"/>
-                <a:ea typeface="Arial"/>
-                <a:cs typeface="Arial"/>
-              </a:defRPr>
-            </a:pPr>
-            <a:r>
-              <a:rPr sz="1800" b="1">
-                <a:solidFill>
-                  <a:srgbClr val="6044B6"/>
-                </a:solidFill>
-                <a:latin typeface="Arial"/>
-                <a:ea typeface="Arial"/>
-                <a:cs typeface="Arial"/>
-              </a:rPr>
-              <a:t>HARÁS</a:t>
-            </a:r>
-          </a:p>
-        </p:txBody>
-      </p:sp>
-      <p:sp>
-        <p:nvSpPr>
           <p:cNvPr id="7" name="Practice outcome">
             <a:extLst xmlns:a="http://schemas.openxmlformats.org/drawingml/2006/main">
               <a:ext uri="{FF2B5EF4-FFF2-40B4-BE49-F238E27FC236}">
@@ -7918,7 +7347,7 @@
         </p:nvSpPr>
         <p:spPr>
           <a:xfrm xmlns:a="http://schemas.openxmlformats.org/drawingml/2006/main">
-            <a:off x="3219450" y="5534025"/>
+            <a:off x="3219450" y="5143500"/>
             <a:ext cx="8191500" cy="800100"/>
           </a:xfrm>
           <a:prstGeom xmlns:a="http://schemas.openxmlformats.org/drawingml/2006/main" prst="rect">
@@ -8153,6 +7582,7 @@
           <a:lstStyle xmlns:a="http://schemas.openxmlformats.org/drawingml/2006/main"/>
           <a:p xmlns:a="http://schemas.openxmlformats.org/drawingml/2006/main">
             <a:pPr>
+              <a:buNone/>
               <a:defRPr sz="1800" b="1">
                 <a:solidFill>
                   <a:srgbClr val="A7E2D7"/>
@@ -8210,6 +7640,7 @@
           <a:lstStyle xmlns:a="http://schemas.openxmlformats.org/drawingml/2006/main"/>
           <a:p xmlns:a="http://schemas.openxmlformats.org/drawingml/2006/main">
             <a:pPr>
+              <a:buNone/>
               <a:defRPr sz="4050" b="1">
                 <a:solidFill>
                   <a:srgbClr val="FFFFFF"/>
@@ -8267,6 +7698,7 @@
           <a:lstStyle xmlns:a="http://schemas.openxmlformats.org/drawingml/2006/main"/>
           <a:p xmlns:a="http://schemas.openxmlformats.org/drawingml/2006/main">
             <a:pPr>
+              <a:buNone/>
               <a:defRPr sz="2400" b="0">
                 <a:solidFill>
                   <a:srgbClr val="FFFFFF"/>
@@ -8290,6 +7722,7 @@
           </a:p>
           <a:p xmlns:a="http://schemas.openxmlformats.org/drawingml/2006/main">
             <a:pPr>
+              <a:buNone/>
               <a:defRPr sz="2400" b="0">
                 <a:solidFill>
                   <a:srgbClr val="FFFFFF"/>
@@ -8347,6 +7780,7 @@
           <a:lstStyle xmlns:a="http://schemas.openxmlformats.org/drawingml/2006/main"/>
           <a:p xmlns:a="http://schemas.openxmlformats.org/drawingml/2006/main">
             <a:pPr>
+              <a:buNone/>
               <a:defRPr sz="2250" b="0">
                 <a:solidFill>
                   <a:srgbClr val="D0D8E6"/>
@@ -8370,6 +7804,7 @@
           </a:p>
           <a:p xmlns:a="http://schemas.openxmlformats.org/drawingml/2006/main">
             <a:pPr>
+              <a:buNone/>
               <a:defRPr sz="2250" b="0">
                 <a:solidFill>
                   <a:srgbClr val="D0D8E6"/>
@@ -8393,6 +7828,7 @@
           </a:p>
           <a:p xmlns:a="http://schemas.openxmlformats.org/drawingml/2006/main">
             <a:pPr>
+              <a:buNone/>
               <a:defRPr sz="2250" b="0">
                 <a:solidFill>
                   <a:srgbClr val="D0D8E6"/>
@@ -8450,6 +7886,7 @@
           <a:lstStyle xmlns:a="http://schemas.openxmlformats.org/drawingml/2006/main"/>
           <a:p xmlns:a="http://schemas.openxmlformats.org/drawingml/2006/main">
             <a:pPr>
+              <a:buNone/>
               <a:defRPr sz="1800" b="1">
                 <a:solidFill>
                   <a:srgbClr val="A7E2D7"/>
@@ -8507,6 +7944,7 @@
           <a:lstStyle xmlns:a="http://schemas.openxmlformats.org/drawingml/2006/main"/>
           <a:p xmlns:a="http://schemas.openxmlformats.org/drawingml/2006/main">
             <a:pPr>
+              <a:buNone/>
               <a:defRPr sz="2250" b="0">
                 <a:solidFill>
                   <a:srgbClr val="FFFFFF"/>
@@ -8530,6 +7968,7 @@
           </a:p>
           <a:p xmlns:a="http://schemas.openxmlformats.org/drawingml/2006/main">
             <a:pPr>
+              <a:buNone/>
               <a:defRPr sz="2250" b="0">
                 <a:solidFill>
                   <a:srgbClr val="FFFFFF"/>
@@ -8642,88 +8081,6 @@
       </p:sp>
       <p:sp>
         <p:nvSpPr>
-          <p:cNvPr id="2" name="Class duration">
-            <a:extLst xmlns:a="http://schemas.openxmlformats.org/drawingml/2006/main">
-              <a:ext uri="{FF2B5EF4-FFF2-40B4-BE49-F238E27FC236}">
-                <a16:creationId xmlns:a16="http://schemas.microsoft.com/office/drawing/2014/main" id="{7F3518BC-EDD3-4DBD-B1C5-389F98DA838E}"/>
-              </a:ext>
-            </a:extLst>
-          </p:cNvPr>
-          <p:cNvSpPr>
-            <a:spLocks xmlns:a="http://schemas.openxmlformats.org/drawingml/2006/main" noGrp="1"/>
-          </p:cNvSpPr>
-          <p:nvPr/>
-        </p:nvSpPr>
-        <p:spPr>
-          <a:xfrm xmlns:a="http://schemas.openxmlformats.org/drawingml/2006/main">
-            <a:off x="790575" y="2428875"/>
-            <a:ext cx="1952625" cy="857250"/>
-          </a:xfrm>
-          <a:prstGeom xmlns:a="http://schemas.openxmlformats.org/drawingml/2006/main" prst="rect">
-            <a:avLst/>
-          </a:prstGeom>
-          <a:noFill xmlns:a="http://schemas.openxmlformats.org/drawingml/2006/main"/>
-          <a:ln xmlns:a="http://schemas.openxmlformats.org/drawingml/2006/main" w="0">
-            <a:noFill/>
-          </a:ln>
-        </p:spPr>
-        <p:txBody>
-          <a:bodyPr xmlns:a="http://schemas.openxmlformats.org/drawingml/2006/main" wrap="square" lIns="0" tIns="0" rIns="0" bIns="0" anchor="t">
-            <a:noAutofit/>
-          </a:bodyPr>
-          <a:lstStyle xmlns:a="http://schemas.openxmlformats.org/drawingml/2006/main"/>
-          <a:p xmlns:a="http://schemas.openxmlformats.org/drawingml/2006/main">
-            <a:pPr>
-              <a:buNone/>
-              <a:defRPr sz="1875" b="0">
-                <a:solidFill>
-                  <a:srgbClr val="45516A"/>
-                </a:solidFill>
-                <a:latin typeface="Arial"/>
-                <a:ea typeface="Arial"/>
-                <a:cs typeface="Arial"/>
-              </a:defRPr>
-            </a:pPr>
-            <a:r>
-              <a:rPr sz="1875" b="0">
-                <a:solidFill>
-                  <a:srgbClr val="45516A"/>
-                </a:solidFill>
-                <a:latin typeface="Arial"/>
-                <a:ea typeface="Arial"/>
-                <a:cs typeface="Arial"/>
-              </a:rPr>
-              <a:t>CLASE</a:t>
-            </a:r>
-          </a:p>
-          <a:p xmlns:a="http://schemas.openxmlformats.org/drawingml/2006/main">
-            <a:pPr>
-              <a:buNone/>
-              <a:defRPr sz="1875" b="0">
-                <a:solidFill>
-                  <a:srgbClr val="45516A"/>
-                </a:solidFill>
-                <a:latin typeface="Arial"/>
-                <a:ea typeface="Arial"/>
-                <a:cs typeface="Arial"/>
-              </a:defRPr>
-            </a:pPr>
-            <a:r>
-              <a:rPr sz="1875" b="0">
-                <a:solidFill>
-                  <a:srgbClr val="45516A"/>
-                </a:solidFill>
-                <a:latin typeface="Arial"/>
-                <a:ea typeface="Arial"/>
-                <a:cs typeface="Arial"/>
-              </a:rPr>
-              <a:t>4 horas</a:t>
-            </a:r>
-          </a:p>
-        </p:txBody>
-      </p:sp>
-      <p:sp>
-        <p:nvSpPr>
           <p:cNvPr id="3" name="Class title">
             <a:extLst xmlns:a="http://schemas.openxmlformats.org/drawingml/2006/main">
               <a:ext uri="{FF2B5EF4-FFF2-40B4-BE49-F238E27FC236}">
@@ -8782,64 +8139,6 @@
       </p:sp>
       <p:sp>
         <p:nvSpPr>
-          <p:cNvPr id="4" name="Learning label">
-            <a:extLst xmlns:a="http://schemas.openxmlformats.org/drawingml/2006/main">
-              <a:ext uri="{FF2B5EF4-FFF2-40B4-BE49-F238E27FC236}">
-                <a16:creationId xmlns:a16="http://schemas.microsoft.com/office/drawing/2014/main" id="{097A2047-AED9-462B-85F5-8EDBB38C86C9}"/>
-              </a:ext>
-            </a:extLst>
-          </p:cNvPr>
-          <p:cNvSpPr>
-            <a:spLocks xmlns:a="http://schemas.openxmlformats.org/drawingml/2006/main" noGrp="1"/>
-          </p:cNvSpPr>
-          <p:nvPr/>
-        </p:nvSpPr>
-        <p:spPr>
-          <a:xfrm xmlns:a="http://schemas.openxmlformats.org/drawingml/2006/main">
-            <a:off x="3248025" y="3619500"/>
-            <a:ext cx="7620000" cy="314325"/>
-          </a:xfrm>
-          <a:prstGeom xmlns:a="http://schemas.openxmlformats.org/drawingml/2006/main" prst="rect">
-            <a:avLst/>
-          </a:prstGeom>
-          <a:noFill xmlns:a="http://schemas.openxmlformats.org/drawingml/2006/main"/>
-          <a:ln xmlns:a="http://schemas.openxmlformats.org/drawingml/2006/main" w="0">
-            <a:noFill/>
-          </a:ln>
-        </p:spPr>
-        <p:txBody>
-          <a:bodyPr xmlns:a="http://schemas.openxmlformats.org/drawingml/2006/main" wrap="square" lIns="0" tIns="0" rIns="0" bIns="0" anchor="t">
-            <a:noAutofit/>
-          </a:bodyPr>
-          <a:lstStyle xmlns:a="http://schemas.openxmlformats.org/drawingml/2006/main"/>
-          <a:p xmlns:a="http://schemas.openxmlformats.org/drawingml/2006/main">
-            <a:pPr>
-              <a:buNone/>
-              <a:defRPr sz="1800" b="1">
-                <a:solidFill>
-                  <a:srgbClr val="6044B6"/>
-                </a:solidFill>
-                <a:latin typeface="Arial"/>
-                <a:ea typeface="Arial"/>
-                <a:cs typeface="Arial"/>
-              </a:defRPr>
-            </a:pPr>
-            <a:r>
-              <a:rPr sz="1800" b="1">
-                <a:solidFill>
-                  <a:srgbClr val="6044B6"/>
-                </a:solidFill>
-                <a:latin typeface="Arial"/>
-                <a:ea typeface="Arial"/>
-                <a:cs typeface="Arial"/>
-              </a:rPr>
-              <a:t>APRENDERÁS</a:t>
-            </a:r>
-          </a:p>
-        </p:txBody>
-      </p:sp>
-      <p:sp>
-        <p:nvSpPr>
           <p:cNvPr id="5" name="Learning outcome">
             <a:extLst xmlns:a="http://schemas.openxmlformats.org/drawingml/2006/main">
               <a:ext uri="{FF2B5EF4-FFF2-40B4-BE49-F238E27FC236}">
@@ -8854,7 +8153,7 @@
         </p:nvSpPr>
         <p:spPr>
           <a:xfrm xmlns:a="http://schemas.openxmlformats.org/drawingml/2006/main">
-            <a:off x="3219450" y="4010025"/>
+            <a:off x="3219450" y="3905250"/>
             <a:ext cx="8191500" cy="800100"/>
           </a:xfrm>
           <a:prstGeom xmlns:a="http://schemas.openxmlformats.org/drawingml/2006/main" prst="rect">
@@ -8922,64 +8221,6 @@
       </p:sp>
       <p:sp>
         <p:nvSpPr>
-          <p:cNvPr id="6" name="Practice label">
-            <a:extLst xmlns:a="http://schemas.openxmlformats.org/drawingml/2006/main">
-              <a:ext uri="{FF2B5EF4-FFF2-40B4-BE49-F238E27FC236}">
-                <a16:creationId xmlns:a16="http://schemas.microsoft.com/office/drawing/2014/main" id="{2E4A0CF8-B1F9-4408-8CB9-7B62E6DDF112}"/>
-              </a:ext>
-            </a:extLst>
-          </p:cNvPr>
-          <p:cNvSpPr>
-            <a:spLocks xmlns:a="http://schemas.openxmlformats.org/drawingml/2006/main" noGrp="1"/>
-          </p:cNvSpPr>
-          <p:nvPr/>
-        </p:nvSpPr>
-        <p:spPr>
-          <a:xfrm xmlns:a="http://schemas.openxmlformats.org/drawingml/2006/main">
-            <a:off x="3248025" y="5143500"/>
-            <a:ext cx="7620000" cy="314325"/>
-          </a:xfrm>
-          <a:prstGeom xmlns:a="http://schemas.openxmlformats.org/drawingml/2006/main" prst="rect">
-            <a:avLst/>
-          </a:prstGeom>
-          <a:noFill xmlns:a="http://schemas.openxmlformats.org/drawingml/2006/main"/>
-          <a:ln xmlns:a="http://schemas.openxmlformats.org/drawingml/2006/main" w="0">
-            <a:noFill/>
-          </a:ln>
-        </p:spPr>
-        <p:txBody>
-          <a:bodyPr xmlns:a="http://schemas.openxmlformats.org/drawingml/2006/main" wrap="square" lIns="0" tIns="0" rIns="0" bIns="0" anchor="t">
-            <a:noAutofit/>
-          </a:bodyPr>
-          <a:lstStyle xmlns:a="http://schemas.openxmlformats.org/drawingml/2006/main"/>
-          <a:p xmlns:a="http://schemas.openxmlformats.org/drawingml/2006/main">
-            <a:pPr>
-              <a:buNone/>
-              <a:defRPr sz="1800" b="1">
-                <a:solidFill>
-                  <a:srgbClr val="6044B6"/>
-                </a:solidFill>
-                <a:latin typeface="Arial"/>
-                <a:ea typeface="Arial"/>
-                <a:cs typeface="Arial"/>
-              </a:defRPr>
-            </a:pPr>
-            <a:r>
-              <a:rPr sz="1800" b="1">
-                <a:solidFill>
-                  <a:srgbClr val="6044B6"/>
-                </a:solidFill>
-                <a:latin typeface="Arial"/>
-                <a:ea typeface="Arial"/>
-                <a:cs typeface="Arial"/>
-              </a:rPr>
-              <a:t>HARÁS</a:t>
-            </a:r>
-          </a:p>
-        </p:txBody>
-      </p:sp>
-      <p:sp>
-        <p:nvSpPr>
           <p:cNvPr id="7" name="Practice outcome">
             <a:extLst xmlns:a="http://schemas.openxmlformats.org/drawingml/2006/main">
               <a:ext uri="{FF2B5EF4-FFF2-40B4-BE49-F238E27FC236}">
@@ -8994,7 +8235,7 @@
         </p:nvSpPr>
         <p:spPr>
           <a:xfrm xmlns:a="http://schemas.openxmlformats.org/drawingml/2006/main">
-            <a:off x="3219450" y="5534025"/>
+            <a:off x="3219450" y="5143500"/>
             <a:ext cx="8191500" cy="800100"/>
           </a:xfrm>
           <a:prstGeom xmlns:a="http://schemas.openxmlformats.org/drawingml/2006/main" prst="rect">
@@ -9229,6 +8470,7 @@
           <a:lstStyle xmlns:a="http://schemas.openxmlformats.org/drawingml/2006/main"/>
           <a:p xmlns:a="http://schemas.openxmlformats.org/drawingml/2006/main">
             <a:pPr>
+              <a:buNone/>
               <a:defRPr sz="1800" b="1">
                 <a:solidFill>
                   <a:srgbClr val="A7E2D7"/>
@@ -9286,6 +8528,7 @@
           <a:lstStyle xmlns:a="http://schemas.openxmlformats.org/drawingml/2006/main"/>
           <a:p xmlns:a="http://schemas.openxmlformats.org/drawingml/2006/main">
             <a:pPr>
+              <a:buNone/>
               <a:defRPr sz="4050" b="1">
                 <a:solidFill>
                   <a:srgbClr val="FFFFFF"/>
@@ -9343,6 +8586,7 @@
           <a:lstStyle xmlns:a="http://schemas.openxmlformats.org/drawingml/2006/main"/>
           <a:p xmlns:a="http://schemas.openxmlformats.org/drawingml/2006/main">
             <a:pPr>
+              <a:buNone/>
               <a:defRPr sz="2400" b="0">
                 <a:solidFill>
                   <a:srgbClr val="FFFFFF"/>
@@ -9366,6 +8610,7 @@
           </a:p>
           <a:p xmlns:a="http://schemas.openxmlformats.org/drawingml/2006/main">
             <a:pPr>
+              <a:buNone/>
               <a:defRPr sz="2400" b="0">
                 <a:solidFill>
                   <a:srgbClr val="FFFFFF"/>
@@ -9389,6 +8634,7 @@
           </a:p>
           <a:p xmlns:a="http://schemas.openxmlformats.org/drawingml/2006/main">
             <a:pPr>
+              <a:buNone/>
               <a:defRPr sz="2400" b="0">
                 <a:solidFill>
                   <a:srgbClr val="FFFFFF"/>
@@ -9446,6 +8692,7 @@
           <a:lstStyle xmlns:a="http://schemas.openxmlformats.org/drawingml/2006/main"/>
           <a:p xmlns:a="http://schemas.openxmlformats.org/drawingml/2006/main">
             <a:pPr>
+              <a:buNone/>
               <a:defRPr sz="2250" b="0">
                 <a:solidFill>
                   <a:srgbClr val="D0D8E6"/>
@@ -9469,6 +8716,7 @@
           </a:p>
           <a:p xmlns:a="http://schemas.openxmlformats.org/drawingml/2006/main">
             <a:pPr>
+              <a:buNone/>
               <a:defRPr sz="2250" b="0">
                 <a:solidFill>
                   <a:srgbClr val="D0D8E6"/>
@@ -9492,6 +8740,7 @@
           </a:p>
           <a:p xmlns:a="http://schemas.openxmlformats.org/drawingml/2006/main">
             <a:pPr>
+              <a:buNone/>
               <a:defRPr sz="2250" b="0">
                 <a:solidFill>
                   <a:srgbClr val="D0D8E6"/>
@@ -9549,6 +8798,7 @@
           <a:lstStyle xmlns:a="http://schemas.openxmlformats.org/drawingml/2006/main"/>
           <a:p xmlns:a="http://schemas.openxmlformats.org/drawingml/2006/main">
             <a:pPr>
+              <a:buNone/>
               <a:defRPr sz="1800" b="1">
                 <a:solidFill>
                   <a:srgbClr val="A7E2D7"/>
@@ -9606,6 +8856,7 @@
           <a:lstStyle xmlns:a="http://schemas.openxmlformats.org/drawingml/2006/main"/>
           <a:p xmlns:a="http://schemas.openxmlformats.org/drawingml/2006/main">
             <a:pPr>
+              <a:buNone/>
               <a:defRPr sz="2250" b="0">
                 <a:solidFill>
                   <a:srgbClr val="FFFFFF"/>
@@ -9629,6 +8880,7 @@
           </a:p>
           <a:p xmlns:a="http://schemas.openxmlformats.org/drawingml/2006/main">
             <a:pPr>
+              <a:buNone/>
               <a:defRPr sz="2250" b="0">
                 <a:solidFill>
                   <a:srgbClr val="FFFFFF"/>
@@ -9652,6 +8904,7 @@
           </a:p>
           <a:p xmlns:a="http://schemas.openxmlformats.org/drawingml/2006/main">
             <a:pPr>
+              <a:buNone/>
               <a:defRPr sz="2250" b="0">
                 <a:solidFill>
                   <a:srgbClr val="FFFFFF"/>
@@ -9764,88 +9017,6 @@
       </p:sp>
       <p:sp>
         <p:nvSpPr>
-          <p:cNvPr id="2" name="Class duration">
-            <a:extLst xmlns:a="http://schemas.openxmlformats.org/drawingml/2006/main">
-              <a:ext uri="{FF2B5EF4-FFF2-40B4-BE49-F238E27FC236}">
-                <a16:creationId xmlns:a16="http://schemas.microsoft.com/office/drawing/2014/main" id="{2CFDA9E2-954E-43C4-8D60-718D1E4CECD0}"/>
-              </a:ext>
-            </a:extLst>
-          </p:cNvPr>
-          <p:cNvSpPr>
-            <a:spLocks xmlns:a="http://schemas.openxmlformats.org/drawingml/2006/main" noGrp="1"/>
-          </p:cNvSpPr>
-          <p:nvPr/>
-        </p:nvSpPr>
-        <p:spPr>
-          <a:xfrm xmlns:a="http://schemas.openxmlformats.org/drawingml/2006/main">
-            <a:off x="790575" y="2428875"/>
-            <a:ext cx="1952625" cy="857250"/>
-          </a:xfrm>
-          <a:prstGeom xmlns:a="http://schemas.openxmlformats.org/drawingml/2006/main" prst="rect">
-            <a:avLst/>
-          </a:prstGeom>
-          <a:noFill xmlns:a="http://schemas.openxmlformats.org/drawingml/2006/main"/>
-          <a:ln xmlns:a="http://schemas.openxmlformats.org/drawingml/2006/main" w="0">
-            <a:noFill/>
-          </a:ln>
-        </p:spPr>
-        <p:txBody>
-          <a:bodyPr xmlns:a="http://schemas.openxmlformats.org/drawingml/2006/main" wrap="square" lIns="0" tIns="0" rIns="0" bIns="0" anchor="t">
-            <a:noAutofit/>
-          </a:bodyPr>
-          <a:lstStyle xmlns:a="http://schemas.openxmlformats.org/drawingml/2006/main"/>
-          <a:p xmlns:a="http://schemas.openxmlformats.org/drawingml/2006/main">
-            <a:pPr>
-              <a:buNone/>
-              <a:defRPr sz="1875" b="0">
-                <a:solidFill>
-                  <a:srgbClr val="45516A"/>
-                </a:solidFill>
-                <a:latin typeface="Arial"/>
-                <a:ea typeface="Arial"/>
-                <a:cs typeface="Arial"/>
-              </a:defRPr>
-            </a:pPr>
-            <a:r>
-              <a:rPr sz="1875" b="0">
-                <a:solidFill>
-                  <a:srgbClr val="45516A"/>
-                </a:solidFill>
-                <a:latin typeface="Arial"/>
-                <a:ea typeface="Arial"/>
-                <a:cs typeface="Arial"/>
-              </a:rPr>
-              <a:t>CLASE</a:t>
-            </a:r>
-          </a:p>
-          <a:p xmlns:a="http://schemas.openxmlformats.org/drawingml/2006/main">
-            <a:pPr>
-              <a:buNone/>
-              <a:defRPr sz="1875" b="0">
-                <a:solidFill>
-                  <a:srgbClr val="45516A"/>
-                </a:solidFill>
-                <a:latin typeface="Arial"/>
-                <a:ea typeface="Arial"/>
-                <a:cs typeface="Arial"/>
-              </a:defRPr>
-            </a:pPr>
-            <a:r>
-              <a:rPr sz="1875" b="0">
-                <a:solidFill>
-                  <a:srgbClr val="45516A"/>
-                </a:solidFill>
-                <a:latin typeface="Arial"/>
-                <a:ea typeface="Arial"/>
-                <a:cs typeface="Arial"/>
-              </a:rPr>
-              <a:t>4 horas</a:t>
-            </a:r>
-          </a:p>
-        </p:txBody>
-      </p:sp>
-      <p:sp>
-        <p:nvSpPr>
           <p:cNvPr id="3" name="Class title">
             <a:extLst xmlns:a="http://schemas.openxmlformats.org/drawingml/2006/main">
               <a:ext uri="{FF2B5EF4-FFF2-40B4-BE49-F238E27FC236}">
@@ -9928,64 +9099,6 @@
       </p:sp>
       <p:sp>
         <p:nvSpPr>
-          <p:cNvPr id="4" name="Learning label">
-            <a:extLst xmlns:a="http://schemas.openxmlformats.org/drawingml/2006/main">
-              <a:ext uri="{FF2B5EF4-FFF2-40B4-BE49-F238E27FC236}">
-                <a16:creationId xmlns:a16="http://schemas.microsoft.com/office/drawing/2014/main" id="{24866873-9C86-4F33-B021-63C12E0C6E56}"/>
-              </a:ext>
-            </a:extLst>
-          </p:cNvPr>
-          <p:cNvSpPr>
-            <a:spLocks xmlns:a="http://schemas.openxmlformats.org/drawingml/2006/main" noGrp="1"/>
-          </p:cNvSpPr>
-          <p:nvPr/>
-        </p:nvSpPr>
-        <p:spPr>
-          <a:xfrm xmlns:a="http://schemas.openxmlformats.org/drawingml/2006/main">
-            <a:off x="3248025" y="3619500"/>
-            <a:ext cx="7620000" cy="314325"/>
-          </a:xfrm>
-          <a:prstGeom xmlns:a="http://schemas.openxmlformats.org/drawingml/2006/main" prst="rect">
-            <a:avLst/>
-          </a:prstGeom>
-          <a:noFill xmlns:a="http://schemas.openxmlformats.org/drawingml/2006/main"/>
-          <a:ln xmlns:a="http://schemas.openxmlformats.org/drawingml/2006/main" w="0">
-            <a:noFill/>
-          </a:ln>
-        </p:spPr>
-        <p:txBody>
-          <a:bodyPr xmlns:a="http://schemas.openxmlformats.org/drawingml/2006/main" wrap="square" lIns="0" tIns="0" rIns="0" bIns="0" anchor="t">
-            <a:noAutofit/>
-          </a:bodyPr>
-          <a:lstStyle xmlns:a="http://schemas.openxmlformats.org/drawingml/2006/main"/>
-          <a:p xmlns:a="http://schemas.openxmlformats.org/drawingml/2006/main">
-            <a:pPr>
-              <a:buNone/>
-              <a:defRPr sz="1800" b="1">
-                <a:solidFill>
-                  <a:srgbClr val="6044B6"/>
-                </a:solidFill>
-                <a:latin typeface="Arial"/>
-                <a:ea typeface="Arial"/>
-                <a:cs typeface="Arial"/>
-              </a:defRPr>
-            </a:pPr>
-            <a:r>
-              <a:rPr sz="1800" b="1">
-                <a:solidFill>
-                  <a:srgbClr val="6044B6"/>
-                </a:solidFill>
-                <a:latin typeface="Arial"/>
-                <a:ea typeface="Arial"/>
-                <a:cs typeface="Arial"/>
-              </a:rPr>
-              <a:t>APRENDERÁS</a:t>
-            </a:r>
-          </a:p>
-        </p:txBody>
-      </p:sp>
-      <p:sp>
-        <p:nvSpPr>
           <p:cNvPr id="5" name="Learning outcome">
             <a:extLst xmlns:a="http://schemas.openxmlformats.org/drawingml/2006/main">
               <a:ext uri="{FF2B5EF4-FFF2-40B4-BE49-F238E27FC236}">
@@ -10000,7 +9113,7 @@
         </p:nvSpPr>
         <p:spPr>
           <a:xfrm xmlns:a="http://schemas.openxmlformats.org/drawingml/2006/main">
-            <a:off x="3219450" y="4010025"/>
+            <a:off x="3219450" y="3905250"/>
             <a:ext cx="8191500" cy="800100"/>
           </a:xfrm>
           <a:prstGeom xmlns:a="http://schemas.openxmlformats.org/drawingml/2006/main" prst="rect">
@@ -10068,64 +9181,6 @@
       </p:sp>
       <p:sp>
         <p:nvSpPr>
-          <p:cNvPr id="6" name="Practice label">
-            <a:extLst xmlns:a="http://schemas.openxmlformats.org/drawingml/2006/main">
-              <a:ext uri="{FF2B5EF4-FFF2-40B4-BE49-F238E27FC236}">
-                <a16:creationId xmlns:a16="http://schemas.microsoft.com/office/drawing/2014/main" id="{4BA663B4-5439-4AAB-945F-B55BEC8C5593}"/>
-              </a:ext>
-            </a:extLst>
-          </p:cNvPr>
-          <p:cNvSpPr>
-            <a:spLocks xmlns:a="http://schemas.openxmlformats.org/drawingml/2006/main" noGrp="1"/>
-          </p:cNvSpPr>
-          <p:nvPr/>
-        </p:nvSpPr>
-        <p:spPr>
-          <a:xfrm xmlns:a="http://schemas.openxmlformats.org/drawingml/2006/main">
-            <a:off x="3248025" y="5143500"/>
-            <a:ext cx="7620000" cy="314325"/>
-          </a:xfrm>
-          <a:prstGeom xmlns:a="http://schemas.openxmlformats.org/drawingml/2006/main" prst="rect">
-            <a:avLst/>
-          </a:prstGeom>
-          <a:noFill xmlns:a="http://schemas.openxmlformats.org/drawingml/2006/main"/>
-          <a:ln xmlns:a="http://schemas.openxmlformats.org/drawingml/2006/main" w="0">
-            <a:noFill/>
-          </a:ln>
-        </p:spPr>
-        <p:txBody>
-          <a:bodyPr xmlns:a="http://schemas.openxmlformats.org/drawingml/2006/main" wrap="square" lIns="0" tIns="0" rIns="0" bIns="0" anchor="t">
-            <a:noAutofit/>
-          </a:bodyPr>
-          <a:lstStyle xmlns:a="http://schemas.openxmlformats.org/drawingml/2006/main"/>
-          <a:p xmlns:a="http://schemas.openxmlformats.org/drawingml/2006/main">
-            <a:pPr>
-              <a:buNone/>
-              <a:defRPr sz="1800" b="1">
-                <a:solidFill>
-                  <a:srgbClr val="6044B6"/>
-                </a:solidFill>
-                <a:latin typeface="Arial"/>
-                <a:ea typeface="Arial"/>
-                <a:cs typeface="Arial"/>
-              </a:defRPr>
-            </a:pPr>
-            <a:r>
-              <a:rPr sz="1800" b="1">
-                <a:solidFill>
-                  <a:srgbClr val="6044B6"/>
-                </a:solidFill>
-                <a:latin typeface="Arial"/>
-                <a:ea typeface="Arial"/>
-                <a:cs typeface="Arial"/>
-              </a:rPr>
-              <a:t>HARÁS</a:t>
-            </a:r>
-          </a:p>
-        </p:txBody>
-      </p:sp>
-      <p:sp>
-        <p:nvSpPr>
           <p:cNvPr id="7" name="Practice outcome">
             <a:extLst xmlns:a="http://schemas.openxmlformats.org/drawingml/2006/main">
               <a:ext uri="{FF2B5EF4-FFF2-40B4-BE49-F238E27FC236}">
@@ -10140,7 +9195,7 @@
         </p:nvSpPr>
         <p:spPr>
           <a:xfrm xmlns:a="http://schemas.openxmlformats.org/drawingml/2006/main">
-            <a:off x="3219450" y="5534025"/>
+            <a:off x="3219450" y="5143500"/>
             <a:ext cx="8191500" cy="800100"/>
           </a:xfrm>
           <a:prstGeom xmlns:a="http://schemas.openxmlformats.org/drawingml/2006/main" prst="rect">
@@ -10375,6 +9430,7 @@
           <a:lstStyle xmlns:a="http://schemas.openxmlformats.org/drawingml/2006/main"/>
           <a:p xmlns:a="http://schemas.openxmlformats.org/drawingml/2006/main">
             <a:pPr>
+              <a:buNone/>
               <a:defRPr sz="1800" b="1">
                 <a:solidFill>
                   <a:srgbClr val="A7E2D7"/>
@@ -10432,6 +9488,7 @@
           <a:lstStyle xmlns:a="http://schemas.openxmlformats.org/drawingml/2006/main"/>
           <a:p xmlns:a="http://schemas.openxmlformats.org/drawingml/2006/main">
             <a:pPr>
+              <a:buNone/>
               <a:defRPr sz="4050" b="1">
                 <a:solidFill>
                   <a:srgbClr val="FFFFFF"/>
@@ -10489,6 +9546,7 @@
           <a:lstStyle xmlns:a="http://schemas.openxmlformats.org/drawingml/2006/main"/>
           <a:p xmlns:a="http://schemas.openxmlformats.org/drawingml/2006/main">
             <a:pPr>
+              <a:buNone/>
               <a:defRPr sz="2400" b="0">
                 <a:solidFill>
                   <a:srgbClr val="FFFFFF"/>
@@ -10512,6 +9570,7 @@
           </a:p>
           <a:p xmlns:a="http://schemas.openxmlformats.org/drawingml/2006/main">
             <a:pPr>
+              <a:buNone/>
               <a:defRPr sz="2400" b="0">
                 <a:solidFill>
                   <a:srgbClr val="FFFFFF"/>
@@ -10569,6 +9628,7 @@
           <a:lstStyle xmlns:a="http://schemas.openxmlformats.org/drawingml/2006/main"/>
           <a:p xmlns:a="http://schemas.openxmlformats.org/drawingml/2006/main">
             <a:pPr>
+              <a:buNone/>
               <a:defRPr sz="2250" b="0">
                 <a:solidFill>
                   <a:srgbClr val="D0D8E6"/>
@@ -10592,6 +9652,7 @@
           </a:p>
           <a:p xmlns:a="http://schemas.openxmlformats.org/drawingml/2006/main">
             <a:pPr>
+              <a:buNone/>
               <a:defRPr sz="2250" b="0">
                 <a:solidFill>
                   <a:srgbClr val="D0D8E6"/>
@@ -10615,6 +9676,7 @@
           </a:p>
           <a:p xmlns:a="http://schemas.openxmlformats.org/drawingml/2006/main">
             <a:pPr>
+              <a:buNone/>
               <a:defRPr sz="2250" b="0">
                 <a:solidFill>
                   <a:srgbClr val="D0D8E6"/>
@@ -10672,6 +9734,7 @@
           <a:lstStyle xmlns:a="http://schemas.openxmlformats.org/drawingml/2006/main"/>
           <a:p xmlns:a="http://schemas.openxmlformats.org/drawingml/2006/main">
             <a:pPr>
+              <a:buNone/>
               <a:defRPr sz="1800" b="1">
                 <a:solidFill>
                   <a:srgbClr val="A7E2D7"/>
@@ -10729,6 +9792,7 @@
           <a:lstStyle xmlns:a="http://schemas.openxmlformats.org/drawingml/2006/main"/>
           <a:p xmlns:a="http://schemas.openxmlformats.org/drawingml/2006/main">
             <a:pPr>
+              <a:buNone/>
               <a:defRPr sz="2250" b="0">
                 <a:solidFill>
                   <a:srgbClr val="FFFFFF"/>
@@ -10752,6 +9816,7 @@
           </a:p>
           <a:p xmlns:a="http://schemas.openxmlformats.org/drawingml/2006/main">
             <a:pPr>
+              <a:buNone/>
               <a:defRPr sz="2250" b="0">
                 <a:solidFill>
                   <a:srgbClr val="FFFFFF"/>
@@ -10775,6 +9840,7 @@
           </a:p>
           <a:p xmlns:a="http://schemas.openxmlformats.org/drawingml/2006/main">
             <a:pPr>
+              <a:buNone/>
               <a:defRPr sz="2250" b="0">
                 <a:solidFill>
                   <a:srgbClr val="FFFFFF"/>
@@ -11138,88 +10204,6 @@
       </p:sp>
       <p:sp>
         <p:nvSpPr>
-          <p:cNvPr id="2" name="Class duration">
-            <a:extLst xmlns:a="http://schemas.openxmlformats.org/drawingml/2006/main">
-              <a:ext uri="{FF2B5EF4-FFF2-40B4-BE49-F238E27FC236}">
-                <a16:creationId xmlns:a16="http://schemas.microsoft.com/office/drawing/2014/main" id="{0AE636C9-A8F3-4807-9493-CF4DE75312F8}"/>
-              </a:ext>
-            </a:extLst>
-          </p:cNvPr>
-          <p:cNvSpPr>
-            <a:spLocks xmlns:a="http://schemas.openxmlformats.org/drawingml/2006/main" noGrp="1"/>
-          </p:cNvSpPr>
-          <p:nvPr/>
-        </p:nvSpPr>
-        <p:spPr>
-          <a:xfrm xmlns:a="http://schemas.openxmlformats.org/drawingml/2006/main">
-            <a:off x="790575" y="2428875"/>
-            <a:ext cx="1952625" cy="857250"/>
-          </a:xfrm>
-          <a:prstGeom xmlns:a="http://schemas.openxmlformats.org/drawingml/2006/main" prst="rect">
-            <a:avLst/>
-          </a:prstGeom>
-          <a:noFill xmlns:a="http://schemas.openxmlformats.org/drawingml/2006/main"/>
-          <a:ln xmlns:a="http://schemas.openxmlformats.org/drawingml/2006/main" w="0">
-            <a:noFill/>
-          </a:ln>
-        </p:spPr>
-        <p:txBody>
-          <a:bodyPr xmlns:a="http://schemas.openxmlformats.org/drawingml/2006/main" wrap="square" lIns="0" tIns="0" rIns="0" bIns="0" anchor="t">
-            <a:noAutofit/>
-          </a:bodyPr>
-          <a:lstStyle xmlns:a="http://schemas.openxmlformats.org/drawingml/2006/main"/>
-          <a:p xmlns:a="http://schemas.openxmlformats.org/drawingml/2006/main">
-            <a:pPr>
-              <a:buNone/>
-              <a:defRPr sz="1875" b="0">
-                <a:solidFill>
-                  <a:srgbClr val="45516A"/>
-                </a:solidFill>
-                <a:latin typeface="Arial"/>
-                <a:ea typeface="Arial"/>
-                <a:cs typeface="Arial"/>
-              </a:defRPr>
-            </a:pPr>
-            <a:r>
-              <a:rPr sz="1875" b="0">
-                <a:solidFill>
-                  <a:srgbClr val="45516A"/>
-                </a:solidFill>
-                <a:latin typeface="Arial"/>
-                <a:ea typeface="Arial"/>
-                <a:cs typeface="Arial"/>
-              </a:rPr>
-              <a:t>CLASE</a:t>
-            </a:r>
-          </a:p>
-          <a:p xmlns:a="http://schemas.openxmlformats.org/drawingml/2006/main">
-            <a:pPr>
-              <a:buNone/>
-              <a:defRPr sz="1875" b="0">
-                <a:solidFill>
-                  <a:srgbClr val="45516A"/>
-                </a:solidFill>
-                <a:latin typeface="Arial"/>
-                <a:ea typeface="Arial"/>
-                <a:cs typeface="Arial"/>
-              </a:defRPr>
-            </a:pPr>
-            <a:r>
-              <a:rPr sz="1875" b="0">
-                <a:solidFill>
-                  <a:srgbClr val="45516A"/>
-                </a:solidFill>
-                <a:latin typeface="Arial"/>
-                <a:ea typeface="Arial"/>
-                <a:cs typeface="Arial"/>
-              </a:rPr>
-              <a:t>4 horas</a:t>
-            </a:r>
-          </a:p>
-        </p:txBody>
-      </p:sp>
-      <p:sp>
-        <p:nvSpPr>
           <p:cNvPr id="3" name="Class title">
             <a:extLst xmlns:a="http://schemas.openxmlformats.org/drawingml/2006/main">
               <a:ext uri="{FF2B5EF4-FFF2-40B4-BE49-F238E27FC236}">
@@ -11302,64 +10286,6 @@
       </p:sp>
       <p:sp>
         <p:nvSpPr>
-          <p:cNvPr id="4" name="Learning label">
-            <a:extLst xmlns:a="http://schemas.openxmlformats.org/drawingml/2006/main">
-              <a:ext uri="{FF2B5EF4-FFF2-40B4-BE49-F238E27FC236}">
-                <a16:creationId xmlns:a16="http://schemas.microsoft.com/office/drawing/2014/main" id="{E6F4B20F-DB27-4901-B7DA-E2638CD035A6}"/>
-              </a:ext>
-            </a:extLst>
-          </p:cNvPr>
-          <p:cNvSpPr>
-            <a:spLocks xmlns:a="http://schemas.openxmlformats.org/drawingml/2006/main" noGrp="1"/>
-          </p:cNvSpPr>
-          <p:nvPr/>
-        </p:nvSpPr>
-        <p:spPr>
-          <a:xfrm xmlns:a="http://schemas.openxmlformats.org/drawingml/2006/main">
-            <a:off x="3248025" y="3619500"/>
-            <a:ext cx="7620000" cy="314325"/>
-          </a:xfrm>
-          <a:prstGeom xmlns:a="http://schemas.openxmlformats.org/drawingml/2006/main" prst="rect">
-            <a:avLst/>
-          </a:prstGeom>
-          <a:noFill xmlns:a="http://schemas.openxmlformats.org/drawingml/2006/main"/>
-          <a:ln xmlns:a="http://schemas.openxmlformats.org/drawingml/2006/main" w="0">
-            <a:noFill/>
-          </a:ln>
-        </p:spPr>
-        <p:txBody>
-          <a:bodyPr xmlns:a="http://schemas.openxmlformats.org/drawingml/2006/main" wrap="square" lIns="0" tIns="0" rIns="0" bIns="0" anchor="t">
-            <a:noAutofit/>
-          </a:bodyPr>
-          <a:lstStyle xmlns:a="http://schemas.openxmlformats.org/drawingml/2006/main"/>
-          <a:p xmlns:a="http://schemas.openxmlformats.org/drawingml/2006/main">
-            <a:pPr>
-              <a:buNone/>
-              <a:defRPr sz="1800" b="1">
-                <a:solidFill>
-                  <a:srgbClr val="6044B6"/>
-                </a:solidFill>
-                <a:latin typeface="Arial"/>
-                <a:ea typeface="Arial"/>
-                <a:cs typeface="Arial"/>
-              </a:defRPr>
-            </a:pPr>
-            <a:r>
-              <a:rPr sz="1800" b="1">
-                <a:solidFill>
-                  <a:srgbClr val="6044B6"/>
-                </a:solidFill>
-                <a:latin typeface="Arial"/>
-                <a:ea typeface="Arial"/>
-                <a:cs typeface="Arial"/>
-              </a:rPr>
-              <a:t>APRENDERÁS</a:t>
-            </a:r>
-          </a:p>
-        </p:txBody>
-      </p:sp>
-      <p:sp>
-        <p:nvSpPr>
           <p:cNvPr id="5" name="Learning outcome">
             <a:extLst xmlns:a="http://schemas.openxmlformats.org/drawingml/2006/main">
               <a:ext uri="{FF2B5EF4-FFF2-40B4-BE49-F238E27FC236}">
@@ -11374,7 +10300,7 @@
         </p:nvSpPr>
         <p:spPr>
           <a:xfrm xmlns:a="http://schemas.openxmlformats.org/drawingml/2006/main">
-            <a:off x="3219450" y="4010025"/>
+            <a:off x="3219450" y="3905250"/>
             <a:ext cx="8191500" cy="800100"/>
           </a:xfrm>
           <a:prstGeom xmlns:a="http://schemas.openxmlformats.org/drawingml/2006/main" prst="rect">
@@ -11442,64 +10368,6 @@
       </p:sp>
       <p:sp>
         <p:nvSpPr>
-          <p:cNvPr id="6" name="Practice label">
-            <a:extLst xmlns:a="http://schemas.openxmlformats.org/drawingml/2006/main">
-              <a:ext uri="{FF2B5EF4-FFF2-40B4-BE49-F238E27FC236}">
-                <a16:creationId xmlns:a16="http://schemas.microsoft.com/office/drawing/2014/main" id="{E2969768-4316-447A-B242-F364DF5DF071}"/>
-              </a:ext>
-            </a:extLst>
-          </p:cNvPr>
-          <p:cNvSpPr>
-            <a:spLocks xmlns:a="http://schemas.openxmlformats.org/drawingml/2006/main" noGrp="1"/>
-          </p:cNvSpPr>
-          <p:nvPr/>
-        </p:nvSpPr>
-        <p:spPr>
-          <a:xfrm xmlns:a="http://schemas.openxmlformats.org/drawingml/2006/main">
-            <a:off x="3248025" y="5143500"/>
-            <a:ext cx="7620000" cy="314325"/>
-          </a:xfrm>
-          <a:prstGeom xmlns:a="http://schemas.openxmlformats.org/drawingml/2006/main" prst="rect">
-            <a:avLst/>
-          </a:prstGeom>
-          <a:noFill xmlns:a="http://schemas.openxmlformats.org/drawingml/2006/main"/>
-          <a:ln xmlns:a="http://schemas.openxmlformats.org/drawingml/2006/main" w="0">
-            <a:noFill/>
-          </a:ln>
-        </p:spPr>
-        <p:txBody>
-          <a:bodyPr xmlns:a="http://schemas.openxmlformats.org/drawingml/2006/main" wrap="square" lIns="0" tIns="0" rIns="0" bIns="0" anchor="t">
-            <a:noAutofit/>
-          </a:bodyPr>
-          <a:lstStyle xmlns:a="http://schemas.openxmlformats.org/drawingml/2006/main"/>
-          <a:p xmlns:a="http://schemas.openxmlformats.org/drawingml/2006/main">
-            <a:pPr>
-              <a:buNone/>
-              <a:defRPr sz="1800" b="1">
-                <a:solidFill>
-                  <a:srgbClr val="6044B6"/>
-                </a:solidFill>
-                <a:latin typeface="Arial"/>
-                <a:ea typeface="Arial"/>
-                <a:cs typeface="Arial"/>
-              </a:defRPr>
-            </a:pPr>
-            <a:r>
-              <a:rPr sz="1800" b="1">
-                <a:solidFill>
-                  <a:srgbClr val="6044B6"/>
-                </a:solidFill>
-                <a:latin typeface="Arial"/>
-                <a:ea typeface="Arial"/>
-                <a:cs typeface="Arial"/>
-              </a:rPr>
-              <a:t>HARÁS</a:t>
-            </a:r>
-          </a:p>
-        </p:txBody>
-      </p:sp>
-      <p:sp>
-        <p:nvSpPr>
           <p:cNvPr id="7" name="Practice outcome">
             <a:extLst xmlns:a="http://schemas.openxmlformats.org/drawingml/2006/main">
               <a:ext uri="{FF2B5EF4-FFF2-40B4-BE49-F238E27FC236}">
@@ -11514,7 +10382,7 @@
         </p:nvSpPr>
         <p:spPr>
           <a:xfrm xmlns:a="http://schemas.openxmlformats.org/drawingml/2006/main">
-            <a:off x="3219450" y="5534025"/>
+            <a:off x="3219450" y="5143500"/>
             <a:ext cx="8191500" cy="800100"/>
           </a:xfrm>
           <a:prstGeom xmlns:a="http://schemas.openxmlformats.org/drawingml/2006/main" prst="rect">
@@ -11749,6 +10617,7 @@
           <a:lstStyle xmlns:a="http://schemas.openxmlformats.org/drawingml/2006/main"/>
           <a:p xmlns:a="http://schemas.openxmlformats.org/drawingml/2006/main">
             <a:pPr>
+              <a:buNone/>
               <a:defRPr sz="1800" b="1">
                 <a:solidFill>
                   <a:srgbClr val="A7E2D7"/>
@@ -11806,6 +10675,7 @@
           <a:lstStyle xmlns:a="http://schemas.openxmlformats.org/drawingml/2006/main"/>
           <a:p xmlns:a="http://schemas.openxmlformats.org/drawingml/2006/main">
             <a:pPr>
+              <a:buNone/>
               <a:defRPr sz="4050" b="1">
                 <a:solidFill>
                   <a:srgbClr val="FFFFFF"/>
@@ -11863,6 +10733,7 @@
           <a:lstStyle xmlns:a="http://schemas.openxmlformats.org/drawingml/2006/main"/>
           <a:p xmlns:a="http://schemas.openxmlformats.org/drawingml/2006/main">
             <a:pPr>
+              <a:buNone/>
               <a:defRPr sz="2400" b="0">
                 <a:solidFill>
                   <a:srgbClr val="FFFFFF"/>
@@ -11886,6 +10757,7 @@
           </a:p>
           <a:p xmlns:a="http://schemas.openxmlformats.org/drawingml/2006/main">
             <a:pPr>
+              <a:buNone/>
               <a:defRPr sz="2400" b="0">
                 <a:solidFill>
                   <a:srgbClr val="FFFFFF"/>
@@ -11909,6 +10781,7 @@
           </a:p>
           <a:p xmlns:a="http://schemas.openxmlformats.org/drawingml/2006/main">
             <a:pPr>
+              <a:buNone/>
               <a:defRPr sz="2400" b="0">
                 <a:solidFill>
                   <a:srgbClr val="FFFFFF"/>
@@ -11966,6 +10839,7 @@
           <a:lstStyle xmlns:a="http://schemas.openxmlformats.org/drawingml/2006/main"/>
           <a:p xmlns:a="http://schemas.openxmlformats.org/drawingml/2006/main">
             <a:pPr>
+              <a:buNone/>
               <a:defRPr sz="2250" b="0">
                 <a:solidFill>
                   <a:srgbClr val="D0D8E6"/>
@@ -11989,6 +10863,7 @@
           </a:p>
           <a:p xmlns:a="http://schemas.openxmlformats.org/drawingml/2006/main">
             <a:pPr>
+              <a:buNone/>
               <a:defRPr sz="2250" b="0">
                 <a:solidFill>
                   <a:srgbClr val="D0D8E6"/>
@@ -12012,6 +10887,7 @@
           </a:p>
           <a:p xmlns:a="http://schemas.openxmlformats.org/drawingml/2006/main">
             <a:pPr>
+              <a:buNone/>
               <a:defRPr sz="2250" b="0">
                 <a:solidFill>
                   <a:srgbClr val="D0D8E6"/>
@@ -12069,6 +10945,7 @@
           <a:lstStyle xmlns:a="http://schemas.openxmlformats.org/drawingml/2006/main"/>
           <a:p xmlns:a="http://schemas.openxmlformats.org/drawingml/2006/main">
             <a:pPr>
+              <a:buNone/>
               <a:defRPr sz="1800" b="1">
                 <a:solidFill>
                   <a:srgbClr val="A7E2D7"/>
@@ -12126,6 +11003,7 @@
           <a:lstStyle xmlns:a="http://schemas.openxmlformats.org/drawingml/2006/main"/>
           <a:p xmlns:a="http://schemas.openxmlformats.org/drawingml/2006/main">
             <a:pPr>
+              <a:buNone/>
               <a:defRPr sz="2250" b="0">
                 <a:solidFill>
                   <a:srgbClr val="FFFFFF"/>
@@ -12149,6 +11027,7 @@
           </a:p>
           <a:p xmlns:a="http://schemas.openxmlformats.org/drawingml/2006/main">
             <a:pPr>
+              <a:buNone/>
               <a:defRPr sz="2250" b="0">
                 <a:solidFill>
                   <a:srgbClr val="FFFFFF"/>
@@ -12261,88 +11140,6 @@
       </p:sp>
       <p:sp>
         <p:nvSpPr>
-          <p:cNvPr id="2" name="Class duration">
-            <a:extLst xmlns:a="http://schemas.openxmlformats.org/drawingml/2006/main">
-              <a:ext uri="{FF2B5EF4-FFF2-40B4-BE49-F238E27FC236}">
-                <a16:creationId xmlns:a16="http://schemas.microsoft.com/office/drawing/2014/main" id="{4889EF75-BB5D-46F3-A9FA-49B7AFC2BA79}"/>
-              </a:ext>
-            </a:extLst>
-          </p:cNvPr>
-          <p:cNvSpPr>
-            <a:spLocks xmlns:a="http://schemas.openxmlformats.org/drawingml/2006/main" noGrp="1"/>
-          </p:cNvSpPr>
-          <p:nvPr/>
-        </p:nvSpPr>
-        <p:spPr>
-          <a:xfrm xmlns:a="http://schemas.openxmlformats.org/drawingml/2006/main">
-            <a:off x="790575" y="2428875"/>
-            <a:ext cx="1952625" cy="857250"/>
-          </a:xfrm>
-          <a:prstGeom xmlns:a="http://schemas.openxmlformats.org/drawingml/2006/main" prst="rect">
-            <a:avLst/>
-          </a:prstGeom>
-          <a:noFill xmlns:a="http://schemas.openxmlformats.org/drawingml/2006/main"/>
-          <a:ln xmlns:a="http://schemas.openxmlformats.org/drawingml/2006/main" w="0">
-            <a:noFill/>
-          </a:ln>
-        </p:spPr>
-        <p:txBody>
-          <a:bodyPr xmlns:a="http://schemas.openxmlformats.org/drawingml/2006/main" wrap="square" lIns="0" tIns="0" rIns="0" bIns="0" anchor="t">
-            <a:noAutofit/>
-          </a:bodyPr>
-          <a:lstStyle xmlns:a="http://schemas.openxmlformats.org/drawingml/2006/main"/>
-          <a:p xmlns:a="http://schemas.openxmlformats.org/drawingml/2006/main">
-            <a:pPr>
-              <a:buNone/>
-              <a:defRPr sz="1875" b="0">
-                <a:solidFill>
-                  <a:srgbClr val="45516A"/>
-                </a:solidFill>
-                <a:latin typeface="Arial"/>
-                <a:ea typeface="Arial"/>
-                <a:cs typeface="Arial"/>
-              </a:defRPr>
-            </a:pPr>
-            <a:r>
-              <a:rPr sz="1875" b="0">
-                <a:solidFill>
-                  <a:srgbClr val="45516A"/>
-                </a:solidFill>
-                <a:latin typeface="Arial"/>
-                <a:ea typeface="Arial"/>
-                <a:cs typeface="Arial"/>
-              </a:rPr>
-              <a:t>CLASE</a:t>
-            </a:r>
-          </a:p>
-          <a:p xmlns:a="http://schemas.openxmlformats.org/drawingml/2006/main">
-            <a:pPr>
-              <a:buNone/>
-              <a:defRPr sz="1875" b="0">
-                <a:solidFill>
-                  <a:srgbClr val="45516A"/>
-                </a:solidFill>
-                <a:latin typeface="Arial"/>
-                <a:ea typeface="Arial"/>
-                <a:cs typeface="Arial"/>
-              </a:defRPr>
-            </a:pPr>
-            <a:r>
-              <a:rPr sz="1875" b="0">
-                <a:solidFill>
-                  <a:srgbClr val="45516A"/>
-                </a:solidFill>
-                <a:latin typeface="Arial"/>
-                <a:ea typeface="Arial"/>
-                <a:cs typeface="Arial"/>
-              </a:rPr>
-              <a:t>4 horas</a:t>
-            </a:r>
-          </a:p>
-        </p:txBody>
-      </p:sp>
-      <p:sp>
-        <p:nvSpPr>
           <p:cNvPr id="3" name="Class title">
             <a:extLst xmlns:a="http://schemas.openxmlformats.org/drawingml/2006/main">
               <a:ext uri="{FF2B5EF4-FFF2-40B4-BE49-F238E27FC236}">
@@ -12425,64 +11222,6 @@
       </p:sp>
       <p:sp>
         <p:nvSpPr>
-          <p:cNvPr id="4" name="Learning label">
-            <a:extLst xmlns:a="http://schemas.openxmlformats.org/drawingml/2006/main">
-              <a:ext uri="{FF2B5EF4-FFF2-40B4-BE49-F238E27FC236}">
-                <a16:creationId xmlns:a16="http://schemas.microsoft.com/office/drawing/2014/main" id="{F89574B7-B855-4B43-835C-8E454D3CFB34}"/>
-              </a:ext>
-            </a:extLst>
-          </p:cNvPr>
-          <p:cNvSpPr>
-            <a:spLocks xmlns:a="http://schemas.openxmlformats.org/drawingml/2006/main" noGrp="1"/>
-          </p:cNvSpPr>
-          <p:nvPr/>
-        </p:nvSpPr>
-        <p:spPr>
-          <a:xfrm xmlns:a="http://schemas.openxmlformats.org/drawingml/2006/main">
-            <a:off x="3248025" y="3619500"/>
-            <a:ext cx="7620000" cy="314325"/>
-          </a:xfrm>
-          <a:prstGeom xmlns:a="http://schemas.openxmlformats.org/drawingml/2006/main" prst="rect">
-            <a:avLst/>
-          </a:prstGeom>
-          <a:noFill xmlns:a="http://schemas.openxmlformats.org/drawingml/2006/main"/>
-          <a:ln xmlns:a="http://schemas.openxmlformats.org/drawingml/2006/main" w="0">
-            <a:noFill/>
-          </a:ln>
-        </p:spPr>
-        <p:txBody>
-          <a:bodyPr xmlns:a="http://schemas.openxmlformats.org/drawingml/2006/main" wrap="square" lIns="0" tIns="0" rIns="0" bIns="0" anchor="t">
-            <a:noAutofit/>
-          </a:bodyPr>
-          <a:lstStyle xmlns:a="http://schemas.openxmlformats.org/drawingml/2006/main"/>
-          <a:p xmlns:a="http://schemas.openxmlformats.org/drawingml/2006/main">
-            <a:pPr>
-              <a:buNone/>
-              <a:defRPr sz="1800" b="1">
-                <a:solidFill>
-                  <a:srgbClr val="6044B6"/>
-                </a:solidFill>
-                <a:latin typeface="Arial"/>
-                <a:ea typeface="Arial"/>
-                <a:cs typeface="Arial"/>
-              </a:defRPr>
-            </a:pPr>
-            <a:r>
-              <a:rPr sz="1800" b="1">
-                <a:solidFill>
-                  <a:srgbClr val="6044B6"/>
-                </a:solidFill>
-                <a:latin typeface="Arial"/>
-                <a:ea typeface="Arial"/>
-                <a:cs typeface="Arial"/>
-              </a:rPr>
-              <a:t>APRENDERÁS</a:t>
-            </a:r>
-          </a:p>
-        </p:txBody>
-      </p:sp>
-      <p:sp>
-        <p:nvSpPr>
           <p:cNvPr id="5" name="Learning outcome">
             <a:extLst xmlns:a="http://schemas.openxmlformats.org/drawingml/2006/main">
               <a:ext uri="{FF2B5EF4-FFF2-40B4-BE49-F238E27FC236}">
@@ -12497,7 +11236,7 @@
         </p:nvSpPr>
         <p:spPr>
           <a:xfrm xmlns:a="http://schemas.openxmlformats.org/drawingml/2006/main">
-            <a:off x="3219450" y="4010025"/>
+            <a:off x="3219450" y="3905250"/>
             <a:ext cx="8191500" cy="800100"/>
           </a:xfrm>
           <a:prstGeom xmlns:a="http://schemas.openxmlformats.org/drawingml/2006/main" prst="rect">
@@ -12565,64 +11304,6 @@
       </p:sp>
       <p:sp>
         <p:nvSpPr>
-          <p:cNvPr id="6" name="Practice label">
-            <a:extLst xmlns:a="http://schemas.openxmlformats.org/drawingml/2006/main">
-              <a:ext uri="{FF2B5EF4-FFF2-40B4-BE49-F238E27FC236}">
-                <a16:creationId xmlns:a16="http://schemas.microsoft.com/office/drawing/2014/main" id="{C5AC8392-52F4-4576-9B6F-DF523102C46C}"/>
-              </a:ext>
-            </a:extLst>
-          </p:cNvPr>
-          <p:cNvSpPr>
-            <a:spLocks xmlns:a="http://schemas.openxmlformats.org/drawingml/2006/main" noGrp="1"/>
-          </p:cNvSpPr>
-          <p:nvPr/>
-        </p:nvSpPr>
-        <p:spPr>
-          <a:xfrm xmlns:a="http://schemas.openxmlformats.org/drawingml/2006/main">
-            <a:off x="3248025" y="5143500"/>
-            <a:ext cx="7620000" cy="314325"/>
-          </a:xfrm>
-          <a:prstGeom xmlns:a="http://schemas.openxmlformats.org/drawingml/2006/main" prst="rect">
-            <a:avLst/>
-          </a:prstGeom>
-          <a:noFill xmlns:a="http://schemas.openxmlformats.org/drawingml/2006/main"/>
-          <a:ln xmlns:a="http://schemas.openxmlformats.org/drawingml/2006/main" w="0">
-            <a:noFill/>
-          </a:ln>
-        </p:spPr>
-        <p:txBody>
-          <a:bodyPr xmlns:a="http://schemas.openxmlformats.org/drawingml/2006/main" wrap="square" lIns="0" tIns="0" rIns="0" bIns="0" anchor="t">
-            <a:noAutofit/>
-          </a:bodyPr>
-          <a:lstStyle xmlns:a="http://schemas.openxmlformats.org/drawingml/2006/main"/>
-          <a:p xmlns:a="http://schemas.openxmlformats.org/drawingml/2006/main">
-            <a:pPr>
-              <a:buNone/>
-              <a:defRPr sz="1800" b="1">
-                <a:solidFill>
-                  <a:srgbClr val="6044B6"/>
-                </a:solidFill>
-                <a:latin typeface="Arial"/>
-                <a:ea typeface="Arial"/>
-                <a:cs typeface="Arial"/>
-              </a:defRPr>
-            </a:pPr>
-            <a:r>
-              <a:rPr sz="1800" b="1">
-                <a:solidFill>
-                  <a:srgbClr val="6044B6"/>
-                </a:solidFill>
-                <a:latin typeface="Arial"/>
-                <a:ea typeface="Arial"/>
-                <a:cs typeface="Arial"/>
-              </a:rPr>
-              <a:t>HARÁS</a:t>
-            </a:r>
-          </a:p>
-        </p:txBody>
-      </p:sp>
-      <p:sp>
-        <p:nvSpPr>
           <p:cNvPr id="7" name="Practice outcome">
             <a:extLst xmlns:a="http://schemas.openxmlformats.org/drawingml/2006/main">
               <a:ext uri="{FF2B5EF4-FFF2-40B4-BE49-F238E27FC236}">
@@ -12637,7 +11318,7 @@
         </p:nvSpPr>
         <p:spPr>
           <a:xfrm xmlns:a="http://schemas.openxmlformats.org/drawingml/2006/main">
-            <a:off x="3219450" y="5534025"/>
+            <a:off x="3219450" y="5143500"/>
             <a:ext cx="8191500" cy="800100"/>
           </a:xfrm>
           <a:prstGeom xmlns:a="http://schemas.openxmlformats.org/drawingml/2006/main" prst="rect">
@@ -12872,6 +11553,7 @@
           <a:lstStyle xmlns:a="http://schemas.openxmlformats.org/drawingml/2006/main"/>
           <a:p xmlns:a="http://schemas.openxmlformats.org/drawingml/2006/main">
             <a:pPr>
+              <a:buNone/>
               <a:defRPr sz="1800" b="1">
                 <a:solidFill>
                   <a:srgbClr val="A7E2D7"/>
@@ -12929,6 +11611,7 @@
           <a:lstStyle xmlns:a="http://schemas.openxmlformats.org/drawingml/2006/main"/>
           <a:p xmlns:a="http://schemas.openxmlformats.org/drawingml/2006/main">
             <a:pPr>
+              <a:buNone/>
               <a:defRPr sz="4050" b="1">
                 <a:solidFill>
                   <a:srgbClr val="FFFFFF"/>
@@ -12986,6 +11669,7 @@
           <a:lstStyle xmlns:a="http://schemas.openxmlformats.org/drawingml/2006/main"/>
           <a:p xmlns:a="http://schemas.openxmlformats.org/drawingml/2006/main">
             <a:pPr>
+              <a:buNone/>
               <a:defRPr sz="2400" b="0">
                 <a:solidFill>
                   <a:srgbClr val="FFFFFF"/>
@@ -13009,6 +11693,7 @@
           </a:p>
           <a:p xmlns:a="http://schemas.openxmlformats.org/drawingml/2006/main">
             <a:pPr>
+              <a:buNone/>
               <a:defRPr sz="2400" b="0">
                 <a:solidFill>
                   <a:srgbClr val="FFFFFF"/>
@@ -13066,6 +11751,7 @@
           <a:lstStyle xmlns:a="http://schemas.openxmlformats.org/drawingml/2006/main"/>
           <a:p xmlns:a="http://schemas.openxmlformats.org/drawingml/2006/main">
             <a:pPr>
+              <a:buNone/>
               <a:defRPr sz="2250" b="0">
                 <a:solidFill>
                   <a:srgbClr val="D0D8E6"/>
@@ -13089,6 +11775,7 @@
           </a:p>
           <a:p xmlns:a="http://schemas.openxmlformats.org/drawingml/2006/main">
             <a:pPr>
+              <a:buNone/>
               <a:defRPr sz="2250" b="0">
                 <a:solidFill>
                   <a:srgbClr val="D0D8E6"/>
@@ -13112,6 +11799,7 @@
           </a:p>
           <a:p xmlns:a="http://schemas.openxmlformats.org/drawingml/2006/main">
             <a:pPr>
+              <a:buNone/>
               <a:defRPr sz="2250" b="0">
                 <a:solidFill>
                   <a:srgbClr val="D0D8E6"/>
@@ -13169,6 +11857,7 @@
           <a:lstStyle xmlns:a="http://schemas.openxmlformats.org/drawingml/2006/main"/>
           <a:p xmlns:a="http://schemas.openxmlformats.org/drawingml/2006/main">
             <a:pPr>
+              <a:buNone/>
               <a:defRPr sz="1800" b="1">
                 <a:solidFill>
                   <a:srgbClr val="A7E2D7"/>
@@ -13226,6 +11915,7 @@
           <a:lstStyle xmlns:a="http://schemas.openxmlformats.org/drawingml/2006/main"/>
           <a:p xmlns:a="http://schemas.openxmlformats.org/drawingml/2006/main">
             <a:pPr>
+              <a:buNone/>
               <a:defRPr sz="2250" b="0">
                 <a:solidFill>
                   <a:srgbClr val="FFFFFF"/>
@@ -13249,6 +11939,7 @@
           </a:p>
           <a:p xmlns:a="http://schemas.openxmlformats.org/drawingml/2006/main">
             <a:pPr>
+              <a:buNone/>
               <a:defRPr sz="2250" b="0">
                 <a:solidFill>
                   <a:srgbClr val="FFFFFF"/>
@@ -13310,7 +12001,7 @@
           <p:nvPr/>
         </p:nvPicPr>
         <p:blipFill>
-          <a:blip xmlns:r="http://schemas.openxmlformats.org/officeDocument/2006/relationships" xmlns:a="http://schemas.openxmlformats.org/drawingml/2006/main" r:embed="R2d80427b5f8e47d6"/>
+          <a:blip xmlns:r="http://schemas.openxmlformats.org/officeDocument/2006/relationships" xmlns:a="http://schemas.openxmlformats.org/drawingml/2006/main" r:embed="R80798260886f47b6"/>
           <a:srcRect xmlns:a="http://schemas.openxmlformats.org/drawingml/2006/main" l="0" t="27" r="0" b="27"/>
           <a:stretch xmlns:a="http://schemas.openxmlformats.org/drawingml/2006/main">
             <a:fillRect l="0" t="0" r="0" b="0"/>
@@ -13610,7 +12301,7 @@
                 <a:latin typeface="Arial"/>
                 <a:ea typeface="Arial"/>
                 <a:cs typeface="Arial"/>
-                <a:hlinkClick xmlns:r="http://schemas.openxmlformats.org/officeDocument/2006/relationships" r:id="Rd9ca83bb4b0c426d"/>
+                <a:hlinkClick xmlns:r="http://schemas.openxmlformats.org/officeDocument/2006/relationships" r:id="Rdf1cf172ef2b41b6"/>
               </a:rPr>
               <a:t>github.com/ychavez/CursoNETIA</a:t>
             </a:r>
@@ -13991,88 +12682,6 @@
       </p:sp>
       <p:sp>
         <p:nvSpPr>
-          <p:cNvPr id="2" name="Class duration">
-            <a:extLst xmlns:a="http://schemas.openxmlformats.org/drawingml/2006/main">
-              <a:ext uri="{FF2B5EF4-FFF2-40B4-BE49-F238E27FC236}">
-                <a16:creationId xmlns:a16="http://schemas.microsoft.com/office/drawing/2014/main" id="{85E17A89-0CC8-4C69-8FE2-1B004133921D}"/>
-              </a:ext>
-            </a:extLst>
-          </p:cNvPr>
-          <p:cNvSpPr>
-            <a:spLocks xmlns:a="http://schemas.openxmlformats.org/drawingml/2006/main" noGrp="1"/>
-          </p:cNvSpPr>
-          <p:nvPr/>
-        </p:nvSpPr>
-        <p:spPr>
-          <a:xfrm xmlns:a="http://schemas.openxmlformats.org/drawingml/2006/main">
-            <a:off x="790575" y="2428875"/>
-            <a:ext cx="1952625" cy="857250"/>
-          </a:xfrm>
-          <a:prstGeom xmlns:a="http://schemas.openxmlformats.org/drawingml/2006/main" prst="rect">
-            <a:avLst/>
-          </a:prstGeom>
-          <a:noFill xmlns:a="http://schemas.openxmlformats.org/drawingml/2006/main"/>
-          <a:ln xmlns:a="http://schemas.openxmlformats.org/drawingml/2006/main" w="0">
-            <a:noFill/>
-          </a:ln>
-        </p:spPr>
-        <p:txBody>
-          <a:bodyPr xmlns:a="http://schemas.openxmlformats.org/drawingml/2006/main" wrap="square" lIns="0" tIns="0" rIns="0" bIns="0" anchor="t">
-            <a:noAutofit/>
-          </a:bodyPr>
-          <a:lstStyle xmlns:a="http://schemas.openxmlformats.org/drawingml/2006/main"/>
-          <a:p xmlns:a="http://schemas.openxmlformats.org/drawingml/2006/main">
-            <a:pPr>
-              <a:buNone/>
-              <a:defRPr sz="1875" b="0">
-                <a:solidFill>
-                  <a:srgbClr val="45516A"/>
-                </a:solidFill>
-                <a:latin typeface="Arial"/>
-                <a:ea typeface="Arial"/>
-                <a:cs typeface="Arial"/>
-              </a:defRPr>
-            </a:pPr>
-            <a:r>
-              <a:rPr sz="1875" b="0">
-                <a:solidFill>
-                  <a:srgbClr val="45516A"/>
-                </a:solidFill>
-                <a:latin typeface="Arial"/>
-                <a:ea typeface="Arial"/>
-                <a:cs typeface="Arial"/>
-              </a:rPr>
-              <a:t>CLASE</a:t>
-            </a:r>
-          </a:p>
-          <a:p xmlns:a="http://schemas.openxmlformats.org/drawingml/2006/main">
-            <a:pPr>
-              <a:buNone/>
-              <a:defRPr sz="1875" b="0">
-                <a:solidFill>
-                  <a:srgbClr val="45516A"/>
-                </a:solidFill>
-                <a:latin typeface="Arial"/>
-                <a:ea typeface="Arial"/>
-                <a:cs typeface="Arial"/>
-              </a:defRPr>
-            </a:pPr>
-            <a:r>
-              <a:rPr sz="1875" b="0">
-                <a:solidFill>
-                  <a:srgbClr val="45516A"/>
-                </a:solidFill>
-                <a:latin typeface="Arial"/>
-                <a:ea typeface="Arial"/>
-                <a:cs typeface="Arial"/>
-              </a:rPr>
-              <a:t>4 horas</a:t>
-            </a:r>
-          </a:p>
-        </p:txBody>
-      </p:sp>
-      <p:sp>
-        <p:nvSpPr>
           <p:cNvPr id="3" name="Class title">
             <a:extLst xmlns:a="http://schemas.openxmlformats.org/drawingml/2006/main">
               <a:ext uri="{FF2B5EF4-FFF2-40B4-BE49-F238E27FC236}">
@@ -14131,64 +12740,6 @@
       </p:sp>
       <p:sp>
         <p:nvSpPr>
-          <p:cNvPr id="4" name="Learning label">
-            <a:extLst xmlns:a="http://schemas.openxmlformats.org/drawingml/2006/main">
-              <a:ext uri="{FF2B5EF4-FFF2-40B4-BE49-F238E27FC236}">
-                <a16:creationId xmlns:a16="http://schemas.microsoft.com/office/drawing/2014/main" id="{DB71A511-F263-43D8-86C1-7341D80ECB1C}"/>
-              </a:ext>
-            </a:extLst>
-          </p:cNvPr>
-          <p:cNvSpPr>
-            <a:spLocks xmlns:a="http://schemas.openxmlformats.org/drawingml/2006/main" noGrp="1"/>
-          </p:cNvSpPr>
-          <p:nvPr/>
-        </p:nvSpPr>
-        <p:spPr>
-          <a:xfrm xmlns:a="http://schemas.openxmlformats.org/drawingml/2006/main">
-            <a:off x="3248025" y="3619500"/>
-            <a:ext cx="7620000" cy="314325"/>
-          </a:xfrm>
-          <a:prstGeom xmlns:a="http://schemas.openxmlformats.org/drawingml/2006/main" prst="rect">
-            <a:avLst/>
-          </a:prstGeom>
-          <a:noFill xmlns:a="http://schemas.openxmlformats.org/drawingml/2006/main"/>
-          <a:ln xmlns:a="http://schemas.openxmlformats.org/drawingml/2006/main" w="0">
-            <a:noFill/>
-          </a:ln>
-        </p:spPr>
-        <p:txBody>
-          <a:bodyPr xmlns:a="http://schemas.openxmlformats.org/drawingml/2006/main" wrap="square" lIns="0" tIns="0" rIns="0" bIns="0" anchor="t">
-            <a:noAutofit/>
-          </a:bodyPr>
-          <a:lstStyle xmlns:a="http://schemas.openxmlformats.org/drawingml/2006/main"/>
-          <a:p xmlns:a="http://schemas.openxmlformats.org/drawingml/2006/main">
-            <a:pPr>
-              <a:buNone/>
-              <a:defRPr sz="1800" b="1">
-                <a:solidFill>
-                  <a:srgbClr val="6044B6"/>
-                </a:solidFill>
-                <a:latin typeface="Arial"/>
-                <a:ea typeface="Arial"/>
-                <a:cs typeface="Arial"/>
-              </a:defRPr>
-            </a:pPr>
-            <a:r>
-              <a:rPr sz="1800" b="1">
-                <a:solidFill>
-                  <a:srgbClr val="6044B6"/>
-                </a:solidFill>
-                <a:latin typeface="Arial"/>
-                <a:ea typeface="Arial"/>
-                <a:cs typeface="Arial"/>
-              </a:rPr>
-              <a:t>APRENDERÁS</a:t>
-            </a:r>
-          </a:p>
-        </p:txBody>
-      </p:sp>
-      <p:sp>
-        <p:nvSpPr>
           <p:cNvPr id="5" name="Learning outcome">
             <a:extLst xmlns:a="http://schemas.openxmlformats.org/drawingml/2006/main">
               <a:ext uri="{FF2B5EF4-FFF2-40B4-BE49-F238E27FC236}">
@@ -14203,7 +12754,7 @@
         </p:nvSpPr>
         <p:spPr>
           <a:xfrm xmlns:a="http://schemas.openxmlformats.org/drawingml/2006/main">
-            <a:off x="3219450" y="4010025"/>
+            <a:off x="3219450" y="3905250"/>
             <a:ext cx="8191500" cy="800100"/>
           </a:xfrm>
           <a:prstGeom xmlns:a="http://schemas.openxmlformats.org/drawingml/2006/main" prst="rect">
@@ -14271,64 +12822,6 @@
       </p:sp>
       <p:sp>
         <p:nvSpPr>
-          <p:cNvPr id="6" name="Practice label">
-            <a:extLst xmlns:a="http://schemas.openxmlformats.org/drawingml/2006/main">
-              <a:ext uri="{FF2B5EF4-FFF2-40B4-BE49-F238E27FC236}">
-                <a16:creationId xmlns:a16="http://schemas.microsoft.com/office/drawing/2014/main" id="{A3167BC9-ADA9-4B9F-897C-436F6E21EE88}"/>
-              </a:ext>
-            </a:extLst>
-          </p:cNvPr>
-          <p:cNvSpPr>
-            <a:spLocks xmlns:a="http://schemas.openxmlformats.org/drawingml/2006/main" noGrp="1"/>
-          </p:cNvSpPr>
-          <p:nvPr/>
-        </p:nvSpPr>
-        <p:spPr>
-          <a:xfrm xmlns:a="http://schemas.openxmlformats.org/drawingml/2006/main">
-            <a:off x="3248025" y="5143500"/>
-            <a:ext cx="7620000" cy="314325"/>
-          </a:xfrm>
-          <a:prstGeom xmlns:a="http://schemas.openxmlformats.org/drawingml/2006/main" prst="rect">
-            <a:avLst/>
-          </a:prstGeom>
-          <a:noFill xmlns:a="http://schemas.openxmlformats.org/drawingml/2006/main"/>
-          <a:ln xmlns:a="http://schemas.openxmlformats.org/drawingml/2006/main" w="0">
-            <a:noFill/>
-          </a:ln>
-        </p:spPr>
-        <p:txBody>
-          <a:bodyPr xmlns:a="http://schemas.openxmlformats.org/drawingml/2006/main" wrap="square" lIns="0" tIns="0" rIns="0" bIns="0" anchor="t">
-            <a:noAutofit/>
-          </a:bodyPr>
-          <a:lstStyle xmlns:a="http://schemas.openxmlformats.org/drawingml/2006/main"/>
-          <a:p xmlns:a="http://schemas.openxmlformats.org/drawingml/2006/main">
-            <a:pPr>
-              <a:buNone/>
-              <a:defRPr sz="1800" b="1">
-                <a:solidFill>
-                  <a:srgbClr val="6044B6"/>
-                </a:solidFill>
-                <a:latin typeface="Arial"/>
-                <a:ea typeface="Arial"/>
-                <a:cs typeface="Arial"/>
-              </a:defRPr>
-            </a:pPr>
-            <a:r>
-              <a:rPr sz="1800" b="1">
-                <a:solidFill>
-                  <a:srgbClr val="6044B6"/>
-                </a:solidFill>
-                <a:latin typeface="Arial"/>
-                <a:ea typeface="Arial"/>
-                <a:cs typeface="Arial"/>
-              </a:rPr>
-              <a:t>HARÁS</a:t>
-            </a:r>
-          </a:p>
-        </p:txBody>
-      </p:sp>
-      <p:sp>
-        <p:nvSpPr>
           <p:cNvPr id="7" name="Practice outcome">
             <a:extLst xmlns:a="http://schemas.openxmlformats.org/drawingml/2006/main">
               <a:ext uri="{FF2B5EF4-FFF2-40B4-BE49-F238E27FC236}">
@@ -14343,7 +12836,7 @@
         </p:nvSpPr>
         <p:spPr>
           <a:xfrm xmlns:a="http://schemas.openxmlformats.org/drawingml/2006/main">
-            <a:off x="3219450" y="5534025"/>
+            <a:off x="3219450" y="5143500"/>
             <a:ext cx="8191500" cy="800100"/>
           </a:xfrm>
           <a:prstGeom xmlns:a="http://schemas.openxmlformats.org/drawingml/2006/main" prst="rect">
@@ -14578,6 +13071,7 @@
           <a:lstStyle xmlns:a="http://schemas.openxmlformats.org/drawingml/2006/main"/>
           <a:p xmlns:a="http://schemas.openxmlformats.org/drawingml/2006/main">
             <a:pPr>
+              <a:buNone/>
               <a:defRPr sz="1800" b="1">
                 <a:solidFill>
                   <a:srgbClr val="A7E2D7"/>
@@ -14635,6 +13129,7 @@
           <a:lstStyle xmlns:a="http://schemas.openxmlformats.org/drawingml/2006/main"/>
           <a:p xmlns:a="http://schemas.openxmlformats.org/drawingml/2006/main">
             <a:pPr>
+              <a:buNone/>
               <a:defRPr sz="4050" b="1">
                 <a:solidFill>
                   <a:srgbClr val="FFFFFF"/>
@@ -14692,6 +13187,7 @@
           <a:lstStyle xmlns:a="http://schemas.openxmlformats.org/drawingml/2006/main"/>
           <a:p xmlns:a="http://schemas.openxmlformats.org/drawingml/2006/main">
             <a:pPr>
+              <a:buNone/>
               <a:defRPr sz="2400" b="0">
                 <a:solidFill>
                   <a:srgbClr val="FFFFFF"/>
@@ -14715,6 +13211,7 @@
           </a:p>
           <a:p xmlns:a="http://schemas.openxmlformats.org/drawingml/2006/main">
             <a:pPr>
+              <a:buNone/>
               <a:defRPr sz="2400" b="0">
                 <a:solidFill>
                   <a:srgbClr val="FFFFFF"/>
@@ -14738,6 +13235,7 @@
           </a:p>
           <a:p xmlns:a="http://schemas.openxmlformats.org/drawingml/2006/main">
             <a:pPr>
+              <a:buNone/>
               <a:defRPr sz="2400" b="0">
                 <a:solidFill>
                   <a:srgbClr val="FFFFFF"/>
@@ -14795,6 +13293,7 @@
           <a:lstStyle xmlns:a="http://schemas.openxmlformats.org/drawingml/2006/main"/>
           <a:p xmlns:a="http://schemas.openxmlformats.org/drawingml/2006/main">
             <a:pPr>
+              <a:buNone/>
               <a:defRPr sz="2250" b="0">
                 <a:solidFill>
                   <a:srgbClr val="D0D8E6"/>
@@ -14818,6 +13317,7 @@
           </a:p>
           <a:p xmlns:a="http://schemas.openxmlformats.org/drawingml/2006/main">
             <a:pPr>
+              <a:buNone/>
               <a:defRPr sz="2250" b="0">
                 <a:solidFill>
                   <a:srgbClr val="D0D8E6"/>
@@ -14841,6 +13341,7 @@
           </a:p>
           <a:p xmlns:a="http://schemas.openxmlformats.org/drawingml/2006/main">
             <a:pPr>
+              <a:buNone/>
               <a:defRPr sz="2250" b="0">
                 <a:solidFill>
                   <a:srgbClr val="D0D8E6"/>
@@ -14898,6 +13399,7 @@
           <a:lstStyle xmlns:a="http://schemas.openxmlformats.org/drawingml/2006/main"/>
           <a:p xmlns:a="http://schemas.openxmlformats.org/drawingml/2006/main">
             <a:pPr>
+              <a:buNone/>
               <a:defRPr sz="1800" b="1">
                 <a:solidFill>
                   <a:srgbClr val="A7E2D7"/>
@@ -14955,6 +13457,7 @@
           <a:lstStyle xmlns:a="http://schemas.openxmlformats.org/drawingml/2006/main"/>
           <a:p xmlns:a="http://schemas.openxmlformats.org/drawingml/2006/main">
             <a:pPr>
+              <a:buNone/>
               <a:defRPr sz="2250" b="0">
                 <a:solidFill>
                   <a:srgbClr val="FFFFFF"/>
@@ -14978,6 +13481,7 @@
           </a:p>
           <a:p xmlns:a="http://schemas.openxmlformats.org/drawingml/2006/main">
             <a:pPr>
+              <a:buNone/>
               <a:defRPr sz="2250" b="0">
                 <a:solidFill>
                   <a:srgbClr val="FFFFFF"/>
@@ -15090,88 +13594,6 @@
       </p:sp>
       <p:sp>
         <p:nvSpPr>
-          <p:cNvPr id="2" name="Class duration">
-            <a:extLst xmlns:a="http://schemas.openxmlformats.org/drawingml/2006/main">
-              <a:ext uri="{FF2B5EF4-FFF2-40B4-BE49-F238E27FC236}">
-                <a16:creationId xmlns:a16="http://schemas.microsoft.com/office/drawing/2014/main" id="{CD38F558-5AA6-4311-9C57-EAB60FC8D7A8}"/>
-              </a:ext>
-            </a:extLst>
-          </p:cNvPr>
-          <p:cNvSpPr>
-            <a:spLocks xmlns:a="http://schemas.openxmlformats.org/drawingml/2006/main" noGrp="1"/>
-          </p:cNvSpPr>
-          <p:nvPr/>
-        </p:nvSpPr>
-        <p:spPr>
-          <a:xfrm xmlns:a="http://schemas.openxmlformats.org/drawingml/2006/main">
-            <a:off x="790575" y="2428875"/>
-            <a:ext cx="1952625" cy="857250"/>
-          </a:xfrm>
-          <a:prstGeom xmlns:a="http://schemas.openxmlformats.org/drawingml/2006/main" prst="rect">
-            <a:avLst/>
-          </a:prstGeom>
-          <a:noFill xmlns:a="http://schemas.openxmlformats.org/drawingml/2006/main"/>
-          <a:ln xmlns:a="http://schemas.openxmlformats.org/drawingml/2006/main" w="0">
-            <a:noFill/>
-          </a:ln>
-        </p:spPr>
-        <p:txBody>
-          <a:bodyPr xmlns:a="http://schemas.openxmlformats.org/drawingml/2006/main" wrap="square" lIns="0" tIns="0" rIns="0" bIns="0" anchor="t">
-            <a:noAutofit/>
-          </a:bodyPr>
-          <a:lstStyle xmlns:a="http://schemas.openxmlformats.org/drawingml/2006/main"/>
-          <a:p xmlns:a="http://schemas.openxmlformats.org/drawingml/2006/main">
-            <a:pPr>
-              <a:buNone/>
-              <a:defRPr sz="1875" b="0">
-                <a:solidFill>
-                  <a:srgbClr val="45516A"/>
-                </a:solidFill>
-                <a:latin typeface="Arial"/>
-                <a:ea typeface="Arial"/>
-                <a:cs typeface="Arial"/>
-              </a:defRPr>
-            </a:pPr>
-            <a:r>
-              <a:rPr sz="1875" b="0">
-                <a:solidFill>
-                  <a:srgbClr val="45516A"/>
-                </a:solidFill>
-                <a:latin typeface="Arial"/>
-                <a:ea typeface="Arial"/>
-                <a:cs typeface="Arial"/>
-              </a:rPr>
-              <a:t>CLASE</a:t>
-            </a:r>
-          </a:p>
-          <a:p xmlns:a="http://schemas.openxmlformats.org/drawingml/2006/main">
-            <a:pPr>
-              <a:buNone/>
-              <a:defRPr sz="1875" b="0">
-                <a:solidFill>
-                  <a:srgbClr val="45516A"/>
-                </a:solidFill>
-                <a:latin typeface="Arial"/>
-                <a:ea typeface="Arial"/>
-                <a:cs typeface="Arial"/>
-              </a:defRPr>
-            </a:pPr>
-            <a:r>
-              <a:rPr sz="1875" b="0">
-                <a:solidFill>
-                  <a:srgbClr val="45516A"/>
-                </a:solidFill>
-                <a:latin typeface="Arial"/>
-                <a:ea typeface="Arial"/>
-                <a:cs typeface="Arial"/>
-              </a:rPr>
-              <a:t>4 horas</a:t>
-            </a:r>
-          </a:p>
-        </p:txBody>
-      </p:sp>
-      <p:sp>
-        <p:nvSpPr>
           <p:cNvPr id="3" name="Class title">
             <a:extLst xmlns:a="http://schemas.openxmlformats.org/drawingml/2006/main">
               <a:ext uri="{FF2B5EF4-FFF2-40B4-BE49-F238E27FC236}">
@@ -15254,64 +13676,6 @@
       </p:sp>
       <p:sp>
         <p:nvSpPr>
-          <p:cNvPr id="4" name="Learning label">
-            <a:extLst xmlns:a="http://schemas.openxmlformats.org/drawingml/2006/main">
-              <a:ext uri="{FF2B5EF4-FFF2-40B4-BE49-F238E27FC236}">
-                <a16:creationId xmlns:a16="http://schemas.microsoft.com/office/drawing/2014/main" id="{838A77B3-9DBB-497C-A156-D80B5CE85766}"/>
-              </a:ext>
-            </a:extLst>
-          </p:cNvPr>
-          <p:cNvSpPr>
-            <a:spLocks xmlns:a="http://schemas.openxmlformats.org/drawingml/2006/main" noGrp="1"/>
-          </p:cNvSpPr>
-          <p:nvPr/>
-        </p:nvSpPr>
-        <p:spPr>
-          <a:xfrm xmlns:a="http://schemas.openxmlformats.org/drawingml/2006/main">
-            <a:off x="3248025" y="3619500"/>
-            <a:ext cx="7620000" cy="314325"/>
-          </a:xfrm>
-          <a:prstGeom xmlns:a="http://schemas.openxmlformats.org/drawingml/2006/main" prst="rect">
-            <a:avLst/>
-          </a:prstGeom>
-          <a:noFill xmlns:a="http://schemas.openxmlformats.org/drawingml/2006/main"/>
-          <a:ln xmlns:a="http://schemas.openxmlformats.org/drawingml/2006/main" w="0">
-            <a:noFill/>
-          </a:ln>
-        </p:spPr>
-        <p:txBody>
-          <a:bodyPr xmlns:a="http://schemas.openxmlformats.org/drawingml/2006/main" wrap="square" lIns="0" tIns="0" rIns="0" bIns="0" anchor="t">
-            <a:noAutofit/>
-          </a:bodyPr>
-          <a:lstStyle xmlns:a="http://schemas.openxmlformats.org/drawingml/2006/main"/>
-          <a:p xmlns:a="http://schemas.openxmlformats.org/drawingml/2006/main">
-            <a:pPr>
-              <a:buNone/>
-              <a:defRPr sz="1800" b="1">
-                <a:solidFill>
-                  <a:srgbClr val="6044B6"/>
-                </a:solidFill>
-                <a:latin typeface="Arial"/>
-                <a:ea typeface="Arial"/>
-                <a:cs typeface="Arial"/>
-              </a:defRPr>
-            </a:pPr>
-            <a:r>
-              <a:rPr sz="1800" b="1">
-                <a:solidFill>
-                  <a:srgbClr val="6044B6"/>
-                </a:solidFill>
-                <a:latin typeface="Arial"/>
-                <a:ea typeface="Arial"/>
-                <a:cs typeface="Arial"/>
-              </a:rPr>
-              <a:t>APRENDERÁS</a:t>
-            </a:r>
-          </a:p>
-        </p:txBody>
-      </p:sp>
-      <p:sp>
-        <p:nvSpPr>
           <p:cNvPr id="5" name="Learning outcome">
             <a:extLst xmlns:a="http://schemas.openxmlformats.org/drawingml/2006/main">
               <a:ext uri="{FF2B5EF4-FFF2-40B4-BE49-F238E27FC236}">
@@ -15326,7 +13690,7 @@
         </p:nvSpPr>
         <p:spPr>
           <a:xfrm xmlns:a="http://schemas.openxmlformats.org/drawingml/2006/main">
-            <a:off x="3219450" y="4010025"/>
+            <a:off x="3219450" y="3905250"/>
             <a:ext cx="8191500" cy="800100"/>
           </a:xfrm>
           <a:prstGeom xmlns:a="http://schemas.openxmlformats.org/drawingml/2006/main" prst="rect">
@@ -15394,64 +13758,6 @@
       </p:sp>
       <p:sp>
         <p:nvSpPr>
-          <p:cNvPr id="6" name="Practice label">
-            <a:extLst xmlns:a="http://schemas.openxmlformats.org/drawingml/2006/main">
-              <a:ext uri="{FF2B5EF4-FFF2-40B4-BE49-F238E27FC236}">
-                <a16:creationId xmlns:a16="http://schemas.microsoft.com/office/drawing/2014/main" id="{DED3C2AA-1A20-41DA-91AE-933ED0737AFB}"/>
-              </a:ext>
-            </a:extLst>
-          </p:cNvPr>
-          <p:cNvSpPr>
-            <a:spLocks xmlns:a="http://schemas.openxmlformats.org/drawingml/2006/main" noGrp="1"/>
-          </p:cNvSpPr>
-          <p:nvPr/>
-        </p:nvSpPr>
-        <p:spPr>
-          <a:xfrm xmlns:a="http://schemas.openxmlformats.org/drawingml/2006/main">
-            <a:off x="3248025" y="5143500"/>
-            <a:ext cx="7620000" cy="314325"/>
-          </a:xfrm>
-          <a:prstGeom xmlns:a="http://schemas.openxmlformats.org/drawingml/2006/main" prst="rect">
-            <a:avLst/>
-          </a:prstGeom>
-          <a:noFill xmlns:a="http://schemas.openxmlformats.org/drawingml/2006/main"/>
-          <a:ln xmlns:a="http://schemas.openxmlformats.org/drawingml/2006/main" w="0">
-            <a:noFill/>
-          </a:ln>
-        </p:spPr>
-        <p:txBody>
-          <a:bodyPr xmlns:a="http://schemas.openxmlformats.org/drawingml/2006/main" wrap="square" lIns="0" tIns="0" rIns="0" bIns="0" anchor="t">
-            <a:noAutofit/>
-          </a:bodyPr>
-          <a:lstStyle xmlns:a="http://schemas.openxmlformats.org/drawingml/2006/main"/>
-          <a:p xmlns:a="http://schemas.openxmlformats.org/drawingml/2006/main">
-            <a:pPr>
-              <a:buNone/>
-              <a:defRPr sz="1800" b="1">
-                <a:solidFill>
-                  <a:srgbClr val="6044B6"/>
-                </a:solidFill>
-                <a:latin typeface="Arial"/>
-                <a:ea typeface="Arial"/>
-                <a:cs typeface="Arial"/>
-              </a:defRPr>
-            </a:pPr>
-            <a:r>
-              <a:rPr sz="1800" b="1">
-                <a:solidFill>
-                  <a:srgbClr val="6044B6"/>
-                </a:solidFill>
-                <a:latin typeface="Arial"/>
-                <a:ea typeface="Arial"/>
-                <a:cs typeface="Arial"/>
-              </a:rPr>
-              <a:t>HARÁS</a:t>
-            </a:r>
-          </a:p>
-        </p:txBody>
-      </p:sp>
-      <p:sp>
-        <p:nvSpPr>
           <p:cNvPr id="7" name="Practice outcome">
             <a:extLst xmlns:a="http://schemas.openxmlformats.org/drawingml/2006/main">
               <a:ext uri="{FF2B5EF4-FFF2-40B4-BE49-F238E27FC236}">
@@ -15466,7 +13772,7 @@
         </p:nvSpPr>
         <p:spPr>
           <a:xfrm xmlns:a="http://schemas.openxmlformats.org/drawingml/2006/main">
-            <a:off x="3219450" y="5534025"/>
+            <a:off x="3219450" y="5143500"/>
             <a:ext cx="8191500" cy="800100"/>
           </a:xfrm>
           <a:prstGeom xmlns:a="http://schemas.openxmlformats.org/drawingml/2006/main" prst="rect">
@@ -15677,6 +13983,7 @@
           <a:lstStyle xmlns:a="http://schemas.openxmlformats.org/drawingml/2006/main"/>
           <a:p xmlns:a="http://schemas.openxmlformats.org/drawingml/2006/main">
             <a:pPr>
+              <a:buNone/>
               <a:defRPr sz="1800" b="1">
                 <a:solidFill>
                   <a:srgbClr val="A7E2D7"/>
@@ -15734,6 +14041,7 @@
           <a:lstStyle xmlns:a="http://schemas.openxmlformats.org/drawingml/2006/main"/>
           <a:p xmlns:a="http://schemas.openxmlformats.org/drawingml/2006/main">
             <a:pPr>
+              <a:buNone/>
               <a:defRPr sz="4050" b="1">
                 <a:solidFill>
                   <a:srgbClr val="FFFFFF"/>
@@ -15791,6 +14099,7 @@
           <a:lstStyle xmlns:a="http://schemas.openxmlformats.org/drawingml/2006/main"/>
           <a:p xmlns:a="http://schemas.openxmlformats.org/drawingml/2006/main">
             <a:pPr>
+              <a:buNone/>
               <a:defRPr sz="2400" b="0">
                 <a:solidFill>
                   <a:srgbClr val="FFFFFF"/>
@@ -15814,6 +14123,7 @@
           </a:p>
           <a:p xmlns:a="http://schemas.openxmlformats.org/drawingml/2006/main">
             <a:pPr>
+              <a:buNone/>
               <a:defRPr sz="2400" b="0">
                 <a:solidFill>
                   <a:srgbClr val="FFFFFF"/>
@@ -15837,6 +14147,7 @@
           </a:p>
           <a:p xmlns:a="http://schemas.openxmlformats.org/drawingml/2006/main">
             <a:pPr>
+              <a:buNone/>
               <a:defRPr sz="2400" b="0">
                 <a:solidFill>
                   <a:srgbClr val="FFFFFF"/>
@@ -15894,6 +14205,7 @@
           <a:lstStyle xmlns:a="http://schemas.openxmlformats.org/drawingml/2006/main"/>
           <a:p xmlns:a="http://schemas.openxmlformats.org/drawingml/2006/main">
             <a:pPr>
+              <a:buNone/>
               <a:defRPr sz="2250" b="0">
                 <a:solidFill>
                   <a:srgbClr val="D0D8E6"/>
@@ -15917,6 +14229,7 @@
           </a:p>
           <a:p xmlns:a="http://schemas.openxmlformats.org/drawingml/2006/main">
             <a:pPr>
+              <a:buNone/>
               <a:defRPr sz="2250" b="0">
                 <a:solidFill>
                   <a:srgbClr val="D0D8E6"/>
@@ -15940,6 +14253,7 @@
           </a:p>
           <a:p xmlns:a="http://schemas.openxmlformats.org/drawingml/2006/main">
             <a:pPr>
+              <a:buNone/>
               <a:defRPr sz="2250" b="0">
                 <a:solidFill>
                   <a:srgbClr val="D0D8E6"/>
@@ -15997,6 +14311,7 @@
           <a:lstStyle xmlns:a="http://schemas.openxmlformats.org/drawingml/2006/main"/>
           <a:p xmlns:a="http://schemas.openxmlformats.org/drawingml/2006/main">
             <a:pPr>
+              <a:buNone/>
               <a:defRPr sz="1800" b="1">
                 <a:solidFill>
                   <a:srgbClr val="A7E2D7"/>
@@ -16054,6 +14369,7 @@
           <a:lstStyle xmlns:a="http://schemas.openxmlformats.org/drawingml/2006/main"/>
           <a:p xmlns:a="http://schemas.openxmlformats.org/drawingml/2006/main">
             <a:pPr>
+              <a:buNone/>
               <a:defRPr sz="2250" b="0">
                 <a:solidFill>
                   <a:srgbClr val="FFFFFF"/>
@@ -16077,6 +14393,7 @@
           </a:p>
           <a:p xmlns:a="http://schemas.openxmlformats.org/drawingml/2006/main">
             <a:pPr>
+              <a:buNone/>
               <a:defRPr sz="2250" b="0">
                 <a:solidFill>
                   <a:srgbClr val="FFFFFF"/>
@@ -16189,88 +14506,6 @@
       </p:sp>
       <p:sp>
         <p:nvSpPr>
-          <p:cNvPr id="2" name="Class duration">
-            <a:extLst xmlns:a="http://schemas.openxmlformats.org/drawingml/2006/main">
-              <a:ext uri="{FF2B5EF4-FFF2-40B4-BE49-F238E27FC236}">
-                <a16:creationId xmlns:a16="http://schemas.microsoft.com/office/drawing/2014/main" id="{84374E56-A4AF-42A4-A56D-D24C17649B00}"/>
-              </a:ext>
-            </a:extLst>
-          </p:cNvPr>
-          <p:cNvSpPr>
-            <a:spLocks xmlns:a="http://schemas.openxmlformats.org/drawingml/2006/main" noGrp="1"/>
-          </p:cNvSpPr>
-          <p:nvPr/>
-        </p:nvSpPr>
-        <p:spPr>
-          <a:xfrm xmlns:a="http://schemas.openxmlformats.org/drawingml/2006/main">
-            <a:off x="790575" y="2428875"/>
-            <a:ext cx="1952625" cy="857250"/>
-          </a:xfrm>
-          <a:prstGeom xmlns:a="http://schemas.openxmlformats.org/drawingml/2006/main" prst="rect">
-            <a:avLst/>
-          </a:prstGeom>
-          <a:noFill xmlns:a="http://schemas.openxmlformats.org/drawingml/2006/main"/>
-          <a:ln xmlns:a="http://schemas.openxmlformats.org/drawingml/2006/main" w="0">
-            <a:noFill/>
-          </a:ln>
-        </p:spPr>
-        <p:txBody>
-          <a:bodyPr xmlns:a="http://schemas.openxmlformats.org/drawingml/2006/main" wrap="square" lIns="0" tIns="0" rIns="0" bIns="0" anchor="t">
-            <a:noAutofit/>
-          </a:bodyPr>
-          <a:lstStyle xmlns:a="http://schemas.openxmlformats.org/drawingml/2006/main"/>
-          <a:p xmlns:a="http://schemas.openxmlformats.org/drawingml/2006/main">
-            <a:pPr>
-              <a:buNone/>
-              <a:defRPr sz="1875" b="0">
-                <a:solidFill>
-                  <a:srgbClr val="45516A"/>
-                </a:solidFill>
-                <a:latin typeface="Arial"/>
-                <a:ea typeface="Arial"/>
-                <a:cs typeface="Arial"/>
-              </a:defRPr>
-            </a:pPr>
-            <a:r>
-              <a:rPr sz="1875" b="0">
-                <a:solidFill>
-                  <a:srgbClr val="45516A"/>
-                </a:solidFill>
-                <a:latin typeface="Arial"/>
-                <a:ea typeface="Arial"/>
-                <a:cs typeface="Arial"/>
-              </a:rPr>
-              <a:t>CLASE</a:t>
-            </a:r>
-          </a:p>
-          <a:p xmlns:a="http://schemas.openxmlformats.org/drawingml/2006/main">
-            <a:pPr>
-              <a:buNone/>
-              <a:defRPr sz="1875" b="0">
-                <a:solidFill>
-                  <a:srgbClr val="45516A"/>
-                </a:solidFill>
-                <a:latin typeface="Arial"/>
-                <a:ea typeface="Arial"/>
-                <a:cs typeface="Arial"/>
-              </a:defRPr>
-            </a:pPr>
-            <a:r>
-              <a:rPr sz="1875" b="0">
-                <a:solidFill>
-                  <a:srgbClr val="45516A"/>
-                </a:solidFill>
-                <a:latin typeface="Arial"/>
-                <a:ea typeface="Arial"/>
-                <a:cs typeface="Arial"/>
-              </a:rPr>
-              <a:t>4 horas</a:t>
-            </a:r>
-          </a:p>
-        </p:txBody>
-      </p:sp>
-      <p:sp>
-        <p:nvSpPr>
           <p:cNvPr id="3" name="Class title">
             <a:extLst xmlns:a="http://schemas.openxmlformats.org/drawingml/2006/main">
               <a:ext uri="{FF2B5EF4-FFF2-40B4-BE49-F238E27FC236}">
@@ -16353,64 +14588,6 @@
       </p:sp>
       <p:sp>
         <p:nvSpPr>
-          <p:cNvPr id="4" name="Learning label">
-            <a:extLst xmlns:a="http://schemas.openxmlformats.org/drawingml/2006/main">
-              <a:ext uri="{FF2B5EF4-FFF2-40B4-BE49-F238E27FC236}">
-                <a16:creationId xmlns:a16="http://schemas.microsoft.com/office/drawing/2014/main" id="{B4B0B9E3-D5C3-4B76-A647-838684340805}"/>
-              </a:ext>
-            </a:extLst>
-          </p:cNvPr>
-          <p:cNvSpPr>
-            <a:spLocks xmlns:a="http://schemas.openxmlformats.org/drawingml/2006/main" noGrp="1"/>
-          </p:cNvSpPr>
-          <p:nvPr/>
-        </p:nvSpPr>
-        <p:spPr>
-          <a:xfrm xmlns:a="http://schemas.openxmlformats.org/drawingml/2006/main">
-            <a:off x="3248025" y="3619500"/>
-            <a:ext cx="7620000" cy="314325"/>
-          </a:xfrm>
-          <a:prstGeom xmlns:a="http://schemas.openxmlformats.org/drawingml/2006/main" prst="rect">
-            <a:avLst/>
-          </a:prstGeom>
-          <a:noFill xmlns:a="http://schemas.openxmlformats.org/drawingml/2006/main"/>
-          <a:ln xmlns:a="http://schemas.openxmlformats.org/drawingml/2006/main" w="0">
-            <a:noFill/>
-          </a:ln>
-        </p:spPr>
-        <p:txBody>
-          <a:bodyPr xmlns:a="http://schemas.openxmlformats.org/drawingml/2006/main" wrap="square" lIns="0" tIns="0" rIns="0" bIns="0" anchor="t">
-            <a:noAutofit/>
-          </a:bodyPr>
-          <a:lstStyle xmlns:a="http://schemas.openxmlformats.org/drawingml/2006/main"/>
-          <a:p xmlns:a="http://schemas.openxmlformats.org/drawingml/2006/main">
-            <a:pPr>
-              <a:buNone/>
-              <a:defRPr sz="1800" b="1">
-                <a:solidFill>
-                  <a:srgbClr val="6044B6"/>
-                </a:solidFill>
-                <a:latin typeface="Arial"/>
-                <a:ea typeface="Arial"/>
-                <a:cs typeface="Arial"/>
-              </a:defRPr>
-            </a:pPr>
-            <a:r>
-              <a:rPr sz="1800" b="1">
-                <a:solidFill>
-                  <a:srgbClr val="6044B6"/>
-                </a:solidFill>
-                <a:latin typeface="Arial"/>
-                <a:ea typeface="Arial"/>
-                <a:cs typeface="Arial"/>
-              </a:rPr>
-              <a:t>APRENDERÁS</a:t>
-            </a:r>
-          </a:p>
-        </p:txBody>
-      </p:sp>
-      <p:sp>
-        <p:nvSpPr>
           <p:cNvPr id="5" name="Learning outcome">
             <a:extLst xmlns:a="http://schemas.openxmlformats.org/drawingml/2006/main">
               <a:ext uri="{FF2B5EF4-FFF2-40B4-BE49-F238E27FC236}">
@@ -16425,7 +14602,7 @@
         </p:nvSpPr>
         <p:spPr>
           <a:xfrm xmlns:a="http://schemas.openxmlformats.org/drawingml/2006/main">
-            <a:off x="3219450" y="4010025"/>
+            <a:off x="3219450" y="3905250"/>
             <a:ext cx="8191500" cy="800100"/>
           </a:xfrm>
           <a:prstGeom xmlns:a="http://schemas.openxmlformats.org/drawingml/2006/main" prst="rect">
@@ -16493,64 +14670,6 @@
       </p:sp>
       <p:sp>
         <p:nvSpPr>
-          <p:cNvPr id="6" name="Practice label">
-            <a:extLst xmlns:a="http://schemas.openxmlformats.org/drawingml/2006/main">
-              <a:ext uri="{FF2B5EF4-FFF2-40B4-BE49-F238E27FC236}">
-                <a16:creationId xmlns:a16="http://schemas.microsoft.com/office/drawing/2014/main" id="{11FB8215-06A0-4981-991A-C2BDE125BCD6}"/>
-              </a:ext>
-            </a:extLst>
-          </p:cNvPr>
-          <p:cNvSpPr>
-            <a:spLocks xmlns:a="http://schemas.openxmlformats.org/drawingml/2006/main" noGrp="1"/>
-          </p:cNvSpPr>
-          <p:nvPr/>
-        </p:nvSpPr>
-        <p:spPr>
-          <a:xfrm xmlns:a="http://schemas.openxmlformats.org/drawingml/2006/main">
-            <a:off x="3248025" y="5143500"/>
-            <a:ext cx="7620000" cy="314325"/>
-          </a:xfrm>
-          <a:prstGeom xmlns:a="http://schemas.openxmlformats.org/drawingml/2006/main" prst="rect">
-            <a:avLst/>
-          </a:prstGeom>
-          <a:noFill xmlns:a="http://schemas.openxmlformats.org/drawingml/2006/main"/>
-          <a:ln xmlns:a="http://schemas.openxmlformats.org/drawingml/2006/main" w="0">
-            <a:noFill/>
-          </a:ln>
-        </p:spPr>
-        <p:txBody>
-          <a:bodyPr xmlns:a="http://schemas.openxmlformats.org/drawingml/2006/main" wrap="square" lIns="0" tIns="0" rIns="0" bIns="0" anchor="t">
-            <a:noAutofit/>
-          </a:bodyPr>
-          <a:lstStyle xmlns:a="http://schemas.openxmlformats.org/drawingml/2006/main"/>
-          <a:p xmlns:a="http://schemas.openxmlformats.org/drawingml/2006/main">
-            <a:pPr>
-              <a:buNone/>
-              <a:defRPr sz="1800" b="1">
-                <a:solidFill>
-                  <a:srgbClr val="6044B6"/>
-                </a:solidFill>
-                <a:latin typeface="Arial"/>
-                <a:ea typeface="Arial"/>
-                <a:cs typeface="Arial"/>
-              </a:defRPr>
-            </a:pPr>
-            <a:r>
-              <a:rPr sz="1800" b="1">
-                <a:solidFill>
-                  <a:srgbClr val="6044B6"/>
-                </a:solidFill>
-                <a:latin typeface="Arial"/>
-                <a:ea typeface="Arial"/>
-                <a:cs typeface="Arial"/>
-              </a:rPr>
-              <a:t>HARÁS</a:t>
-            </a:r>
-          </a:p>
-        </p:txBody>
-      </p:sp>
-      <p:sp>
-        <p:nvSpPr>
           <p:cNvPr id="7" name="Practice outcome">
             <a:extLst xmlns:a="http://schemas.openxmlformats.org/drawingml/2006/main">
               <a:ext uri="{FF2B5EF4-FFF2-40B4-BE49-F238E27FC236}">
@@ -16565,7 +14684,7 @@
         </p:nvSpPr>
         <p:spPr>
           <a:xfrm xmlns:a="http://schemas.openxmlformats.org/drawingml/2006/main">
-            <a:off x="3219450" y="5534025"/>
+            <a:off x="3219450" y="5143500"/>
             <a:ext cx="8191500" cy="800100"/>
           </a:xfrm>
           <a:prstGeom xmlns:a="http://schemas.openxmlformats.org/drawingml/2006/main" prst="rect">
@@ -16800,6 +14919,7 @@
           <a:lstStyle xmlns:a="http://schemas.openxmlformats.org/drawingml/2006/main"/>
           <a:p xmlns:a="http://schemas.openxmlformats.org/drawingml/2006/main">
             <a:pPr>
+              <a:buNone/>
               <a:defRPr sz="1800" b="1">
                 <a:solidFill>
                   <a:srgbClr val="A7E2D7"/>
@@ -16857,6 +14977,7 @@
           <a:lstStyle xmlns:a="http://schemas.openxmlformats.org/drawingml/2006/main"/>
           <a:p xmlns:a="http://schemas.openxmlformats.org/drawingml/2006/main">
             <a:pPr>
+              <a:buNone/>
               <a:defRPr sz="4050" b="1">
                 <a:solidFill>
                   <a:srgbClr val="FFFFFF"/>
@@ -16914,6 +15035,7 @@
           <a:lstStyle xmlns:a="http://schemas.openxmlformats.org/drawingml/2006/main"/>
           <a:p xmlns:a="http://schemas.openxmlformats.org/drawingml/2006/main">
             <a:pPr>
+              <a:buNone/>
               <a:defRPr sz="2400" b="0">
                 <a:solidFill>
                   <a:srgbClr val="FFFFFF"/>
@@ -16937,6 +15059,7 @@
           </a:p>
           <a:p xmlns:a="http://schemas.openxmlformats.org/drawingml/2006/main">
             <a:pPr>
+              <a:buNone/>
               <a:defRPr sz="2400" b="0">
                 <a:solidFill>
                   <a:srgbClr val="FFFFFF"/>
@@ -16994,6 +15117,7 @@
           <a:lstStyle xmlns:a="http://schemas.openxmlformats.org/drawingml/2006/main"/>
           <a:p xmlns:a="http://schemas.openxmlformats.org/drawingml/2006/main">
             <a:pPr>
+              <a:buNone/>
               <a:defRPr sz="2250" b="0">
                 <a:solidFill>
                   <a:srgbClr val="D0D8E6"/>
@@ -17017,6 +15141,7 @@
           </a:p>
           <a:p xmlns:a="http://schemas.openxmlformats.org/drawingml/2006/main">
             <a:pPr>
+              <a:buNone/>
               <a:defRPr sz="2250" b="0">
                 <a:solidFill>
                   <a:srgbClr val="D0D8E6"/>
@@ -17040,6 +15165,7 @@
           </a:p>
           <a:p xmlns:a="http://schemas.openxmlformats.org/drawingml/2006/main">
             <a:pPr>
+              <a:buNone/>
               <a:defRPr sz="2250" b="0">
                 <a:solidFill>
                   <a:srgbClr val="D0D8E6"/>
@@ -17097,6 +15223,7 @@
           <a:lstStyle xmlns:a="http://schemas.openxmlformats.org/drawingml/2006/main"/>
           <a:p xmlns:a="http://schemas.openxmlformats.org/drawingml/2006/main">
             <a:pPr>
+              <a:buNone/>
               <a:defRPr sz="1800" b="1">
                 <a:solidFill>
                   <a:srgbClr val="A7E2D7"/>
@@ -17154,6 +15281,7 @@
           <a:lstStyle xmlns:a="http://schemas.openxmlformats.org/drawingml/2006/main"/>
           <a:p xmlns:a="http://schemas.openxmlformats.org/drawingml/2006/main">
             <a:pPr>
+              <a:buNone/>
               <a:defRPr sz="2250" b="0">
                 <a:solidFill>
                   <a:srgbClr val="FFFFFF"/>
@@ -17177,6 +15305,7 @@
           </a:p>
           <a:p xmlns:a="http://schemas.openxmlformats.org/drawingml/2006/main">
             <a:pPr>
+              <a:buNone/>
               <a:defRPr sz="2250" b="0">
                 <a:solidFill>
                   <a:srgbClr val="FFFFFF"/>
@@ -17200,6 +15329,7 @@
           </a:p>
           <a:p xmlns:a="http://schemas.openxmlformats.org/drawingml/2006/main">
             <a:pPr>
+              <a:buNone/>
               <a:defRPr sz="2250" b="0">
                 <a:solidFill>
                   <a:srgbClr val="FFFFFF"/>

</xml_diff>